<commit_message>
Use official grant names on p32 and chart the keratin evidence on p22
p32: official program names, medical-device 1.5억 cap for the overseas
certification grant, KMDF 2nd-phase program name, unverified program
removed, past-project search note. p22: numbers shown as bar charts.

Co-Authored-By: Claude Opus 5.5 <noreply@anthropic.com>
Claude-Session: https://claude.ai/code/session_01RfoKnZfSzTcBgCwQYEg1hs
</commit_message>
<xml_diff>
--- a/presentation/BioFriends_KheAl_15-34_제품소개템플릿_20261026.pptx
+++ b/presentation/BioFriends_KheAl_15-34_제품소개템플릿_20261026.pptx
@@ -2741,7 +2741,7 @@
                           <a:ea typeface="210 옴니고딕 040"/>
                           <a:cs typeface="210 옴니고딕 040"/>
                         </a:rPr>
-                        <a:t>지금 접수 중: KTR 해외규격인증획득지원(~11.13). 2027: KMDF 임상지원 · KHIDI 규제지원. 허가 후: 사용자 임상평가</a:t>
+                        <a:t>지금 접수 중: 해외규격인증획득 지원사업 3차(~11.13, 의료기기 최대 1.5억). 2027: 범부처 첨단 의료기기 R&amp;D 임상 · KHIDI 글로벌 규제 대응. 허가 후: 사용자 임상평가</a:t>
                       </a:r>
                       <a:endParaRPr lang="ko-KR" sz="1150"/>
                     </a:p>
@@ -19019,14 +19019,14 @@
       </p:sp>
       <p:sp>
         <p:nvSpPr>
-          <p:cNvPr id="8" name="Ev 0"/>
+          <p:cNvPr id="8" name="A"/>
           <p:cNvSpPr/>
           <p:nvPr/>
         </p:nvSpPr>
         <p:spPr>
           <a:xfrm>
             <a:off x="502920" y="1664208"/>
-            <a:ext cx="2423160" cy="3996842"/>
+            <a:ext cx="3639312" cy="2191817"/>
           </a:xfrm>
           <a:prstGeom prst="roundRect">
             <a:avLst>
@@ -19045,23 +19045,19 @@
       </p:sp>
       <p:sp>
         <p:nvSpPr>
-          <p:cNvPr id="9" name="Ev head 0"/>
-          <p:cNvSpPr txBox="1"/>
-          <p:nvPr/>
-        </p:nvSpPr>
-        <p:spPr>
-          <a:xfrm>
-            <a:off x="502920" y="1664208"/>
-            <a:ext cx="2423160" cy="429768"/>
-          </a:xfrm>
-          <a:prstGeom prst="round2SameRect">
-            <a:avLst>
-              <a:gd name="adj" fmla="val 16000"/>
-            </a:avLst>
-          </a:prstGeom>
-          <a:solidFill>
-            <a:srgbClr val="102290"/>
-          </a:solidFill>
+          <p:cNvPr id="9" name="A t"/>
+          <p:cNvSpPr txBox="1"/>
+          <p:nvPr/>
+        </p:nvSpPr>
+        <p:spPr>
+          <a:xfrm>
+            <a:off x="640080" y="1732971"/>
+            <a:ext cx="2221992" cy="292242"/>
+          </a:xfrm>
+          <a:prstGeom prst="rect">
+            <a:avLst/>
+          </a:prstGeom>
+          <a:noFill/>
           <a:ln>
             <a:noFill/>
           </a:ln>
@@ -19072,34 +19068,34 @@
           </a:bodyPr>
           <a:lstStyle/>
           <a:p>
-            <a:pPr marL="0" indent="0" algn="ctr">
-              <a:buNone/>
-            </a:pPr>
-            <a:r>
-              <a:rPr lang="ko-KR" sz="1200" b="1">
-                <a:solidFill>
-                  <a:srgbClr val="FFFFFF"/>
+            <a:pPr marL="0" indent="0" algn="l">
+              <a:buNone/>
+            </a:pPr>
+            <a:r>
+              <a:rPr lang="ko-KR" sz="1150" b="1">
+                <a:solidFill>
+                  <a:srgbClr val="1D1F2B"/>
                 </a:solidFill>
                 <a:latin typeface="210 옴니고딕 050"/>
                 <a:ea typeface="210 옴니고딕 050"/>
                 <a:cs typeface="210 옴니고딕 050"/>
               </a:rPr>
-              <a:t>1  세포 실험</a:t>
-            </a:r>
-            <a:endParaRPr lang="ko-KR" sz="1200"/>
-          </a:p>
-        </p:txBody>
-      </p:sp>
-      <p:sp>
-        <p:nvSpPr>
-          <p:cNvPr id="10" name="Ev st 0"/>
-          <p:cNvSpPr txBox="1"/>
-          <p:nvPr/>
-        </p:nvSpPr>
-        <p:spPr>
-          <a:xfrm>
-            <a:off x="1120140" y="2222906"/>
-            <a:ext cx="1188720" cy="292242"/>
+              <a:t>동물 · 돼지 심부 2도 화상</a:t>
+            </a:r>
+            <a:endParaRPr lang="ko-KR" sz="1150"/>
+          </a:p>
+        </p:txBody>
+      </p:sp>
+      <p:sp>
+        <p:nvSpPr>
+          <p:cNvPr id="10" name="A st"/>
+          <p:cNvSpPr txBox="1"/>
+          <p:nvPr/>
+        </p:nvSpPr>
+        <p:spPr>
+          <a:xfrm>
+            <a:off x="2862072" y="1758757"/>
+            <a:ext cx="1170432" cy="257861"/>
           </a:xfrm>
           <a:prstGeom prst="roundRect">
             <a:avLst>
@@ -19107,7 +19103,7 @@
             </a:avLst>
           </a:prstGeom>
           <a:solidFill>
-            <a:srgbClr val="E6E9F5"/>
+            <a:srgbClr val="E8EFFF"/>
           </a:solidFill>
           <a:ln>
             <a:noFill/>
@@ -19123,15 +19119,101 @@
               <a:buNone/>
             </a:pPr>
             <a:r>
-              <a:rPr lang="ko-KR" sz="1050" b="1">
-                <a:solidFill>
-                  <a:srgbClr val="102290"/>
+              <a:rPr lang="ko-KR" sz="950" b="1">
+                <a:solidFill>
+                  <a:srgbClr val="437DFF"/>
                 </a:solidFill>
                 <a:latin typeface="210 옴니고딕 050"/>
                 <a:ea typeface="210 옴니고딕 050"/>
                 <a:cs typeface="210 옴니고딕 050"/>
               </a:rPr>
-              <a:t>신호 있음</a:t>
+              <a:t>신호 · 한계</a:t>
+            </a:r>
+            <a:endParaRPr lang="ko-KR" sz="950"/>
+          </a:p>
+        </p:txBody>
+      </p:sp>
+      <p:sp>
+        <p:nvSpPr>
+          <p:cNvPr id="11" name="A cap"/>
+          <p:cNvSpPr txBox="1"/>
+          <p:nvPr/>
+        </p:nvSpPr>
+        <p:spPr>
+          <a:xfrm>
+            <a:off x="640080" y="2008022"/>
+            <a:ext cx="3364992" cy="223479"/>
+          </a:xfrm>
+          <a:prstGeom prst="rect">
+            <a:avLst/>
+          </a:prstGeom>
+          <a:noFill/>
+          <a:ln>
+            <a:noFill/>
+          </a:ln>
+        </p:spPr>
+        <p:txBody>
+          <a:bodyPr wrap="square" lIns="0" tIns="0" rIns="0" bIns="0" anchor="t">
+            <a:noAutofit/>
+          </a:bodyPr>
+          <a:lstStyle/>
+          <a:p>
+            <a:pPr marL="0" indent="0" algn="l">
+              <a:buNone/>
+            </a:pPr>
+            <a:r>
+              <a:rPr lang="ko-KR" sz="950">
+                <a:solidFill>
+                  <a:srgbClr val="6B6E7A"/>
+                </a:solidFill>
+                <a:latin typeface="210 옴니고딕 040"/>
+                <a:ea typeface="210 옴니고딕 040"/>
+                <a:cs typeface="210 옴니고딕 040"/>
+              </a:rPr>
+              <a:t>상처가 닫히기까지 걸린 일수 (짧을수록 좋음)</a:t>
+            </a:r>
+            <a:endParaRPr lang="ko-KR" sz="950"/>
+          </a:p>
+        </p:txBody>
+      </p:sp>
+      <p:sp>
+        <p:nvSpPr>
+          <p:cNvPr id="12" name="A l0"/>
+          <p:cNvSpPr txBox="1"/>
+          <p:nvPr/>
+        </p:nvSpPr>
+        <p:spPr>
+          <a:xfrm>
+            <a:off x="640080" y="2283074"/>
+            <a:ext cx="1097280" cy="309433"/>
+          </a:xfrm>
+          <a:prstGeom prst="rect">
+            <a:avLst/>
+          </a:prstGeom>
+          <a:noFill/>
+          <a:ln>
+            <a:noFill/>
+          </a:ln>
+        </p:spPr>
+        <p:txBody>
+          <a:bodyPr wrap="square" lIns="0" tIns="0" rIns="0" bIns="0" anchor="ctr">
+            <a:noAutofit/>
+          </a:bodyPr>
+          <a:lstStyle/>
+          <a:p>
+            <a:pPr marL="0" indent="0" algn="l">
+              <a:buNone/>
+            </a:pPr>
+            <a:r>
+              <a:rPr lang="ko-KR" sz="1050">
+                <a:solidFill>
+                  <a:srgbClr val="1D1F2B"/>
+                </a:solidFill>
+                <a:latin typeface="210 옴니고딕 040"/>
+                <a:ea typeface="210 옴니고딕 040"/>
+                <a:cs typeface="210 옴니고딕 040"/>
+              </a:rPr>
+              <a:t>콜라겐 겔</a:t>
             </a:r>
             <a:endParaRPr lang="ko-KR" sz="1050"/>
           </a:p>
@@ -19139,18 +19221,40 @@
       </p:sp>
       <p:sp>
         <p:nvSpPr>
-          <p:cNvPr id="11" name="Ev big 0"/>
-          <p:cNvSpPr txBox="1"/>
-          <p:nvPr/>
-        </p:nvSpPr>
-        <p:spPr>
-          <a:xfrm>
-            <a:off x="594360" y="2609698"/>
-            <a:ext cx="2240280" cy="515722"/>
+          <p:cNvPr id="13" name="A b0"/>
+          <p:cNvSpPr/>
+          <p:nvPr/>
+        </p:nvSpPr>
+        <p:spPr>
+          <a:xfrm>
+            <a:off x="1737360" y="2308860"/>
+            <a:ext cx="1106424" cy="257861"/>
           </a:xfrm>
           <a:prstGeom prst="rect">
             <a:avLst/>
           </a:prstGeom>
+          <a:solidFill>
+            <a:srgbClr val="6F8BD8"/>
+          </a:solidFill>
+          <a:ln>
+            <a:noFill/>
+          </a:ln>
+        </p:spPr>
+      </p:sp>
+      <p:sp>
+        <p:nvSpPr>
+          <p:cNvPr id="14" name="A v0"/>
+          <p:cNvSpPr txBox="1"/>
+          <p:nvPr/>
+        </p:nvSpPr>
+        <p:spPr>
+          <a:xfrm>
+            <a:off x="2898648" y="2283074"/>
+            <a:ext cx="685800" cy="309433"/>
+          </a:xfrm>
+          <a:prstGeom prst="rect">
+            <a:avLst/>
+          </a:prstGeom>
           <a:noFill/>
           <a:ln>
             <a:noFill/>
@@ -19162,34 +19266,34 @@
           </a:bodyPr>
           <a:lstStyle/>
           <a:p>
-            <a:pPr marL="0" indent="0" algn="ctr">
-              <a:buNone/>
-            </a:pPr>
-            <a:r>
-              <a:rPr lang="ko-KR" sz="2000" b="1">
-                <a:solidFill>
-                  <a:srgbClr val="102290"/>
+            <a:pPr marL="0" indent="0" algn="l">
+              <a:buNone/>
+            </a:pPr>
+            <a:r>
+              <a:rPr lang="ko-KR" sz="1200" b="1">
+                <a:solidFill>
+                  <a:srgbClr val="6F8BD8"/>
                 </a:solidFill>
                 <a:latin typeface="210 옴니고딕 050"/>
                 <a:ea typeface="210 옴니고딕 050"/>
                 <a:cs typeface="210 옴니고딕 050"/>
               </a:rPr>
-              <a:t>세포 보호</a:t>
-            </a:r>
-            <a:endParaRPr lang="ko-KR" sz="2000"/>
-          </a:p>
-        </p:txBody>
-      </p:sp>
-      <p:sp>
-        <p:nvSpPr>
-          <p:cNvPr id="12" name="Ev lines 0"/>
-          <p:cNvSpPr txBox="1"/>
-          <p:nvPr/>
-        </p:nvSpPr>
-        <p:spPr>
-          <a:xfrm>
-            <a:off x="685800" y="3254350"/>
-            <a:ext cx="2057400" cy="1633118"/>
+              <a:t>24.2일</a:t>
+            </a:r>
+            <a:endParaRPr lang="ko-KR" sz="1200"/>
+          </a:p>
+        </p:txBody>
+      </p:sp>
+      <p:sp>
+        <p:nvSpPr>
+          <p:cNvPr id="15" name="A l1"/>
+          <p:cNvSpPr txBox="1"/>
+          <p:nvPr/>
+        </p:nvSpPr>
+        <p:spPr>
+          <a:xfrm>
+            <a:off x="640080" y="2678460"/>
+            <a:ext cx="1097280" cy="309433"/>
           </a:xfrm>
           <a:prstGeom prst="rect">
             <a:avLst/>
@@ -19200,62 +19304,255 @@
           </a:ln>
         </p:spPr>
         <p:txBody>
-          <a:bodyPr wrap="square" lIns="0" tIns="0" rIns="0" bIns="0" anchor="t">
-            <a:noAutofit/>
-          </a:bodyPr>
-          <a:lstStyle/>
-          <a:p>
-            <a:pPr marL="0" indent="0" algn="ctr">
-              <a:spcAft>
-                <a:spcPts val="700"/>
-              </a:spcAft>
-              <a:buNone/>
-            </a:pPr>
-            <a:r>
-              <a:rPr lang="ko-KR" sz="1200">
-                <a:solidFill>
-                  <a:srgbClr val="3B3B3B"/>
+          <a:bodyPr wrap="square" lIns="0" tIns="0" rIns="0" bIns="0" anchor="ctr">
+            <a:noAutofit/>
+          </a:bodyPr>
+          <a:lstStyle/>
+          <a:p>
+            <a:pPr marL="0" indent="0" algn="l">
+              <a:buNone/>
+            </a:pPr>
+            <a:r>
+              <a:rPr lang="ko-KR" sz="1050" b="1">
+                <a:solidFill>
+                  <a:srgbClr val="1D1F2B"/>
+                </a:solidFill>
+                <a:latin typeface="210 옴니고딕 050"/>
+                <a:ea typeface="210 옴니고딕 050"/>
+                <a:cs typeface="210 옴니고딕 050"/>
+              </a:rPr>
+              <a:t>케라틴 겔</a:t>
+            </a:r>
+            <a:endParaRPr lang="ko-KR" sz="1050"/>
+          </a:p>
+        </p:txBody>
+      </p:sp>
+      <p:sp>
+        <p:nvSpPr>
+          <p:cNvPr id="16" name="A b1"/>
+          <p:cNvSpPr/>
+          <p:nvPr/>
+        </p:nvSpPr>
+        <p:spPr>
+          <a:xfrm>
+            <a:off x="1737360" y="2704247"/>
+            <a:ext cx="1143000" cy="257861"/>
+          </a:xfrm>
+          <a:prstGeom prst="rect">
+            <a:avLst/>
+          </a:prstGeom>
+          <a:solidFill>
+            <a:srgbClr val="437DFF"/>
+          </a:solidFill>
+          <a:ln>
+            <a:noFill/>
+          </a:ln>
+        </p:spPr>
+      </p:sp>
+      <p:sp>
+        <p:nvSpPr>
+          <p:cNvPr id="17" name="A v1"/>
+          <p:cNvSpPr txBox="1"/>
+          <p:nvPr/>
+        </p:nvSpPr>
+        <p:spPr>
+          <a:xfrm>
+            <a:off x="2935224" y="2678460"/>
+            <a:ext cx="685800" cy="309433"/>
+          </a:xfrm>
+          <a:prstGeom prst="rect">
+            <a:avLst/>
+          </a:prstGeom>
+          <a:noFill/>
+          <a:ln>
+            <a:noFill/>
+          </a:ln>
+        </p:spPr>
+        <p:txBody>
+          <a:bodyPr wrap="square" lIns="0" tIns="0" rIns="0" bIns="0" anchor="ctr">
+            <a:noAutofit/>
+          </a:bodyPr>
+          <a:lstStyle/>
+          <a:p>
+            <a:pPr marL="0" indent="0" algn="l">
+              <a:buNone/>
+            </a:pPr>
+            <a:r>
+              <a:rPr lang="ko-KR" sz="1200" b="1">
+                <a:solidFill>
+                  <a:srgbClr val="437DFF"/>
+                </a:solidFill>
+                <a:latin typeface="210 옴니고딕 050"/>
+                <a:ea typeface="210 옴니고딕 050"/>
+                <a:cs typeface="210 옴니고딕 050"/>
+              </a:rPr>
+              <a:t>25.0일</a:t>
+            </a:r>
+            <a:endParaRPr lang="ko-KR" sz="1200"/>
+          </a:p>
+        </p:txBody>
+      </p:sp>
+      <p:sp>
+        <p:nvSpPr>
+          <p:cNvPr id="18" name="A l2"/>
+          <p:cNvSpPr txBox="1"/>
+          <p:nvPr/>
+        </p:nvSpPr>
+        <p:spPr>
+          <a:xfrm>
+            <a:off x="640080" y="3073847"/>
+            <a:ext cx="1097280" cy="309433"/>
+          </a:xfrm>
+          <a:prstGeom prst="rect">
+            <a:avLst/>
+          </a:prstGeom>
+          <a:noFill/>
+          <a:ln>
+            <a:noFill/>
+          </a:ln>
+        </p:spPr>
+        <p:txBody>
+          <a:bodyPr wrap="square" lIns="0" tIns="0" rIns="0" bIns="0" anchor="ctr">
+            <a:noAutofit/>
+          </a:bodyPr>
+          <a:lstStyle/>
+          <a:p>
+            <a:pPr marL="0" indent="0" algn="l">
+              <a:buNone/>
+            </a:pPr>
+            <a:r>
+              <a:rPr lang="ko-KR" sz="1050">
+                <a:solidFill>
+                  <a:srgbClr val="1D1F2B"/>
                 </a:solidFill>
                 <a:latin typeface="210 옴니고딕 040"/>
                 <a:ea typeface="210 옴니고딕 040"/>
                 <a:cs typeface="210 옴니고딕 040"/>
               </a:rPr>
-              <a:t>열 손상 세포 생존 개선</a:t>
+              <a:t>은연고 (SSD)</a:t>
+            </a:r>
+            <a:endParaRPr lang="ko-KR" sz="1050"/>
+          </a:p>
+        </p:txBody>
+      </p:sp>
+      <p:sp>
+        <p:nvSpPr>
+          <p:cNvPr id="19" name="A b2"/>
+          <p:cNvSpPr/>
+          <p:nvPr/>
+        </p:nvSpPr>
+        <p:spPr>
+          <a:xfrm>
+            <a:off x="1737360" y="3099633"/>
+            <a:ext cx="1581912" cy="257861"/>
+          </a:xfrm>
+          <a:prstGeom prst="rect">
+            <a:avLst/>
+          </a:prstGeom>
+          <a:solidFill>
+            <a:srgbClr val="C9CCD6"/>
+          </a:solidFill>
+          <a:ln>
+            <a:noFill/>
+          </a:ln>
+        </p:spPr>
+      </p:sp>
+      <p:sp>
+        <p:nvSpPr>
+          <p:cNvPr id="20" name="A v2"/>
+          <p:cNvSpPr txBox="1"/>
+          <p:nvPr/>
+        </p:nvSpPr>
+        <p:spPr>
+          <a:xfrm>
+            <a:off x="3374136" y="3073847"/>
+            <a:ext cx="685800" cy="309433"/>
+          </a:xfrm>
+          <a:prstGeom prst="rect">
+            <a:avLst/>
+          </a:prstGeom>
+          <a:noFill/>
+          <a:ln>
+            <a:noFill/>
+          </a:ln>
+        </p:spPr>
+        <p:txBody>
+          <a:bodyPr wrap="square" lIns="0" tIns="0" rIns="0" bIns="0" anchor="ctr">
+            <a:noAutofit/>
+          </a:bodyPr>
+          <a:lstStyle/>
+          <a:p>
+            <a:pPr marL="0" indent="0" algn="l">
+              <a:buNone/>
+            </a:pPr>
+            <a:r>
+              <a:rPr lang="ko-KR" sz="1200" b="1">
+                <a:solidFill>
+                  <a:srgbClr val="C9CCD6"/>
+                </a:solidFill>
+                <a:latin typeface="210 옴니고딕 050"/>
+                <a:ea typeface="210 옴니고딕 050"/>
+                <a:cs typeface="210 옴니고딕 050"/>
+              </a:rPr>
+              <a:t>34.6일</a:t>
             </a:r>
             <a:endParaRPr lang="ko-KR" sz="1200"/>
           </a:p>
-          <a:p>
-            <a:pPr marL="0" indent="0" algn="ctr">
-              <a:spcAft>
-                <a:spcPts val="700"/>
-              </a:spcAft>
-              <a:buNone/>
-            </a:pPr>
-            <a:r>
-              <a:rPr lang="ko-KR" sz="1200">
-                <a:solidFill>
-                  <a:srgbClr val="3B3B3B"/>
-                </a:solidFill>
-                <a:latin typeface="210 옴니고딕 040"/>
-                <a:ea typeface="210 옴니고딕 040"/>
-                <a:cs typeface="210 옴니고딕 040"/>
-              </a:rPr>
-              <a:t>염증 줄이는 면역세포(M2) 반응</a:t>
-            </a:r>
-            <a:endParaRPr lang="ko-KR" sz="1200"/>
-          </a:p>
-        </p:txBody>
-      </p:sp>
-      <p:sp>
-        <p:nvSpPr>
-          <p:cNvPr id="13" name="Ev 1"/>
+        </p:txBody>
+      </p:sp>
+      <p:sp>
+        <p:nvSpPr>
+          <p:cNvPr id="21" name="A note"/>
+          <p:cNvSpPr txBox="1"/>
+          <p:nvPr/>
+        </p:nvSpPr>
+        <p:spPr>
+          <a:xfrm>
+            <a:off x="640080" y="3512210"/>
+            <a:ext cx="3364992" cy="275052"/>
+          </a:xfrm>
+          <a:prstGeom prst="rect">
+            <a:avLst/>
+          </a:prstGeom>
+          <a:noFill/>
+          <a:ln>
+            <a:noFill/>
+          </a:ln>
+        </p:spPr>
+        <p:txBody>
+          <a:bodyPr wrap="square" lIns="0" tIns="0" rIns="0" bIns="0" anchor="ctr">
+            <a:noAutofit/>
+          </a:bodyPr>
+          <a:lstStyle/>
+          <a:p>
+            <a:pPr marL="0" indent="0" algn="l">
+              <a:buNone/>
+            </a:pPr>
+            <a:r>
+              <a:rPr lang="ko-KR" sz="1000" b="1">
+                <a:solidFill>
+                  <a:srgbClr val="C00A3E"/>
+                </a:solidFill>
+                <a:latin typeface="210 옴니고딕 050"/>
+                <a:ea typeface="210 옴니고딕 050"/>
+                <a:cs typeface="210 옴니고딕 050"/>
+              </a:rPr>
+              <a:t>케라틴 ≈ 콜라겐 → 케라틴만의 우위는 아님</a:t>
+            </a:r>
+            <a:endParaRPr lang="ko-KR" sz="1000"/>
+          </a:p>
+        </p:txBody>
+      </p:sp>
+      <p:sp>
+        <p:nvSpPr>
+          <p:cNvPr id="22" name="B"/>
           <p:cNvSpPr/>
           <p:nvPr/>
         </p:nvSpPr>
         <p:spPr>
           <a:xfrm>
-            <a:off x="3017520" y="1664208"/>
-            <a:ext cx="2606040" cy="3996842"/>
+            <a:off x="4274820" y="1664208"/>
+            <a:ext cx="3639312" cy="2191817"/>
           </a:xfrm>
           <a:prstGeom prst="roundRect">
             <a:avLst>
@@ -19274,23 +19571,19 @@
       </p:sp>
       <p:sp>
         <p:nvSpPr>
-          <p:cNvPr id="14" name="Ev head 1"/>
-          <p:cNvSpPr txBox="1"/>
-          <p:nvPr/>
-        </p:nvSpPr>
-        <p:spPr>
-          <a:xfrm>
-            <a:off x="3017520" y="1664208"/>
-            <a:ext cx="2606040" cy="429768"/>
-          </a:xfrm>
-          <a:prstGeom prst="round2SameRect">
-            <a:avLst>
-              <a:gd name="adj" fmla="val 16000"/>
-            </a:avLst>
-          </a:prstGeom>
-          <a:solidFill>
-            <a:srgbClr val="437DFF"/>
-          </a:solidFill>
+          <p:cNvPr id="23" name="B t"/>
+          <p:cNvSpPr txBox="1"/>
+          <p:nvPr/>
+        </p:nvSpPr>
+        <p:spPr>
+          <a:xfrm>
+            <a:off x="4411980" y="1732971"/>
+            <a:ext cx="2221992" cy="292242"/>
+          </a:xfrm>
+          <a:prstGeom prst="rect">
+            <a:avLst/>
+          </a:prstGeom>
+          <a:noFill/>
           <a:ln>
             <a:noFill/>
           </a:ln>
@@ -19301,34 +19594,34 @@
           </a:bodyPr>
           <a:lstStyle/>
           <a:p>
-            <a:pPr marL="0" indent="0" algn="ctr">
-              <a:buNone/>
-            </a:pPr>
-            <a:r>
-              <a:rPr lang="ko-KR" sz="1200" b="1">
-                <a:solidFill>
-                  <a:srgbClr val="FFFFFF"/>
+            <a:pPr marL="0" indent="0" algn="l">
+              <a:buNone/>
+            </a:pPr>
+            <a:r>
+              <a:rPr lang="ko-KR" sz="1150" b="1">
+                <a:solidFill>
+                  <a:srgbClr val="1D1F2B"/>
                 </a:solidFill>
                 <a:latin typeface="210 옴니고딕 050"/>
                 <a:ea typeface="210 옴니고딕 050"/>
                 <a:cs typeface="210 옴니고딕 050"/>
               </a:rPr>
-              <a:t>2  동물 (돼지 화상)</a:t>
-            </a:r>
-            <a:endParaRPr lang="ko-KR" sz="1200"/>
-          </a:p>
-        </p:txBody>
-      </p:sp>
-      <p:sp>
-        <p:nvSpPr>
-          <p:cNvPr id="15" name="Ev st 1"/>
-          <p:cNvSpPr txBox="1"/>
-          <p:nvPr/>
-        </p:nvSpPr>
-        <p:spPr>
-          <a:xfrm>
-            <a:off x="3726180" y="2222906"/>
-            <a:ext cx="1188720" cy="292242"/>
+              <a:t>사람 · 유방 방사선피부염</a:t>
+            </a:r>
+            <a:endParaRPr lang="ko-KR" sz="1150"/>
+          </a:p>
+        </p:txBody>
+      </p:sp>
+      <p:sp>
+        <p:nvSpPr>
+          <p:cNvPr id="24" name="B st"/>
+          <p:cNvSpPr txBox="1"/>
+          <p:nvPr/>
+        </p:nvSpPr>
+        <p:spPr>
+          <a:xfrm>
+            <a:off x="6633972" y="1758757"/>
+            <a:ext cx="1170432" cy="257861"/>
           </a:xfrm>
           <a:prstGeom prst="roundRect">
             <a:avLst>
@@ -19336,7 +19629,7 @@
             </a:avLst>
           </a:prstGeom>
           <a:solidFill>
-            <a:srgbClr val="E8EFFF"/>
+            <a:srgbClr val="FBE6EB"/>
           </a:solidFill>
           <a:ln>
             <a:noFill/>
@@ -19352,30 +19645,30 @@
               <a:buNone/>
             </a:pPr>
             <a:r>
-              <a:rPr lang="ko-KR" sz="1050" b="1">
-                <a:solidFill>
-                  <a:srgbClr val="437DFF"/>
+              <a:rPr lang="ko-KR" sz="950" b="1">
+                <a:solidFill>
+                  <a:srgbClr val="C00A3E"/>
                 </a:solidFill>
                 <a:latin typeface="210 옴니고딕 050"/>
                 <a:ea typeface="210 옴니고딕 050"/>
                 <a:cs typeface="210 옴니고딕 050"/>
               </a:rPr>
-              <a:t>신호 · 한계</a:t>
-            </a:r>
-            <a:endParaRPr lang="ko-KR" sz="1050"/>
-          </a:p>
-        </p:txBody>
-      </p:sp>
-      <p:sp>
-        <p:nvSpPr>
-          <p:cNvPr id="16" name="Ev big 1"/>
-          <p:cNvSpPr txBox="1"/>
-          <p:nvPr/>
-        </p:nvSpPr>
-        <p:spPr>
-          <a:xfrm>
-            <a:off x="3108960" y="2609698"/>
-            <a:ext cx="2423160" cy="515722"/>
+              <a:t>유의차 없음</a:t>
+            </a:r>
+            <a:endParaRPr lang="ko-KR" sz="950"/>
+          </a:p>
+        </p:txBody>
+      </p:sp>
+      <p:sp>
+        <p:nvSpPr>
+          <p:cNvPr id="25" name="B cap"/>
+          <p:cNvSpPr txBox="1"/>
+          <p:nvPr/>
+        </p:nvSpPr>
+        <p:spPr>
+          <a:xfrm>
+            <a:off x="4411980" y="2008022"/>
+            <a:ext cx="3364992" cy="223479"/>
           </a:xfrm>
           <a:prstGeom prst="rect">
             <a:avLst/>
@@ -19386,6 +19679,71 @@
           </a:ln>
         </p:spPr>
         <p:txBody>
+          <a:bodyPr wrap="square" lIns="0" tIns="0" rIns="0" bIns="0" anchor="t">
+            <a:noAutofit/>
+          </a:bodyPr>
+          <a:lstStyle/>
+          <a:p>
+            <a:pPr marL="0" indent="0" algn="l">
+              <a:buNone/>
+            </a:pPr>
+            <a:r>
+              <a:rPr lang="ko-KR" sz="950">
+                <a:solidFill>
+                  <a:srgbClr val="6B6E7A"/>
+                </a:solidFill>
+                <a:latin typeface="210 옴니고딕 040"/>
+                <a:ea typeface="210 옴니고딕 040"/>
+                <a:cs typeface="210 옴니고딕 040"/>
+              </a:rPr>
+              <a:t>2도 피부염 발생률 (낮을수록 좋음)</a:t>
+            </a:r>
+            <a:endParaRPr lang="ko-KR" sz="950"/>
+          </a:p>
+        </p:txBody>
+      </p:sp>
+      <p:sp>
+        <p:nvSpPr>
+          <p:cNvPr id="26" name="B b0"/>
+          <p:cNvSpPr/>
+          <p:nvPr/>
+        </p:nvSpPr>
+        <p:spPr>
+          <a:xfrm>
+            <a:off x="5033132" y="2884434"/>
+            <a:ext cx="668792" cy="412893"/>
+          </a:xfrm>
+          <a:prstGeom prst="rect">
+            <a:avLst/>
+          </a:prstGeom>
+          <a:solidFill>
+            <a:srgbClr val="C00A3E"/>
+          </a:solidFill>
+          <a:ln>
+            <a:noFill/>
+          </a:ln>
+        </p:spPr>
+      </p:sp>
+      <p:sp>
+        <p:nvSpPr>
+          <p:cNvPr id="27" name="B v0"/>
+          <p:cNvSpPr txBox="1"/>
+          <p:nvPr/>
+        </p:nvSpPr>
+        <p:spPr>
+          <a:xfrm>
+            <a:off x="4640580" y="2575001"/>
+            <a:ext cx="1453896" cy="292242"/>
+          </a:xfrm>
+          <a:prstGeom prst="rect">
+            <a:avLst/>
+          </a:prstGeom>
+          <a:noFill/>
+          <a:ln>
+            <a:noFill/>
+          </a:ln>
+        </p:spPr>
+        <p:txBody>
           <a:bodyPr wrap="square" lIns="0" tIns="0" rIns="0" bIns="0" anchor="ctr">
             <a:noAutofit/>
           </a:bodyPr>
@@ -19395,30 +19753,30 @@
               <a:buNone/>
             </a:pPr>
             <a:r>
-              <a:rPr lang="ko-KR" sz="1700" b="1">
-                <a:solidFill>
-                  <a:srgbClr val="437DFF"/>
+              <a:rPr lang="ko-KR" sz="1600" b="1">
+                <a:solidFill>
+                  <a:srgbClr val="C00A3E"/>
                 </a:solidFill>
                 <a:latin typeface="210 옴니고딕 050"/>
                 <a:ea typeface="210 옴니고딕 050"/>
                 <a:cs typeface="210 옴니고딕 050"/>
               </a:rPr>
-              <a:t>25.0일 vs 34.6일</a:t>
-            </a:r>
-            <a:endParaRPr lang="ko-KR" sz="1700"/>
-          </a:p>
-        </p:txBody>
-      </p:sp>
-      <p:sp>
-        <p:nvSpPr>
-          <p:cNvPr id="17" name="Ev lines 1"/>
-          <p:cNvSpPr txBox="1"/>
-          <p:nvPr/>
-        </p:nvSpPr>
-        <p:spPr>
-          <a:xfrm>
-            <a:off x="3200400" y="3254350"/>
-            <a:ext cx="2240280" cy="1633118"/>
+              <a:t>30.8%</a:t>
+            </a:r>
+            <a:endParaRPr lang="ko-KR" sz="1600"/>
+          </a:p>
+        </p:txBody>
+      </p:sp>
+      <p:sp>
+        <p:nvSpPr>
+          <p:cNvPr id="28" name="B l0"/>
+          <p:cNvSpPr txBox="1"/>
+          <p:nvPr/>
+        </p:nvSpPr>
+        <p:spPr>
+          <a:xfrm>
+            <a:off x="4640580" y="3331708"/>
+            <a:ext cx="1453896" cy="223479"/>
           </a:xfrm>
           <a:prstGeom prst="rect">
             <a:avLst/>
@@ -19435,68 +19793,18 @@
           <a:lstStyle/>
           <a:p>
             <a:pPr marL="0" indent="0" algn="ctr">
-              <a:spcAft>
-                <a:spcPts val="700"/>
-              </a:spcAft>
-              <a:buNone/>
-            </a:pPr>
-            <a:r>
-              <a:rPr lang="ko-KR" sz="1200">
-                <a:solidFill>
-                  <a:srgbClr val="3B3B3B"/>
-                </a:solidFill>
-                <a:latin typeface="210 옴니고딕 040"/>
-                <a:ea typeface="210 옴니고딕 040"/>
-                <a:cs typeface="210 옴니고딕 040"/>
-              </a:rPr>
-              <a:t>상처 닫힘: 케라틴 겔 vs 은연고(SSD)</a:t>
-            </a:r>
-            <a:endParaRPr lang="ko-KR" sz="1200"/>
-          </a:p>
-        </p:txBody>
-      </p:sp>
-      <p:sp>
-        <p:nvSpPr>
-          <p:cNvPr id="18" name="Ev cav 1"/>
-          <p:cNvSpPr txBox="1"/>
-          <p:nvPr/>
-        </p:nvSpPr>
-        <p:spPr>
-          <a:xfrm>
-            <a:off x="3154680" y="4930445"/>
-            <a:ext cx="2331720" cy="601675"/>
-          </a:xfrm>
-          <a:prstGeom prst="roundRect">
-            <a:avLst>
-              <a:gd name="adj" fmla="val 12000"/>
-            </a:avLst>
-          </a:prstGeom>
-          <a:solidFill>
-            <a:srgbClr val="FBE6EB"/>
-          </a:solidFill>
-          <a:ln>
-            <a:noFill/>
-          </a:ln>
-        </p:spPr>
-        <p:txBody>
-          <a:bodyPr wrap="square" lIns="45720" tIns="27432" rIns="45720" bIns="27432" anchor="ctr">
-            <a:noAutofit/>
-          </a:bodyPr>
-          <a:lstStyle/>
-          <a:p>
-            <a:pPr marL="0" indent="0" algn="ctr">
               <a:buNone/>
             </a:pPr>
             <a:r>
               <a:rPr lang="ko-KR" sz="1000" b="1">
                 <a:solidFill>
-                  <a:srgbClr val="C00A3E"/>
+                  <a:srgbClr val="1D1F2B"/>
                 </a:solidFill>
                 <a:latin typeface="210 옴니고딕 050"/>
                 <a:ea typeface="210 옴니고딕 050"/>
                 <a:cs typeface="210 옴니고딕 050"/>
               </a:rPr>
-              <a:t>콜라겐 겔 24.2일 → 케라틴만의 우위 아님</a:t>
+              <a:t>KeraStat</a:t>
             </a:r>
             <a:endParaRPr lang="ko-KR" sz="1000"/>
           </a:p>
@@ -19504,14 +19812,187 @@
       </p:sp>
       <p:sp>
         <p:nvSpPr>
-          <p:cNvPr id="19" name="Ev 2"/>
+          <p:cNvPr id="29" name="B b1"/>
           <p:cNvSpPr/>
           <p:nvPr/>
         </p:nvSpPr>
         <p:spPr>
           <a:xfrm>
-            <a:off x="5715000" y="1664208"/>
-            <a:ext cx="3657600" cy="3996842"/>
+            <a:off x="6487028" y="2566721"/>
+            <a:ext cx="668792" cy="730606"/>
+          </a:xfrm>
+          <a:prstGeom prst="rect">
+            <a:avLst/>
+          </a:prstGeom>
+          <a:solidFill>
+            <a:srgbClr val="C9CCD6"/>
+          </a:solidFill>
+          <a:ln>
+            <a:noFill/>
+          </a:ln>
+        </p:spPr>
+      </p:sp>
+      <p:sp>
+        <p:nvSpPr>
+          <p:cNvPr id="30" name="B v1"/>
+          <p:cNvSpPr txBox="1"/>
+          <p:nvPr/>
+        </p:nvSpPr>
+        <p:spPr>
+          <a:xfrm>
+            <a:off x="6094476" y="2257288"/>
+            <a:ext cx="1453896" cy="292242"/>
+          </a:xfrm>
+          <a:prstGeom prst="rect">
+            <a:avLst/>
+          </a:prstGeom>
+          <a:noFill/>
+          <a:ln>
+            <a:noFill/>
+          </a:ln>
+        </p:spPr>
+        <p:txBody>
+          <a:bodyPr wrap="square" lIns="0" tIns="0" rIns="0" bIns="0" anchor="ctr">
+            <a:noAutofit/>
+          </a:bodyPr>
+          <a:lstStyle/>
+          <a:p>
+            <a:pPr marL="0" indent="0" algn="ctr">
+              <a:buNone/>
+            </a:pPr>
+            <a:r>
+              <a:rPr lang="ko-KR" sz="1600" b="1">
+                <a:solidFill>
+                  <a:srgbClr val="C9CCD6"/>
+                </a:solidFill>
+                <a:latin typeface="210 옴니고딕 050"/>
+                <a:ea typeface="210 옴니고딕 050"/>
+                <a:cs typeface="210 옴니고딕 050"/>
+              </a:rPr>
+              <a:t>54.5%</a:t>
+            </a:r>
+            <a:endParaRPr lang="ko-KR" sz="1600"/>
+          </a:p>
+        </p:txBody>
+      </p:sp>
+      <p:sp>
+        <p:nvSpPr>
+          <p:cNvPr id="31" name="B l1"/>
+          <p:cNvSpPr txBox="1"/>
+          <p:nvPr/>
+        </p:nvSpPr>
+        <p:spPr>
+          <a:xfrm>
+            <a:off x="6094476" y="3331708"/>
+            <a:ext cx="1453896" cy="223479"/>
+          </a:xfrm>
+          <a:prstGeom prst="rect">
+            <a:avLst/>
+          </a:prstGeom>
+          <a:noFill/>
+          <a:ln>
+            <a:noFill/>
+          </a:ln>
+        </p:spPr>
+        <p:txBody>
+          <a:bodyPr wrap="square" lIns="0" tIns="0" rIns="0" bIns="0" anchor="t">
+            <a:noAutofit/>
+          </a:bodyPr>
+          <a:lstStyle/>
+          <a:p>
+            <a:pPr marL="0" indent="0" algn="ctr">
+              <a:buNone/>
+            </a:pPr>
+            <a:r>
+              <a:rPr lang="ko-KR" sz="1000" b="1">
+                <a:solidFill>
+                  <a:srgbClr val="1D1F2B"/>
+                </a:solidFill>
+                <a:latin typeface="210 옴니고딕 050"/>
+                <a:ea typeface="210 옴니고딕 050"/>
+                <a:cs typeface="210 옴니고딕 050"/>
+              </a:rPr>
+              <a:t>표준관리</a:t>
+            </a:r>
+            <a:endParaRPr lang="ko-KR" sz="1000"/>
+          </a:p>
+        </p:txBody>
+      </p:sp>
+      <p:sp>
+        <p:nvSpPr>
+          <p:cNvPr id="32" name="B base"/>
+          <p:cNvSpPr/>
+          <p:nvPr/>
+        </p:nvSpPr>
+        <p:spPr>
+          <a:xfrm>
+            <a:off x="4640580" y="3297326"/>
+            <a:ext cx="2907792" cy="17191"/>
+          </a:xfrm>
+          <a:prstGeom prst="rect">
+            <a:avLst/>
+          </a:prstGeom>
+          <a:solidFill>
+            <a:srgbClr val="D5D8E0"/>
+          </a:solidFill>
+          <a:ln>
+            <a:noFill/>
+          </a:ln>
+        </p:spPr>
+      </p:sp>
+      <p:sp>
+        <p:nvSpPr>
+          <p:cNvPr id="33" name="B note"/>
+          <p:cNvSpPr txBox="1"/>
+          <p:nvPr/>
+        </p:nvSpPr>
+        <p:spPr>
+          <a:xfrm>
+            <a:off x="4411980" y="3572378"/>
+            <a:ext cx="3364992" cy="240670"/>
+          </a:xfrm>
+          <a:prstGeom prst="rect">
+            <a:avLst/>
+          </a:prstGeom>
+          <a:noFill/>
+          <a:ln>
+            <a:noFill/>
+          </a:ln>
+        </p:spPr>
+        <p:txBody>
+          <a:bodyPr wrap="square" lIns="0" tIns="0" rIns="0" bIns="0" anchor="ctr">
+            <a:noAutofit/>
+          </a:bodyPr>
+          <a:lstStyle/>
+          <a:p>
+            <a:pPr marL="0" indent="0" algn="ctr">
+              <a:buNone/>
+            </a:pPr>
+            <a:r>
+              <a:rPr lang="ko-KR" sz="1000" b="1">
+                <a:solidFill>
+                  <a:srgbClr val="C00A3E"/>
+                </a:solidFill>
+                <a:latin typeface="210 옴니고딕 050"/>
+                <a:ea typeface="210 옴니고딕 050"/>
+                <a:cs typeface="210 옴니고딕 050"/>
+              </a:rPr>
+              <a:t>KeraStat Cream · 24명 · p = 0.408 → 차이 없음</a:t>
+            </a:r>
+            <a:endParaRPr lang="ko-KR" sz="1000"/>
+          </a:p>
+        </p:txBody>
+      </p:sp>
+      <p:sp>
+        <p:nvSpPr>
+          <p:cNvPr id="34" name="C"/>
+          <p:cNvSpPr/>
+          <p:nvPr/>
+        </p:nvSpPr>
+        <p:spPr>
+          <a:xfrm>
+            <a:off x="8046720" y="1664208"/>
+            <a:ext cx="3639312" cy="2191817"/>
           </a:xfrm>
           <a:prstGeom prst="roundRect">
             <a:avLst>
@@ -19530,23 +20011,19 @@
       </p:sp>
       <p:sp>
         <p:nvSpPr>
-          <p:cNvPr id="20" name="Ev head 2"/>
-          <p:cNvSpPr txBox="1"/>
-          <p:nvPr/>
-        </p:nvSpPr>
-        <p:spPr>
-          <a:xfrm>
-            <a:off x="5715000" y="1664208"/>
-            <a:ext cx="3657600" cy="429768"/>
-          </a:xfrm>
-          <a:prstGeom prst="round2SameRect">
-            <a:avLst>
-              <a:gd name="adj" fmla="val 16000"/>
-            </a:avLst>
-          </a:prstGeom>
-          <a:solidFill>
-            <a:srgbClr val="C00A3E"/>
-          </a:solidFill>
+          <p:cNvPr id="35" name="C t"/>
+          <p:cNvSpPr txBox="1"/>
+          <p:nvPr/>
+        </p:nvSpPr>
+        <p:spPr>
+          <a:xfrm>
+            <a:off x="8183880" y="1732971"/>
+            <a:ext cx="2221992" cy="292242"/>
+          </a:xfrm>
+          <a:prstGeom prst="rect">
+            <a:avLst/>
+          </a:prstGeom>
+          <a:noFill/>
           <a:ln>
             <a:noFill/>
           </a:ln>
@@ -19557,34 +20034,34 @@
           </a:bodyPr>
           <a:lstStyle/>
           <a:p>
-            <a:pPr marL="0" indent="0" algn="ctr">
-              <a:buNone/>
-            </a:pPr>
-            <a:r>
-              <a:rPr lang="ko-KR" sz="1200" b="1">
-                <a:solidFill>
-                  <a:srgbClr val="FFFFFF"/>
+            <a:pPr marL="0" indent="0" algn="l">
+              <a:buNone/>
+            </a:pPr>
+            <a:r>
+              <a:rPr lang="ko-KR" sz="1150" b="1">
+                <a:solidFill>
+                  <a:srgbClr val="1D1F2B"/>
                 </a:solidFill>
                 <a:latin typeface="210 옴니고딕 050"/>
                 <a:ea typeface="210 옴니고딕 050"/>
                 <a:cs typeface="210 옴니고딕 050"/>
               </a:rPr>
-              <a:t>3  사람 (KeraStat)</a:t>
-            </a:r>
-            <a:endParaRPr lang="ko-KR" sz="1200"/>
-          </a:p>
-        </p:txBody>
-      </p:sp>
-      <p:sp>
-        <p:nvSpPr>
-          <p:cNvPr id="21" name="Ev st 2"/>
-          <p:cNvSpPr txBox="1"/>
-          <p:nvPr/>
-        </p:nvSpPr>
-        <p:spPr>
-          <a:xfrm>
-            <a:off x="6949440" y="2222906"/>
-            <a:ext cx="1188720" cy="292242"/>
+              <a:t>사람 · 당뇨발 (ProgenaMatrix)</a:t>
+            </a:r>
+            <a:endParaRPr lang="ko-KR" sz="1150"/>
+          </a:p>
+        </p:txBody>
+      </p:sp>
+      <p:sp>
+        <p:nvSpPr>
+          <p:cNvPr id="36" name="C st"/>
+          <p:cNvSpPr txBox="1"/>
+          <p:nvPr/>
+        </p:nvSpPr>
+        <p:spPr>
+          <a:xfrm>
+            <a:off x="10405872" y="1758757"/>
+            <a:ext cx="1170432" cy="257861"/>
           </a:xfrm>
           <a:prstGeom prst="roundRect">
             <a:avLst>
@@ -19608,7 +20085,7 @@
               <a:buNone/>
             </a:pPr>
             <a:r>
-              <a:rPr lang="ko-KR" sz="1050" b="1">
+              <a:rPr lang="ko-KR" sz="950" b="1">
                 <a:solidFill>
                   <a:srgbClr val="C00A3E"/>
                 </a:solidFill>
@@ -19616,22 +20093,22 @@
                 <a:ea typeface="210 옴니고딕 050"/>
                 <a:cs typeface="210 옴니고딕 050"/>
               </a:rPr>
-              <a:t>미확증</a:t>
-            </a:r>
-            <a:endParaRPr lang="ko-KR" sz="1050"/>
-          </a:p>
-        </p:txBody>
-      </p:sp>
-      <p:sp>
-        <p:nvSpPr>
-          <p:cNvPr id="22" name="Ev big 2"/>
-          <p:cNvSpPr txBox="1"/>
-          <p:nvPr/>
-        </p:nvSpPr>
-        <p:spPr>
-          <a:xfrm>
-            <a:off x="5806440" y="2609698"/>
-            <a:ext cx="3474720" cy="515722"/>
+              <a:t>비교군 없음</a:t>
+            </a:r>
+            <a:endParaRPr lang="ko-KR" sz="950"/>
+          </a:p>
+        </p:txBody>
+      </p:sp>
+      <p:sp>
+        <p:nvSpPr>
+          <p:cNvPr id="37" name="C cap"/>
+          <p:cNvSpPr txBox="1"/>
+          <p:nvPr/>
+        </p:nvSpPr>
+        <p:spPr>
+          <a:xfrm>
+            <a:off x="8183880" y="2008022"/>
+            <a:ext cx="3364992" cy="223479"/>
           </a:xfrm>
           <a:prstGeom prst="rect">
             <a:avLst/>
@@ -19642,6 +20119,71 @@
           </a:ln>
         </p:spPr>
         <p:txBody>
+          <a:bodyPr wrap="square" lIns="0" tIns="0" rIns="0" bIns="0" anchor="t">
+            <a:noAutofit/>
+          </a:bodyPr>
+          <a:lstStyle/>
+          <a:p>
+            <a:pPr marL="0" indent="0" algn="l">
+              <a:buNone/>
+            </a:pPr>
+            <a:r>
+              <a:rPr lang="ko-KR" sz="950">
+                <a:solidFill>
+                  <a:srgbClr val="6B6E7A"/>
+                </a:solidFill>
+                <a:latin typeface="210 옴니고딕 040"/>
+                <a:ea typeface="210 옴니고딕 040"/>
+                <a:cs typeface="210 옴니고딕 040"/>
+              </a:rPr>
+              <a:t>12주 내 치유율</a:t>
+            </a:r>
+            <a:endParaRPr lang="ko-KR" sz="950"/>
+          </a:p>
+        </p:txBody>
+      </p:sp>
+      <p:sp>
+        <p:nvSpPr>
+          <p:cNvPr id="38" name="C b0"/>
+          <p:cNvSpPr/>
+          <p:nvPr/>
+        </p:nvSpPr>
+        <p:spPr>
+          <a:xfrm>
+            <a:off x="8805032" y="2566721"/>
+            <a:ext cx="668792" cy="730606"/>
+          </a:xfrm>
+          <a:prstGeom prst="rect">
+            <a:avLst/>
+          </a:prstGeom>
+          <a:solidFill>
+            <a:srgbClr val="7030A0"/>
+          </a:solidFill>
+          <a:ln>
+            <a:noFill/>
+          </a:ln>
+        </p:spPr>
+      </p:sp>
+      <p:sp>
+        <p:nvSpPr>
+          <p:cNvPr id="39" name="C v0"/>
+          <p:cNvSpPr txBox="1"/>
+          <p:nvPr/>
+        </p:nvSpPr>
+        <p:spPr>
+          <a:xfrm>
+            <a:off x="8412480" y="2257288"/>
+            <a:ext cx="1453896" cy="292242"/>
+          </a:xfrm>
+          <a:prstGeom prst="rect">
+            <a:avLst/>
+          </a:prstGeom>
+          <a:noFill/>
+          <a:ln>
+            <a:noFill/>
+          </a:ln>
+        </p:spPr>
+        <p:txBody>
           <a:bodyPr wrap="square" lIns="0" tIns="0" rIns="0" bIns="0" anchor="ctr">
             <a:noAutofit/>
           </a:bodyPr>
@@ -19651,30 +20193,30 @@
               <a:buNone/>
             </a:pPr>
             <a:r>
-              <a:rPr lang="ko-KR" sz="2000" b="1">
-                <a:solidFill>
-                  <a:srgbClr val="C00A3E"/>
+              <a:rPr lang="ko-KR" sz="1600" b="1">
+                <a:solidFill>
+                  <a:srgbClr val="7030A0"/>
                 </a:solidFill>
                 <a:latin typeface="210 옴니고딕 050"/>
                 <a:ea typeface="210 옴니고딕 050"/>
                 <a:cs typeface="210 옴니고딕 050"/>
               </a:rPr>
-              <a:t>유의차 없음</a:t>
-            </a:r>
-            <a:endParaRPr lang="ko-KR" sz="2000"/>
-          </a:p>
-        </p:txBody>
-      </p:sp>
-      <p:sp>
-        <p:nvSpPr>
-          <p:cNvPr id="23" name="Ev lines 2"/>
-          <p:cNvSpPr txBox="1"/>
-          <p:nvPr/>
-        </p:nvSpPr>
-        <p:spPr>
-          <a:xfrm>
-            <a:off x="5897880" y="3254350"/>
-            <a:ext cx="3291840" cy="1633118"/>
+              <a:t>77%</a:t>
+            </a:r>
+            <a:endParaRPr lang="ko-KR" sz="1600"/>
+          </a:p>
+        </p:txBody>
+      </p:sp>
+      <p:sp>
+        <p:nvSpPr>
+          <p:cNvPr id="40" name="C l0"/>
+          <p:cNvSpPr txBox="1"/>
+          <p:nvPr/>
+        </p:nvSpPr>
+        <p:spPr>
+          <a:xfrm>
+            <a:off x="8412480" y="3331708"/>
+            <a:ext cx="1453896" cy="223479"/>
           </a:xfrm>
           <a:prstGeom prst="rect">
             <a:avLst/>
@@ -19690,97 +20232,207 @@
           </a:bodyPr>
           <a:lstStyle/>
           <a:p>
-            <a:pPr marL="0" indent="0" algn="l">
-              <a:spcAft>
-                <a:spcPts val="700"/>
-              </a:spcAft>
-              <a:buNone/>
-            </a:pPr>
-            <a:r>
-              <a:rPr lang="ko-KR" sz="1200">
-                <a:solidFill>
-                  <a:srgbClr val="3B3B3B"/>
-                </a:solidFill>
-                <a:latin typeface="210 옴니고딕 040"/>
-                <a:ea typeface="210 옴니고딕 040"/>
-                <a:cs typeface="210 옴니고딕 040"/>
-              </a:rPr>
-              <a:t>유방 방사선피부염 30.8% vs 54.5% (24명, p=0.408)</a:t>
-            </a:r>
-            <a:endParaRPr lang="ko-KR" sz="1200"/>
-          </a:p>
-          <a:p>
-            <a:pPr marL="0" indent="0" algn="l">
-              <a:spcAft>
-                <a:spcPts val="700"/>
-              </a:spcAft>
-              <a:buNone/>
-            </a:pPr>
-            <a:r>
-              <a:rPr lang="ko-KR" sz="1200">
-                <a:solidFill>
-                  <a:srgbClr val="3B3B3B"/>
-                </a:solidFill>
-                <a:latin typeface="210 옴니고딕 040"/>
-                <a:ea typeface="210 옴니고딕 040"/>
-                <a:cs typeface="210 옴니고딕 040"/>
-              </a:rPr>
-              <a:t>두경부 방사선피부염: 차이 없음 (24명)</a:t>
-            </a:r>
-            <a:endParaRPr lang="ko-KR" sz="1200"/>
-          </a:p>
-          <a:p>
-            <a:pPr marL="0" indent="0" algn="l">
-              <a:spcAft>
-                <a:spcPts val="700"/>
-              </a:spcAft>
-              <a:buNone/>
-            </a:pPr>
-            <a:r>
-              <a:rPr lang="ko-KR" sz="1200">
-                <a:solidFill>
-                  <a:srgbClr val="3B3B3B"/>
-                </a:solidFill>
-                <a:latin typeface="210 옴니고딕 040"/>
-                <a:ea typeface="210 옴니고딕 040"/>
-                <a:cs typeface="210 옴니고딕 040"/>
-              </a:rPr>
-              <a:t>화상 시험: 30명 계획 → 14명 등록 후 종료</a:t>
-            </a:r>
-            <a:endParaRPr lang="ko-KR" sz="1200"/>
-          </a:p>
-          <a:p>
-            <a:pPr marL="0" indent="0" algn="l">
-              <a:spcAft>
-                <a:spcPts val="700"/>
-              </a:spcAft>
-              <a:buNone/>
-            </a:pPr>
-            <a:r>
-              <a:rPr lang="ko-KR" sz="1200">
-                <a:solidFill>
-                  <a:srgbClr val="3B3B3B"/>
-                </a:solidFill>
-                <a:latin typeface="210 옴니고딕 040"/>
-                <a:ea typeface="210 옴니고딕 040"/>
-                <a:cs typeface="210 옴니고딕 040"/>
-              </a:rPr>
-              <a:t>ProgenaMatrix 당뇨발 77% / 69% (비교군 없음)</a:t>
-            </a:r>
-            <a:endParaRPr lang="ko-KR" sz="1200"/>
-          </a:p>
-        </p:txBody>
-      </p:sp>
-      <p:sp>
-        <p:nvSpPr>
-          <p:cNvPr id="24" name="Ev 3"/>
+            <a:pPr marL="0" indent="0" algn="ctr">
+              <a:buNone/>
+            </a:pPr>
+            <a:r>
+              <a:rPr lang="ko-KR" sz="1000" b="1">
+                <a:solidFill>
+                  <a:srgbClr val="1D1F2B"/>
+                </a:solidFill>
+                <a:latin typeface="210 옴니고딕 050"/>
+                <a:ea typeface="210 옴니고딕 050"/>
+                <a:cs typeface="210 옴니고딕 050"/>
+              </a:rPr>
+              <a:t>주 1회</a:t>
+            </a:r>
+            <a:endParaRPr lang="ko-KR" sz="1000"/>
+          </a:p>
+        </p:txBody>
+      </p:sp>
+      <p:sp>
+        <p:nvSpPr>
+          <p:cNvPr id="41" name="C b1"/>
           <p:cNvSpPr/>
           <p:nvPr/>
         </p:nvSpPr>
         <p:spPr>
           <a:xfrm>
-            <a:off x="9464040" y="1664208"/>
-            <a:ext cx="2221992" cy="3996842"/>
+            <a:off x="10258928" y="2642628"/>
+            <a:ext cx="668792" cy="654699"/>
+          </a:xfrm>
+          <a:prstGeom prst="rect">
+            <a:avLst/>
+          </a:prstGeom>
+          <a:solidFill>
+            <a:srgbClr val="9BAAE0"/>
+          </a:solidFill>
+          <a:ln>
+            <a:noFill/>
+          </a:ln>
+        </p:spPr>
+      </p:sp>
+      <p:sp>
+        <p:nvSpPr>
+          <p:cNvPr id="42" name="C v1"/>
+          <p:cNvSpPr txBox="1"/>
+          <p:nvPr/>
+        </p:nvSpPr>
+        <p:spPr>
+          <a:xfrm>
+            <a:off x="9866376" y="2333195"/>
+            <a:ext cx="1453896" cy="292242"/>
+          </a:xfrm>
+          <a:prstGeom prst="rect">
+            <a:avLst/>
+          </a:prstGeom>
+          <a:noFill/>
+          <a:ln>
+            <a:noFill/>
+          </a:ln>
+        </p:spPr>
+        <p:txBody>
+          <a:bodyPr wrap="square" lIns="0" tIns="0" rIns="0" bIns="0" anchor="ctr">
+            <a:noAutofit/>
+          </a:bodyPr>
+          <a:lstStyle/>
+          <a:p>
+            <a:pPr marL="0" indent="0" algn="ctr">
+              <a:buNone/>
+            </a:pPr>
+            <a:r>
+              <a:rPr lang="ko-KR" sz="1600" b="1">
+                <a:solidFill>
+                  <a:srgbClr val="9BAAE0"/>
+                </a:solidFill>
+                <a:latin typeface="210 옴니고딕 050"/>
+                <a:ea typeface="210 옴니고딕 050"/>
+                <a:cs typeface="210 옴니고딕 050"/>
+              </a:rPr>
+              <a:t>69%</a:t>
+            </a:r>
+            <a:endParaRPr lang="ko-KR" sz="1600"/>
+          </a:p>
+        </p:txBody>
+      </p:sp>
+      <p:sp>
+        <p:nvSpPr>
+          <p:cNvPr id="43" name="C l1"/>
+          <p:cNvSpPr txBox="1"/>
+          <p:nvPr/>
+        </p:nvSpPr>
+        <p:spPr>
+          <a:xfrm>
+            <a:off x="9866376" y="3331708"/>
+            <a:ext cx="1453896" cy="223479"/>
+          </a:xfrm>
+          <a:prstGeom prst="rect">
+            <a:avLst/>
+          </a:prstGeom>
+          <a:noFill/>
+          <a:ln>
+            <a:noFill/>
+          </a:ln>
+        </p:spPr>
+        <p:txBody>
+          <a:bodyPr wrap="square" lIns="0" tIns="0" rIns="0" bIns="0" anchor="t">
+            <a:noAutofit/>
+          </a:bodyPr>
+          <a:lstStyle/>
+          <a:p>
+            <a:pPr marL="0" indent="0" algn="ctr">
+              <a:buNone/>
+            </a:pPr>
+            <a:r>
+              <a:rPr lang="ko-KR" sz="1000" b="1">
+                <a:solidFill>
+                  <a:srgbClr val="1D1F2B"/>
+                </a:solidFill>
+                <a:latin typeface="210 옴니고딕 050"/>
+                <a:ea typeface="210 옴니고딕 050"/>
+                <a:cs typeface="210 옴니고딕 050"/>
+              </a:rPr>
+              <a:t>격주</a:t>
+            </a:r>
+            <a:endParaRPr lang="ko-KR" sz="1000"/>
+          </a:p>
+        </p:txBody>
+      </p:sp>
+      <p:sp>
+        <p:nvSpPr>
+          <p:cNvPr id="44" name="C base"/>
+          <p:cNvSpPr/>
+          <p:nvPr/>
+        </p:nvSpPr>
+        <p:spPr>
+          <a:xfrm>
+            <a:off x="8412480" y="3297326"/>
+            <a:ext cx="2907792" cy="17191"/>
+          </a:xfrm>
+          <a:prstGeom prst="rect">
+            <a:avLst/>
+          </a:prstGeom>
+          <a:solidFill>
+            <a:srgbClr val="D5D8E0"/>
+          </a:solidFill>
+          <a:ln>
+            <a:noFill/>
+          </a:ln>
+        </p:spPr>
+      </p:sp>
+      <p:sp>
+        <p:nvSpPr>
+          <p:cNvPr id="45" name="C note"/>
+          <p:cNvSpPr txBox="1"/>
+          <p:nvPr/>
+        </p:nvSpPr>
+        <p:spPr>
+          <a:xfrm>
+            <a:off x="8183880" y="3572378"/>
+            <a:ext cx="3364992" cy="240670"/>
+          </a:xfrm>
+          <a:prstGeom prst="rect">
+            <a:avLst/>
+          </a:prstGeom>
+          <a:noFill/>
+          <a:ln>
+            <a:noFill/>
+          </a:ln>
+        </p:spPr>
+        <p:txBody>
+          <a:bodyPr wrap="square" lIns="0" tIns="0" rIns="0" bIns="0" anchor="ctr">
+            <a:noAutofit/>
+          </a:bodyPr>
+          <a:lstStyle/>
+          <a:p>
+            <a:pPr marL="0" indent="0" algn="ctr">
+              <a:buNone/>
+            </a:pPr>
+            <a:r>
+              <a:rPr lang="ko-KR" sz="1000" b="1">
+                <a:solidFill>
+                  <a:srgbClr val="C00A3E"/>
+                </a:solidFill>
+                <a:latin typeface="210 옴니고딕 050"/>
+                <a:ea typeface="210 옴니고딕 050"/>
+                <a:cs typeface="210 옴니고딕 050"/>
+              </a:rPr>
+              <a:t>26명 · 표준치료 단독 대조군 없음</a:t>
+            </a:r>
+            <a:endParaRPr lang="ko-KR" sz="1000"/>
+          </a:p>
+        </p:txBody>
+      </p:sp>
+      <p:sp>
+        <p:nvSpPr>
+          <p:cNvPr id="46" name="D"/>
+          <p:cNvSpPr/>
+          <p:nvPr/>
+        </p:nvSpPr>
+        <p:spPr>
+          <a:xfrm>
+            <a:off x="502920" y="3984955"/>
+            <a:ext cx="5486400" cy="1701881"/>
           </a:xfrm>
           <a:prstGeom prst="roundRect">
             <a:avLst>
@@ -19799,23 +20451,19 @@
       </p:sp>
       <p:sp>
         <p:nvSpPr>
-          <p:cNvPr id="25" name="Ev head 3"/>
-          <p:cNvSpPr txBox="1"/>
-          <p:nvPr/>
-        </p:nvSpPr>
-        <p:spPr>
-          <a:xfrm>
-            <a:off x="9464040" y="1664208"/>
-            <a:ext cx="2221992" cy="429768"/>
-          </a:xfrm>
-          <a:prstGeom prst="round2SameRect">
-            <a:avLst>
-              <a:gd name="adj" fmla="val 16000"/>
-            </a:avLst>
-          </a:prstGeom>
-          <a:solidFill>
-            <a:srgbClr val="3B3F57"/>
-          </a:solidFill>
+          <p:cNvPr id="47" name="D t"/>
+          <p:cNvSpPr txBox="1"/>
+          <p:nvPr/>
+        </p:nvSpPr>
+        <p:spPr>
+          <a:xfrm>
+            <a:off x="640080" y="4053718"/>
+            <a:ext cx="4069080" cy="292242"/>
+          </a:xfrm>
+          <a:prstGeom prst="rect">
+            <a:avLst/>
+          </a:prstGeom>
+          <a:noFill/>
           <a:ln>
             <a:noFill/>
           </a:ln>
@@ -19826,34 +20474,34 @@
           </a:bodyPr>
           <a:lstStyle/>
           <a:p>
-            <a:pPr marL="0" indent="0" algn="ctr">
-              <a:buNone/>
-            </a:pPr>
-            <a:r>
-              <a:rPr lang="ko-KR" sz="1200" b="1">
-                <a:solidFill>
-                  <a:srgbClr val="FFFFFF"/>
+            <a:pPr marL="0" indent="0" algn="l">
+              <a:buNone/>
+            </a:pPr>
+            <a:r>
+              <a:rPr lang="ko-KR" sz="1150" b="1">
+                <a:solidFill>
+                  <a:srgbClr val="1D1F2B"/>
                 </a:solidFill>
                 <a:latin typeface="210 옴니고딕 050"/>
                 <a:ea typeface="210 옴니고딕 050"/>
                 <a:cs typeface="210 옴니고딕 050"/>
               </a:rPr>
-              <a:t>4  FDA 허가 범위</a:t>
-            </a:r>
-            <a:endParaRPr lang="ko-KR" sz="1200"/>
-          </a:p>
-        </p:txBody>
-      </p:sp>
-      <p:sp>
-        <p:nvSpPr>
-          <p:cNvPr id="26" name="Ev st 3"/>
-          <p:cNvSpPr txBox="1"/>
-          <p:nvPr/>
-        </p:nvSpPr>
-        <p:spPr>
-          <a:xfrm>
-            <a:off x="9980676" y="2222906"/>
-            <a:ext cx="1188720" cy="292242"/>
+              <a:t>사람 · 부분층 화상 (KeraStat Gel)</a:t>
+            </a:r>
+            <a:endParaRPr lang="ko-KR" sz="1150"/>
+          </a:p>
+        </p:txBody>
+      </p:sp>
+      <p:sp>
+        <p:nvSpPr>
+          <p:cNvPr id="48" name="D st"/>
+          <p:cNvSpPr txBox="1"/>
+          <p:nvPr/>
+        </p:nvSpPr>
+        <p:spPr>
+          <a:xfrm>
+            <a:off x="4709160" y="4079504"/>
+            <a:ext cx="1170432" cy="257861"/>
           </a:xfrm>
           <a:prstGeom prst="roundRect">
             <a:avLst>
@@ -19861,7 +20509,7 @@
             </a:avLst>
           </a:prstGeom>
           <a:solidFill>
-            <a:srgbClr val="ECEDF1"/>
+            <a:srgbClr val="FBE6EB"/>
           </a:solidFill>
           <a:ln>
             <a:noFill/>
@@ -19877,30 +20525,30 @@
               <a:buNone/>
             </a:pPr>
             <a:r>
-              <a:rPr lang="ko-KR" sz="1050" b="1">
-                <a:solidFill>
-                  <a:srgbClr val="3B3F57"/>
+              <a:rPr lang="ko-KR" sz="950" b="1">
+                <a:solidFill>
+                  <a:srgbClr val="C00A3E"/>
                 </a:solidFill>
                 <a:latin typeface="210 옴니고딕 050"/>
                 <a:ea typeface="210 옴니고딕 050"/>
                 <a:cs typeface="210 옴니고딕 050"/>
               </a:rPr>
-              <a:t>기능만 인정</a:t>
-            </a:r>
-            <a:endParaRPr lang="ko-KR" sz="1050"/>
-          </a:p>
-        </p:txBody>
-      </p:sp>
-      <p:sp>
-        <p:nvSpPr>
-          <p:cNvPr id="27" name="Ev big 3"/>
-          <p:cNvSpPr txBox="1"/>
-          <p:nvPr/>
-        </p:nvSpPr>
-        <p:spPr>
-          <a:xfrm>
-            <a:off x="9555480" y="2609698"/>
-            <a:ext cx="2039112" cy="515722"/>
+              <a:t>조기 종료</a:t>
+            </a:r>
+            <a:endParaRPr lang="ko-KR" sz="950"/>
+          </a:p>
+        </p:txBody>
+      </p:sp>
+      <p:sp>
+        <p:nvSpPr>
+          <p:cNvPr id="49" name="D cap"/>
+          <p:cNvSpPr txBox="1"/>
+          <p:nvPr/>
+        </p:nvSpPr>
+        <p:spPr>
+          <a:xfrm>
+            <a:off x="640080" y="4328770"/>
+            <a:ext cx="5212080" cy="223479"/>
           </a:xfrm>
           <a:prstGeom prst="rect">
             <a:avLst/>
@@ -19911,39 +20559,130 @@
           </a:ln>
         </p:spPr>
         <p:txBody>
+          <a:bodyPr wrap="square" lIns="0" tIns="0" rIns="0" bIns="0" anchor="t">
+            <a:noAutofit/>
+          </a:bodyPr>
+          <a:lstStyle/>
+          <a:p>
+            <a:pPr marL="0" indent="0" algn="l">
+              <a:buNone/>
+            </a:pPr>
+            <a:r>
+              <a:rPr lang="ko-KR" sz="950">
+                <a:solidFill>
+                  <a:srgbClr val="6B6E7A"/>
+                </a:solidFill>
+                <a:latin typeface="210 옴니고딕 040"/>
+                <a:ea typeface="210 옴니고딕 040"/>
+                <a:cs typeface="210 옴니고딕 040"/>
+              </a:rPr>
+              <a:t>모집 인원 (계획 대비 실제)</a:t>
+            </a:r>
+            <a:endParaRPr lang="ko-KR" sz="950"/>
+          </a:p>
+        </p:txBody>
+      </p:sp>
+      <p:sp>
+        <p:nvSpPr>
+          <p:cNvPr id="50" name="D track"/>
+          <p:cNvSpPr/>
+          <p:nvPr/>
+        </p:nvSpPr>
+        <p:spPr>
+          <a:xfrm>
+            <a:off x="640080" y="4629607"/>
+            <a:ext cx="5212080" cy="361005"/>
+          </a:xfrm>
+          <a:prstGeom prst="roundRect">
+            <a:avLst>
+              <a:gd name="adj" fmla="val 50000"/>
+            </a:avLst>
+          </a:prstGeom>
+          <a:solidFill>
+            <a:srgbClr val="EEF0F4"/>
+          </a:solidFill>
+          <a:ln>
+            <a:noFill/>
+          </a:ln>
+        </p:spPr>
+      </p:sp>
+      <p:sp>
+        <p:nvSpPr>
+          <p:cNvPr id="51" name="D bar"/>
+          <p:cNvSpPr/>
+          <p:nvPr/>
+        </p:nvSpPr>
+        <p:spPr>
+          <a:xfrm>
+            <a:off x="640080" y="4629607"/>
+            <a:ext cx="2432304" cy="361005"/>
+          </a:xfrm>
+          <a:prstGeom prst="roundRect">
+            <a:avLst>
+              <a:gd name="adj" fmla="val 50000"/>
+            </a:avLst>
+          </a:prstGeom>
+          <a:solidFill>
+            <a:srgbClr val="C00A3E"/>
+          </a:solidFill>
+          <a:ln>
+            <a:noFill/>
+          </a:ln>
+        </p:spPr>
+      </p:sp>
+      <p:sp>
+        <p:nvSpPr>
+          <p:cNvPr id="52" name="D v"/>
+          <p:cNvSpPr txBox="1"/>
+          <p:nvPr/>
+        </p:nvSpPr>
+        <p:spPr>
+          <a:xfrm>
+            <a:off x="731520" y="4629607"/>
+            <a:ext cx="2286000" cy="361005"/>
+          </a:xfrm>
+          <a:prstGeom prst="rect">
+            <a:avLst/>
+          </a:prstGeom>
+          <a:noFill/>
+          <a:ln>
+            <a:noFill/>
+          </a:ln>
+        </p:spPr>
+        <p:txBody>
           <a:bodyPr wrap="square" lIns="0" tIns="0" rIns="0" bIns="0" anchor="ctr">
             <a:noAutofit/>
           </a:bodyPr>
           <a:lstStyle/>
           <a:p>
-            <a:pPr marL="0" indent="0" algn="ctr">
-              <a:buNone/>
-            </a:pPr>
-            <a:r>
-              <a:rPr lang="ko-KR" sz="1700" b="1">
-                <a:solidFill>
-                  <a:srgbClr val="3B3F57"/>
+            <a:pPr marL="0" indent="0" algn="l">
+              <a:buNone/>
+            </a:pPr>
+            <a:r>
+              <a:rPr lang="ko-KR" sz="1200" b="1">
+                <a:solidFill>
+                  <a:srgbClr val="FFFFFF"/>
                 </a:solidFill>
                 <a:latin typeface="210 옴니고딕 050"/>
                 <a:ea typeface="210 옴니고딕 050"/>
                 <a:cs typeface="210 옴니고딕 050"/>
               </a:rPr>
-              <a:t>보호 · 흡수 · 습윤</a:t>
-            </a:r>
-            <a:endParaRPr lang="ko-KR" sz="1700"/>
-          </a:p>
-        </p:txBody>
-      </p:sp>
-      <p:sp>
-        <p:nvSpPr>
-          <p:cNvPr id="28" name="Ev lines 3"/>
-          <p:cNvSpPr txBox="1"/>
-          <p:nvPr/>
-        </p:nvSpPr>
-        <p:spPr>
-          <a:xfrm>
-            <a:off x="9646920" y="3254350"/>
-            <a:ext cx="1856232" cy="1633118"/>
+              <a:t>14명 등록 (47%)</a:t>
+            </a:r>
+            <a:endParaRPr lang="ko-KR" sz="1200"/>
+          </a:p>
+        </p:txBody>
+      </p:sp>
+      <p:sp>
+        <p:nvSpPr>
+          <p:cNvPr id="53" name="D plan"/>
+          <p:cNvSpPr txBox="1"/>
+          <p:nvPr/>
+        </p:nvSpPr>
+        <p:spPr>
+          <a:xfrm>
+            <a:off x="4389120" y="4629607"/>
+            <a:ext cx="1371600" cy="361005"/>
           </a:xfrm>
           <a:prstGeom prst="rect">
             <a:avLst/>
@@ -19954,42 +20693,550 @@
           </a:ln>
         </p:spPr>
         <p:txBody>
-          <a:bodyPr wrap="square" lIns="0" tIns="0" rIns="0" bIns="0" anchor="t">
+          <a:bodyPr wrap="square" lIns="0" tIns="0" rIns="0" bIns="0" anchor="ctr">
+            <a:noAutofit/>
+          </a:bodyPr>
+          <a:lstStyle/>
+          <a:p>
+            <a:pPr marL="0" indent="0" algn="r">
+              <a:buNone/>
+            </a:pPr>
+            <a:r>
+              <a:rPr lang="ko-KR" sz="1100" b="1">
+                <a:solidFill>
+                  <a:srgbClr val="1D1F2B"/>
+                </a:solidFill>
+                <a:latin typeface="210 옴니고딕 050"/>
+                <a:ea typeface="210 옴니고딕 050"/>
+                <a:cs typeface="210 옴니고딕 050"/>
+              </a:rPr>
+              <a:t>계획 30명</a:t>
+            </a:r>
+            <a:endParaRPr lang="ko-KR" sz="1100"/>
+          </a:p>
+        </p:txBody>
+      </p:sp>
+      <p:sp>
+        <p:nvSpPr>
+          <p:cNvPr id="54" name="D note"/>
+          <p:cNvSpPr txBox="1"/>
+          <p:nvPr/>
+        </p:nvSpPr>
+        <p:spPr>
+          <a:xfrm>
+            <a:off x="640080" y="5102352"/>
+            <a:ext cx="5212080" cy="472745"/>
+          </a:xfrm>
+          <a:prstGeom prst="rect">
+            <a:avLst/>
+          </a:prstGeom>
+          <a:noFill/>
+          <a:ln>
+            <a:noFill/>
+          </a:ln>
+        </p:spPr>
+        <p:txBody>
+          <a:bodyPr wrap="square" lIns="0" tIns="0" rIns="0" bIns="0" anchor="ctr">
+            <a:noAutofit/>
+          </a:bodyPr>
+          <a:lstStyle/>
+          <a:p>
+            <a:pPr marL="0" indent="0" algn="l">
+              <a:buNone/>
+            </a:pPr>
+            <a:r>
+              <a:rPr lang="ko-KR" sz="1050" b="1">
+                <a:solidFill>
+                  <a:srgbClr val="C00A3E"/>
+                </a:solidFill>
+                <a:latin typeface="210 옴니고딕 050"/>
+                <a:ea typeface="210 옴니고딕 050"/>
+                <a:cs typeface="210 옴니고딕 050"/>
+              </a:rPr>
+              <a:t>모집 부진으로 종료 → 유효성 판단에 필요한 표본 부족</a:t>
+            </a:r>
+            <a:endParaRPr lang="ko-KR" sz="1050"/>
+          </a:p>
+        </p:txBody>
+      </p:sp>
+      <p:sp>
+        <p:nvSpPr>
+          <p:cNvPr id="55" name="E"/>
+          <p:cNvSpPr/>
+          <p:nvPr/>
+        </p:nvSpPr>
+        <p:spPr>
+          <a:xfrm>
+            <a:off x="6126480" y="3984955"/>
+            <a:ext cx="5559552" cy="1701881"/>
+          </a:xfrm>
+          <a:prstGeom prst="roundRect">
+            <a:avLst>
+              <a:gd name="adj" fmla="val 4000"/>
+            </a:avLst>
+          </a:prstGeom>
+          <a:solidFill>
+            <a:srgbClr val="FFFFFF"/>
+          </a:solidFill>
+          <a:ln w="9525">
+            <a:solidFill>
+              <a:srgbClr val="D5D8E0"/>
+            </a:solidFill>
+          </a:ln>
+        </p:spPr>
+      </p:sp>
+      <p:sp>
+        <p:nvSpPr>
+          <p:cNvPr id="56" name="E t"/>
+          <p:cNvSpPr txBox="1"/>
+          <p:nvPr/>
+        </p:nvSpPr>
+        <p:spPr>
+          <a:xfrm>
+            <a:off x="6263640" y="4053718"/>
+            <a:ext cx="5285232" cy="292242"/>
+          </a:xfrm>
+          <a:prstGeom prst="rect">
+            <a:avLst/>
+          </a:prstGeom>
+          <a:noFill/>
+          <a:ln>
+            <a:noFill/>
+          </a:ln>
+        </p:spPr>
+        <p:txBody>
+          <a:bodyPr wrap="square" lIns="0" tIns="0" rIns="0" bIns="0" anchor="ctr">
+            <a:noAutofit/>
+          </a:bodyPr>
+          <a:lstStyle/>
+          <a:p>
+            <a:pPr marL="0" indent="0" algn="l">
+              <a:buNone/>
+            </a:pPr>
+            <a:r>
+              <a:rPr lang="ko-KR" sz="1150" b="1">
+                <a:solidFill>
+                  <a:srgbClr val="1D1F2B"/>
+                </a:solidFill>
+                <a:latin typeface="210 옴니고딕 050"/>
+                <a:ea typeface="210 옴니고딕 050"/>
+                <a:cs typeface="210 옴니고딕 050"/>
+              </a:rPr>
+              <a:t>그 외 근거</a:t>
+            </a:r>
+            <a:endParaRPr lang="ko-KR" sz="1150"/>
+          </a:p>
+        </p:txBody>
+      </p:sp>
+      <p:sp>
+        <p:nvSpPr>
+          <p:cNvPr id="57" name="E st 0"/>
+          <p:cNvSpPr txBox="1"/>
+          <p:nvPr/>
+        </p:nvSpPr>
+        <p:spPr>
+          <a:xfrm>
+            <a:off x="6263640" y="4449105"/>
+            <a:ext cx="960120" cy="257861"/>
+          </a:xfrm>
+          <a:prstGeom prst="roundRect">
+            <a:avLst>
+              <a:gd name="adj" fmla="val 16000"/>
+            </a:avLst>
+          </a:prstGeom>
+          <a:solidFill>
+            <a:srgbClr val="E6E9F5"/>
+          </a:solidFill>
+          <a:ln>
+            <a:noFill/>
+          </a:ln>
+        </p:spPr>
+        <p:txBody>
+          <a:bodyPr wrap="square" lIns="36576" tIns="18288" rIns="36576" bIns="18288" anchor="ctr">
             <a:noAutofit/>
           </a:bodyPr>
           <a:lstStyle/>
           <a:p>
             <a:pPr marL="0" indent="0" algn="ctr">
-              <a:spcAft>
-                <a:spcPts val="700"/>
-              </a:spcAft>
-              <a:buNone/>
-            </a:pPr>
-            <a:r>
-              <a:rPr lang="ko-KR" sz="1200">
-                <a:solidFill>
-                  <a:srgbClr val="3B3B3B"/>
+              <a:buNone/>
+            </a:pPr>
+            <a:r>
+              <a:rPr lang="ko-KR" sz="900" b="1">
+                <a:solidFill>
+                  <a:srgbClr val="102290"/>
+                </a:solidFill>
+                <a:latin typeface="210 옴니고딕 050"/>
+                <a:ea typeface="210 옴니고딕 050"/>
+                <a:cs typeface="210 옴니고딕 050"/>
+              </a:rPr>
+              <a:t>신호 있음</a:t>
+            </a:r>
+            <a:endParaRPr lang="ko-KR" sz="900"/>
+          </a:p>
+        </p:txBody>
+      </p:sp>
+      <p:sp>
+        <p:nvSpPr>
+          <p:cNvPr id="58" name="E h 0"/>
+          <p:cNvSpPr txBox="1"/>
+          <p:nvPr/>
+        </p:nvSpPr>
+        <p:spPr>
+          <a:xfrm>
+            <a:off x="7315200" y="4397532"/>
+            <a:ext cx="1600200" cy="361005"/>
+          </a:xfrm>
+          <a:prstGeom prst="rect">
+            <a:avLst/>
+          </a:prstGeom>
+          <a:noFill/>
+          <a:ln>
+            <a:noFill/>
+          </a:ln>
+        </p:spPr>
+        <p:txBody>
+          <a:bodyPr wrap="square" lIns="0" tIns="0" rIns="0" bIns="0" anchor="ctr">
+            <a:noAutofit/>
+          </a:bodyPr>
+          <a:lstStyle/>
+          <a:p>
+            <a:pPr marL="0" indent="0" algn="l">
+              <a:buNone/>
+            </a:pPr>
+            <a:r>
+              <a:rPr lang="ko-KR" sz="1050" b="1">
+                <a:solidFill>
+                  <a:srgbClr val="1D1F2B"/>
+                </a:solidFill>
+                <a:latin typeface="210 옴니고딕 050"/>
+                <a:ea typeface="210 옴니고딕 050"/>
+                <a:cs typeface="210 옴니고딕 050"/>
+              </a:rPr>
+              <a:t>세포 실험</a:t>
+            </a:r>
+            <a:endParaRPr lang="ko-KR" sz="1050"/>
+          </a:p>
+        </p:txBody>
+      </p:sp>
+      <p:sp>
+        <p:nvSpPr>
+          <p:cNvPr id="59" name="E b 0"/>
+          <p:cNvSpPr txBox="1"/>
+          <p:nvPr/>
+        </p:nvSpPr>
+        <p:spPr>
+          <a:xfrm>
+            <a:off x="8915400" y="4397532"/>
+            <a:ext cx="2679192" cy="361005"/>
+          </a:xfrm>
+          <a:prstGeom prst="rect">
+            <a:avLst/>
+          </a:prstGeom>
+          <a:noFill/>
+          <a:ln>
+            <a:noFill/>
+          </a:ln>
+        </p:spPr>
+        <p:txBody>
+          <a:bodyPr wrap="square" lIns="0" tIns="0" rIns="0" bIns="0" anchor="ctr">
+            <a:noAutofit/>
+          </a:bodyPr>
+          <a:lstStyle/>
+          <a:p>
+            <a:pPr marL="0" indent="0" algn="l">
+              <a:buNone/>
+            </a:pPr>
+            <a:r>
+              <a:rPr lang="ko-KR" sz="950">
+                <a:solidFill>
+                  <a:srgbClr val="6B6E7A"/>
                 </a:solidFill>
                 <a:latin typeface="210 옴니고딕 040"/>
                 <a:ea typeface="210 옴니고딕 040"/>
                 <a:cs typeface="210 옴니고딕 040"/>
               </a:rPr>
-              <a:t>KeraStat 510(k)의 인정 작용</a:t>
-            </a:r>
-            <a:endParaRPr lang="ko-KR" sz="1200"/>
-          </a:p>
-        </p:txBody>
-      </p:sp>
-      <p:sp>
-        <p:nvSpPr>
-          <p:cNvPr id="29" name="Ev cav 3"/>
-          <p:cNvSpPr txBox="1"/>
-          <p:nvPr/>
-        </p:nvSpPr>
-        <p:spPr>
-          <a:xfrm>
-            <a:off x="9601200" y="4930445"/>
-            <a:ext cx="1947672" cy="601675"/>
+              <a:t>열 손상 세포 생존 개선 · 염증 줄이는 면역세포(M2) 반응</a:t>
+            </a:r>
+            <a:endParaRPr lang="ko-KR" sz="950"/>
+          </a:p>
+        </p:txBody>
+      </p:sp>
+      <p:sp>
+        <p:nvSpPr>
+          <p:cNvPr id="60" name="E st 1"/>
+          <p:cNvSpPr txBox="1"/>
+          <p:nvPr/>
+        </p:nvSpPr>
+        <p:spPr>
+          <a:xfrm>
+            <a:off x="6263640" y="4861682"/>
+            <a:ext cx="960120" cy="257861"/>
+          </a:xfrm>
+          <a:prstGeom prst="roundRect">
+            <a:avLst>
+              <a:gd name="adj" fmla="val 16000"/>
+            </a:avLst>
+          </a:prstGeom>
+          <a:solidFill>
+            <a:srgbClr val="FBE6EB"/>
+          </a:solidFill>
+          <a:ln>
+            <a:noFill/>
+          </a:ln>
+        </p:spPr>
+        <p:txBody>
+          <a:bodyPr wrap="square" lIns="36576" tIns="18288" rIns="36576" bIns="18288" anchor="ctr">
+            <a:noAutofit/>
+          </a:bodyPr>
+          <a:lstStyle/>
+          <a:p>
+            <a:pPr marL="0" indent="0" algn="ctr">
+              <a:buNone/>
+            </a:pPr>
+            <a:r>
+              <a:rPr lang="ko-KR" sz="900" b="1">
+                <a:solidFill>
+                  <a:srgbClr val="C00A3E"/>
+                </a:solidFill>
+                <a:latin typeface="210 옴니고딕 050"/>
+                <a:ea typeface="210 옴니고딕 050"/>
+                <a:cs typeface="210 옴니고딕 050"/>
+              </a:rPr>
+              <a:t>차이 없음</a:t>
+            </a:r>
+            <a:endParaRPr lang="ko-KR" sz="900"/>
+          </a:p>
+        </p:txBody>
+      </p:sp>
+      <p:sp>
+        <p:nvSpPr>
+          <p:cNvPr id="61" name="E h 1"/>
+          <p:cNvSpPr txBox="1"/>
+          <p:nvPr/>
+        </p:nvSpPr>
+        <p:spPr>
+          <a:xfrm>
+            <a:off x="7315200" y="4810110"/>
+            <a:ext cx="1600200" cy="361005"/>
+          </a:xfrm>
+          <a:prstGeom prst="rect">
+            <a:avLst/>
+          </a:prstGeom>
+          <a:noFill/>
+          <a:ln>
+            <a:noFill/>
+          </a:ln>
+        </p:spPr>
+        <p:txBody>
+          <a:bodyPr wrap="square" lIns="0" tIns="0" rIns="0" bIns="0" anchor="ctr">
+            <a:noAutofit/>
+          </a:bodyPr>
+          <a:lstStyle/>
+          <a:p>
+            <a:pPr marL="0" indent="0" algn="l">
+              <a:buNone/>
+            </a:pPr>
+            <a:r>
+              <a:rPr lang="ko-KR" sz="1050" b="1">
+                <a:solidFill>
+                  <a:srgbClr val="1D1F2B"/>
+                </a:solidFill>
+                <a:latin typeface="210 옴니고딕 050"/>
+                <a:ea typeface="210 옴니고딕 050"/>
+                <a:cs typeface="210 옴니고딕 050"/>
+              </a:rPr>
+              <a:t>두경부 방사선피부염</a:t>
+            </a:r>
+            <a:endParaRPr lang="ko-KR" sz="1050"/>
+          </a:p>
+        </p:txBody>
+      </p:sp>
+      <p:sp>
+        <p:nvSpPr>
+          <p:cNvPr id="62" name="E b 1"/>
+          <p:cNvSpPr txBox="1"/>
+          <p:nvPr/>
+        </p:nvSpPr>
+        <p:spPr>
+          <a:xfrm>
+            <a:off x="8915400" y="4810110"/>
+            <a:ext cx="2679192" cy="361005"/>
+          </a:xfrm>
+          <a:prstGeom prst="rect">
+            <a:avLst/>
+          </a:prstGeom>
+          <a:noFill/>
+          <a:ln>
+            <a:noFill/>
+          </a:ln>
+        </p:spPr>
+        <p:txBody>
+          <a:bodyPr wrap="square" lIns="0" tIns="0" rIns="0" bIns="0" anchor="ctr">
+            <a:noAutofit/>
+          </a:bodyPr>
+          <a:lstStyle/>
+          <a:p>
+            <a:pPr marL="0" indent="0" algn="l">
+              <a:buNone/>
+            </a:pPr>
+            <a:r>
+              <a:rPr lang="ko-KR" sz="950">
+                <a:solidFill>
+                  <a:srgbClr val="6B6E7A"/>
+                </a:solidFill>
+                <a:latin typeface="210 옴니고딕 040"/>
+                <a:ea typeface="210 옴니고딕 040"/>
+                <a:cs typeface="210 옴니고딕 040"/>
+              </a:rPr>
+              <a:t>KeraStat Cream vs 표준관리 · 24명</a:t>
+            </a:r>
+            <a:endParaRPr lang="ko-KR" sz="950"/>
+          </a:p>
+        </p:txBody>
+      </p:sp>
+      <p:sp>
+        <p:nvSpPr>
+          <p:cNvPr id="63" name="E st 2"/>
+          <p:cNvSpPr txBox="1"/>
+          <p:nvPr/>
+        </p:nvSpPr>
+        <p:spPr>
+          <a:xfrm>
+            <a:off x="6263640" y="5274259"/>
+            <a:ext cx="960120" cy="257861"/>
+          </a:xfrm>
+          <a:prstGeom prst="roundRect">
+            <a:avLst>
+              <a:gd name="adj" fmla="val 16000"/>
+            </a:avLst>
+          </a:prstGeom>
+          <a:solidFill>
+            <a:srgbClr val="ECEDF1"/>
+          </a:solidFill>
+          <a:ln>
+            <a:noFill/>
+          </a:ln>
+        </p:spPr>
+        <p:txBody>
+          <a:bodyPr wrap="square" lIns="36576" tIns="18288" rIns="36576" bIns="18288" anchor="ctr">
+            <a:noAutofit/>
+          </a:bodyPr>
+          <a:lstStyle/>
+          <a:p>
+            <a:pPr marL="0" indent="0" algn="ctr">
+              <a:buNone/>
+            </a:pPr>
+            <a:r>
+              <a:rPr lang="ko-KR" sz="900" b="1">
+                <a:solidFill>
+                  <a:srgbClr val="3B3F57"/>
+                </a:solidFill>
+                <a:latin typeface="210 옴니고딕 050"/>
+                <a:ea typeface="210 옴니고딕 050"/>
+                <a:cs typeface="210 옴니고딕 050"/>
+              </a:rPr>
+              <a:t>기능만</a:t>
+            </a:r>
+            <a:endParaRPr lang="ko-KR" sz="900"/>
+          </a:p>
+        </p:txBody>
+      </p:sp>
+      <p:sp>
+        <p:nvSpPr>
+          <p:cNvPr id="64" name="E h 2"/>
+          <p:cNvSpPr txBox="1"/>
+          <p:nvPr/>
+        </p:nvSpPr>
+        <p:spPr>
+          <a:xfrm>
+            <a:off x="7315200" y="5222687"/>
+            <a:ext cx="1600200" cy="361005"/>
+          </a:xfrm>
+          <a:prstGeom prst="rect">
+            <a:avLst/>
+          </a:prstGeom>
+          <a:noFill/>
+          <a:ln>
+            <a:noFill/>
+          </a:ln>
+        </p:spPr>
+        <p:txBody>
+          <a:bodyPr wrap="square" lIns="0" tIns="0" rIns="0" bIns="0" anchor="ctr">
+            <a:noAutofit/>
+          </a:bodyPr>
+          <a:lstStyle/>
+          <a:p>
+            <a:pPr marL="0" indent="0" algn="l">
+              <a:buNone/>
+            </a:pPr>
+            <a:r>
+              <a:rPr lang="ko-KR" sz="1050" b="1">
+                <a:solidFill>
+                  <a:srgbClr val="1D1F2B"/>
+                </a:solidFill>
+                <a:latin typeface="210 옴니고딕 050"/>
+                <a:ea typeface="210 옴니고딕 050"/>
+                <a:cs typeface="210 옴니고딕 050"/>
+              </a:rPr>
+              <a:t>FDA 인정 작용</a:t>
+            </a:r>
+            <a:endParaRPr lang="ko-KR" sz="1050"/>
+          </a:p>
+        </p:txBody>
+      </p:sp>
+      <p:sp>
+        <p:nvSpPr>
+          <p:cNvPr id="65" name="E b 2"/>
+          <p:cNvSpPr txBox="1"/>
+          <p:nvPr/>
+        </p:nvSpPr>
+        <p:spPr>
+          <a:xfrm>
+            <a:off x="8915400" y="5222687"/>
+            <a:ext cx="2679192" cy="361005"/>
+          </a:xfrm>
+          <a:prstGeom prst="rect">
+            <a:avLst/>
+          </a:prstGeom>
+          <a:noFill/>
+          <a:ln>
+            <a:noFill/>
+          </a:ln>
+        </p:spPr>
+        <p:txBody>
+          <a:bodyPr wrap="square" lIns="0" tIns="0" rIns="0" bIns="0" anchor="ctr">
+            <a:noAutofit/>
+          </a:bodyPr>
+          <a:lstStyle/>
+          <a:p>
+            <a:pPr marL="0" indent="0" algn="l">
+              <a:buNone/>
+            </a:pPr>
+            <a:r>
+              <a:rPr lang="ko-KR" sz="950">
+                <a:solidFill>
+                  <a:srgbClr val="6B6E7A"/>
+                </a:solidFill>
+                <a:latin typeface="210 옴니고딕 040"/>
+                <a:ea typeface="210 옴니고딕 040"/>
+                <a:cs typeface="210 옴니고딕 040"/>
+              </a:rPr>
+              <a:t>보호 · 흡수 · 습윤환경 — 약효(재생 촉진) 인정 아님</a:t>
+            </a:r>
+            <a:endParaRPr lang="ko-KR" sz="950"/>
+          </a:p>
+        </p:txBody>
+      </p:sp>
+      <p:sp>
+        <p:nvSpPr>
+          <p:cNvPr id="66" name="Key box"/>
+          <p:cNvSpPr/>
+          <p:nvPr/>
+        </p:nvSpPr>
+        <p:spPr>
+          <a:xfrm>
+            <a:off x="502920" y="5807172"/>
+            <a:ext cx="11183112" cy="429768"/>
           </a:xfrm>
           <a:prstGeom prst="roundRect">
             <a:avLst>
@@ -19997,53 +21244,6 @@
             </a:avLst>
           </a:prstGeom>
           <a:solidFill>
-            <a:srgbClr val="FBE6EB"/>
-          </a:solidFill>
-          <a:ln>
-            <a:noFill/>
-          </a:ln>
-        </p:spPr>
-        <p:txBody>
-          <a:bodyPr wrap="square" lIns="45720" tIns="27432" rIns="45720" bIns="27432" anchor="ctr">
-            <a:noAutofit/>
-          </a:bodyPr>
-          <a:lstStyle/>
-          <a:p>
-            <a:pPr marL="0" indent="0" algn="ctr">
-              <a:buNone/>
-            </a:pPr>
-            <a:r>
-              <a:rPr lang="ko-KR" sz="1000" b="1">
-                <a:solidFill>
-                  <a:srgbClr val="C00A3E"/>
-                </a:solidFill>
-                <a:latin typeface="210 옴니고딕 050"/>
-                <a:ea typeface="210 옴니고딕 050"/>
-                <a:cs typeface="210 옴니고딕 050"/>
-              </a:rPr>
-              <a:t>피부 재생 촉진 등 약효 인정 아님</a:t>
-            </a:r>
-            <a:endParaRPr lang="ko-KR" sz="1000"/>
-          </a:p>
-        </p:txBody>
-      </p:sp>
-      <p:sp>
-        <p:nvSpPr>
-          <p:cNvPr id="30" name="Key box"/>
-          <p:cNvSpPr/>
-          <p:nvPr/>
-        </p:nvSpPr>
-        <p:spPr>
-          <a:xfrm>
-            <a:off x="502920" y="5807172"/>
-            <a:ext cx="11183112" cy="429768"/>
-          </a:xfrm>
-          <a:prstGeom prst="roundRect">
-            <a:avLst>
-              <a:gd name="adj" fmla="val 12000"/>
-            </a:avLst>
-          </a:prstGeom>
-          <a:solidFill>
             <a:srgbClr val="E6E9F5"/>
           </a:solidFill>
           <a:ln>
@@ -20053,7 +21253,7 @@
       </p:sp>
       <p:sp>
         <p:nvSpPr>
-          <p:cNvPr id="31" name="Key label"/>
+          <p:cNvPr id="67" name="Key label"/>
           <p:cNvSpPr txBox="1"/>
           <p:nvPr/>
         </p:nvSpPr>
@@ -20100,7 +21300,7 @@
       </p:sp>
       <p:sp>
         <p:nvSpPr>
-          <p:cNvPr id="32" name="Key text"/>
+          <p:cNvPr id="68" name="Key text"/>
           <p:cNvSpPr txBox="1"/>
           <p:nvPr/>
         </p:nvSpPr>
@@ -20143,7 +21343,7 @@
       </p:sp>
       <p:sp>
         <p:nvSpPr>
-          <p:cNvPr id="33" name="Sources"/>
+          <p:cNvPr id="69" name="Sources"/>
           <p:cNvSpPr txBox="1"/>
           <p:nvPr/>
         </p:nvSpPr>
@@ -36995,19 +38195,19 @@
         </p:nvGraphicFramePr>
         <p:xfrm>
           <a:off x="502920" y="1664208"/>
-          <a:ext cx="11183112" cy="3610051"/>
+          <a:ext cx="11183112" cy="3137306"/>
         </p:xfrm>
         <a:graphic>
           <a:graphicData uri="http://schemas.openxmlformats.org/drawingml/2006/table">
             <a:tbl>
               <a:tblPr firstRow="1"/>
               <a:tblGrid>
-                <a:gridCol w="1097280"/>
-                <a:gridCol w="2834640"/>
-                <a:gridCol w="3154680"/>
-                <a:gridCol w="1783080"/>
-                <a:gridCol w="1216152"/>
-                <a:gridCol w="1097280"/>
+                <a:gridCol w="960120"/>
+                <a:gridCol w="3520440"/>
+                <a:gridCol w="2743200"/>
+                <a:gridCol w="1691640"/>
+                <a:gridCol w="1261872"/>
+                <a:gridCol w="1005840"/>
               </a:tblGrid>
               <a:tr h="309433">
                 <a:tc>
@@ -37275,7 +38475,7 @@
                   </a:tcPr>
                 </a:tc>
               </a:tr>
-              <a:tr h="412577">
+              <a:tr h="403982">
                 <a:tc rowSpan="3">
                   <a:txBody>
                     <a:bodyPr/>
@@ -37346,7 +38546,7 @@
                         <a:buNone/>
                       </a:pPr>
                       <a:r>
-                        <a:rPr lang="ko-KR" sz="1050" b="1">
+                        <a:rPr lang="ko-KR" sz="1000" b="1">
                           <a:solidFill>
                             <a:srgbClr val="C00A3E"/>
                           </a:solidFill>
@@ -37354,16 +38554,16 @@
                           <a:ea typeface="210 옴니고딕 050"/>
                           <a:cs typeface="210 옴니고딕 050"/>
                         </a:rPr>
-                        <a:t>해외규격인증획득지원 (일반 3차)</a:t>
+                        <a:t>2026년 해외규격인증획득 지원사업 (3차)</a:t>
                       </a:r>
-                      <a:endParaRPr lang="ko-KR" sz="1050"/>
+                      <a:endParaRPr lang="ko-KR" sz="1000"/>
                     </a:p>
                     <a:p>
                       <a:pPr marL="0" indent="0" algn="l">
                         <a:buNone/>
                       </a:pPr>
                       <a:r>
-                        <a:rPr lang="ko-KR" sz="850">
+                        <a:rPr lang="ko-KR" sz="800">
                           <a:solidFill>
                             <a:srgbClr val="6B6E7A"/>
                           </a:solidFill>
@@ -37371,12 +38571,12 @@
                           <a:ea typeface="210 옴니고딕 040"/>
                           <a:cs typeface="210 옴니고딕 040"/>
                         </a:rPr>
-                        <a:t>중기부 · KTR</a:t>
+                        <a:t>중소벤처기업부 · 해외규격인증획득지원센터</a:t>
                       </a:r>
-                      <a:endParaRPr lang="ko-KR" sz="850"/>
+                      <a:endParaRPr lang="ko-KR" sz="800"/>
                     </a:p>
                   </a:txBody>
-                  <a:tcPr marL="64008" marR="45720" marT="27432" marB="27432" anchor="ctr">
+                  <a:tcPr marL="64008" marR="45720" marT="9144" marB="9144" anchor="ctr">
                     <a:lnL w="0">
                       <a:noFill/>
                     </a:lnL>
@@ -37415,7 +38615,7 @@
                           <a:ea typeface="210 옴니고딕 040"/>
                           <a:cs typeface="210 옴니고딕 040"/>
                         </a:rPr>
-                        <a:t>해외 인증 · 시험 · 컨설팅 50~70% (환자 임상비 제외)</a:t>
+                        <a:t>해외 인증 · 시험 · 컨설팅 비용 50~70% (환자 임상비 제외)</a:t>
                       </a:r>
                       <a:endParaRPr lang="ko-KR" sz="950"/>
                     </a:p>
@@ -37459,7 +38659,7 @@
                           <a:ea typeface="210 옴니고딕 050"/>
                           <a:cs typeface="210 옴니고딕 050"/>
                         </a:rPr>
-                        <a:t>최대 1억 · 지정 인증 1.5억</a:t>
+                        <a:t>최대 1억 · 의료기기 1.5억</a:t>
                       </a:r>
                       <a:endParaRPr lang="ko-KR" sz="950"/>
                     </a:p>
@@ -37503,7 +38703,7 @@
                           <a:ea typeface="210 옴니고딕 050"/>
                           <a:cs typeface="210 옴니고딕 050"/>
                         </a:rPr>
-                        <a:t>~11.13 접수 중</a:t>
+                        <a:t>10.14~11.13 접수 중 (마감일 원문 확인)</a:t>
                       </a:r>
                       <a:endParaRPr lang="ko-KR" sz="950"/>
                     </a:p>
@@ -37575,7 +38775,7 @@
                   </a:tcPr>
                 </a:tc>
               </a:tr>
-              <a:tr h="412577">
+              <a:tr h="403982">
                 <a:tc vMerge="1">
                   <a:txBody>
                     <a:bodyPr/>
@@ -37595,7 +38795,7 @@
                         <a:buNone/>
                       </a:pPr>
                       <a:r>
-                        <a:rPr lang="ko-KR" sz="1050" b="1">
+                        <a:rPr lang="ko-KR" sz="1000" b="1">
                           <a:solidFill>
                             <a:srgbClr val="1D1F2B"/>
                           </a:solidFill>
@@ -37603,16 +38803,16 @@
                           <a:ea typeface="210 옴니고딕 050"/>
                           <a:cs typeface="210 옴니고딕 050"/>
                         </a:rPr>
-                        <a:t>FDA 중소기업 인정 (SBD)</a:t>
+                        <a:t>FDA Small Business Determination (SBD)</a:t>
                       </a:r>
-                      <a:endParaRPr lang="ko-KR" sz="1050"/>
+                      <a:endParaRPr lang="ko-KR" sz="1000"/>
                     </a:p>
                     <a:p>
                       <a:pPr marL="0" indent="0" algn="l">
                         <a:buNone/>
                       </a:pPr>
                       <a:r>
-                        <a:rPr lang="ko-KR" sz="850">
+                        <a:rPr lang="ko-KR" sz="800">
                           <a:solidFill>
                             <a:srgbClr val="6B6E7A"/>
                           </a:solidFill>
@@ -37620,12 +38820,12 @@
                           <a:ea typeface="210 옴니고딕 040"/>
                           <a:cs typeface="210 옴니고딕 040"/>
                         </a:rPr>
-                        <a:t>FDA</a:t>
+                        <a:t>미국 FDA</a:t>
                       </a:r>
-                      <a:endParaRPr lang="ko-KR" sz="850"/>
+                      <a:endParaRPr lang="ko-KR" sz="800"/>
                     </a:p>
                   </a:txBody>
-                  <a:tcPr marL="64008" marR="45720" marT="27432" marB="27432" anchor="ctr">
+                  <a:tcPr marL="64008" marR="45720" marT="9144" marB="9144" anchor="ctr">
                     <a:lnL w="0">
                       <a:noFill/>
                     </a:lnL>
@@ -37816,7 +39016,7 @@
                   </a:tcPr>
                 </a:tc>
               </a:tr>
-              <a:tr h="412577">
+              <a:tr h="403982">
                 <a:tc vMerge="1">
                   <a:txBody>
                     <a:bodyPr/>
@@ -37836,7 +39036,7 @@
                         <a:buNone/>
                       </a:pPr>
                       <a:r>
-                        <a:rPr lang="ko-KR" sz="1050" b="1">
+                        <a:rPr lang="ko-KR" sz="1000" b="1">
                           <a:solidFill>
                             <a:srgbClr val="1D1F2B"/>
                           </a:solidFill>
@@ -37844,16 +39044,16 @@
                           <a:ea typeface="210 옴니고딕 050"/>
                           <a:cs typeface="210 옴니고딕 050"/>
                         </a:rPr>
-                        <a:t>FDA 사전상담 (Pre-Sub)</a:t>
+                        <a:t>FDA Q-Submission (Pre-Sub)</a:t>
                       </a:r>
-                      <a:endParaRPr lang="ko-KR" sz="1050"/>
+                      <a:endParaRPr lang="ko-KR" sz="1000"/>
                     </a:p>
                     <a:p>
                       <a:pPr marL="0" indent="0" algn="l">
                         <a:buNone/>
                       </a:pPr>
                       <a:r>
-                        <a:rPr lang="ko-KR" sz="850">
+                        <a:rPr lang="ko-KR" sz="800">
                           <a:solidFill>
                             <a:srgbClr val="6B6E7A"/>
                           </a:solidFill>
@@ -37861,12 +39061,12 @@
                           <a:ea typeface="210 옴니고딕 040"/>
                           <a:cs typeface="210 옴니고딕 040"/>
                         </a:rPr>
-                        <a:t>FDA</a:t>
+                        <a:t>미국 FDA</a:t>
                       </a:r>
-                      <a:endParaRPr lang="ko-KR" sz="850"/>
+                      <a:endParaRPr lang="ko-KR" sz="800"/>
                     </a:p>
                   </a:txBody>
-                  <a:tcPr marL="64008" marR="45720" marT="27432" marB="27432" anchor="ctr">
+                  <a:tcPr marL="64008" marR="45720" marT="9144" marB="9144" anchor="ctr">
                     <a:lnL w="0">
                       <a:noFill/>
                     </a:lnL>
@@ -38057,8 +39257,8 @@
                   </a:tcPr>
                 </a:tc>
               </a:tr>
-              <a:tr h="412577">
-                <a:tc rowSpan="4">
+              <a:tr h="403982">
+                <a:tc rowSpan="3">
                   <a:txBody>
                     <a:bodyPr/>
                     <a:lstStyle/>
@@ -38128,7 +39328,7 @@
                         <a:buNone/>
                       </a:pPr>
                       <a:r>
-                        <a:rPr lang="ko-KR" sz="1050" b="1">
+                        <a:rPr lang="ko-KR" sz="1000" b="1">
                           <a:solidFill>
                             <a:srgbClr val="1D1F2B"/>
                           </a:solidFill>
@@ -38136,16 +39336,16 @@
                           <a:ea typeface="210 옴니고딕 050"/>
                           <a:cs typeface="210 옴니고딕 050"/>
                         </a:rPr>
-                        <a:t>범부처 첨단 의료기기 R&amp;D — 임상시험 지원</a:t>
+                        <a:t>범부처 첨단 의료기기 연구개발사업</a:t>
                       </a:r>
-                      <a:endParaRPr lang="ko-KR" sz="1050"/>
+                      <a:endParaRPr lang="ko-KR" sz="1000"/>
                     </a:p>
                     <a:p>
                       <a:pPr marL="0" indent="0" algn="l">
                         <a:buNone/>
                       </a:pPr>
                       <a:r>
-                        <a:rPr lang="ko-KR" sz="850">
+                        <a:rPr lang="ko-KR" sz="800">
                           <a:solidFill>
                             <a:srgbClr val="6B6E7A"/>
                           </a:solidFill>
@@ -38153,12 +39353,12 @@
                           <a:ea typeface="210 옴니고딕 040"/>
                           <a:cs typeface="210 옴니고딕 040"/>
                         </a:rPr>
-                        <a:t>KMDF</a:t>
+                        <a:t>KMDF · 내역: 의료현장 진입 역량 강화 (임상 · 규제과학)</a:t>
                       </a:r>
-                      <a:endParaRPr lang="ko-KR" sz="850"/>
+                      <a:endParaRPr lang="ko-KR" sz="800"/>
                     </a:p>
                   </a:txBody>
-                  <a:tcPr marL="64008" marR="45720" marT="27432" marB="27432" anchor="ctr">
+                  <a:tcPr marL="64008" marR="45720" marT="9144" marB="9144" anchor="ctr">
                     <a:lnL w="0">
                       <a:noFill/>
                     </a:lnL>
@@ -38279,7 +39479,7 @@
                           <a:ea typeface="210 옴니고딕 040"/>
                           <a:cs typeface="210 옴니고딕 040"/>
                         </a:rPr>
-                        <a:t>연초 공고 예상</a:t>
+                        <a:t>2026: 1차 2.19~3.9 · 2차 6.9~6.29 마감</a:t>
                       </a:r>
                       <a:endParaRPr lang="ko-KR" sz="950"/>
                     </a:p>
@@ -38349,7 +39549,7 @@
                   </a:tcPr>
                 </a:tc>
               </a:tr>
-              <a:tr h="412577">
+              <a:tr h="403982">
                 <a:tc vMerge="1">
                   <a:txBody>
                     <a:bodyPr/>
@@ -38369,7 +39569,7 @@
                         <a:buNone/>
                       </a:pPr>
                       <a:r>
-                        <a:rPr lang="ko-KR" sz="1050" b="1">
+                        <a:rPr lang="ko-KR" sz="1000" b="1">
                           <a:solidFill>
                             <a:srgbClr val="1D1F2B"/>
                           </a:solidFill>
@@ -38377,16 +39577,16 @@
                           <a:ea typeface="210 옴니고딕 050"/>
                           <a:cs typeface="210 옴니고딕 050"/>
                         </a:rPr>
-                        <a:t>글로벌 규제 대응 비용지원</a:t>
+                        <a:t>2026년 글로벌 규제 대응 비용 지원 사업 (의료기기)</a:t>
                       </a:r>
-                      <a:endParaRPr lang="ko-KR" sz="1050"/>
+                      <a:endParaRPr lang="ko-KR" sz="1000"/>
                     </a:p>
                     <a:p>
                       <a:pPr marL="0" indent="0" algn="l">
                         <a:buNone/>
                       </a:pPr>
                       <a:r>
-                        <a:rPr lang="ko-KR" sz="850">
+                        <a:rPr lang="ko-KR" sz="800">
                           <a:solidFill>
                             <a:srgbClr val="6B6E7A"/>
                           </a:solidFill>
@@ -38394,12 +39594,12 @@
                           <a:ea typeface="210 옴니고딕 040"/>
                           <a:cs typeface="210 옴니고딕 040"/>
                         </a:rPr>
-                        <a:t>복지부 · KHIDI</a:t>
+                        <a:t>보건복지부 · KHIDI · K-VIP</a:t>
                       </a:r>
-                      <a:endParaRPr lang="ko-KR" sz="850"/>
+                      <a:endParaRPr lang="ko-KR" sz="800"/>
                     </a:p>
                   </a:txBody>
-                  <a:tcPr marL="64008" marR="45720" marT="27432" marB="27432" anchor="ctr">
+                  <a:tcPr marL="64008" marR="45720" marT="9144" marB="9144" anchor="ctr">
                     <a:lnL w="0">
                       <a:noFill/>
                     </a:lnL>
@@ -38436,7 +39636,7 @@
                           <a:ea typeface="210 옴니고딕 040"/>
                           <a:cs typeface="210 옴니고딕 040"/>
                         </a:rPr>
-                        <a:t>해외 인허가 · 시험 · 임상비 일부</a:t>
+                        <a:t>FDA · EMA 등 해외 인허가 · 유지 · 갱신 비용</a:t>
                       </a:r>
                       <a:endParaRPr lang="ko-KR" sz="950"/>
                     </a:p>
@@ -38478,7 +39678,7 @@
                           <a:ea typeface="210 옴니고딕 050"/>
                           <a:cs typeface="210 옴니고딕 050"/>
                         </a:rPr>
-                        <a:t>공고별 최대 2억</a:t>
+                        <a:t>공고별 확인</a:t>
                       </a:r>
                       <a:endParaRPr lang="ko-KR" sz="950"/>
                     </a:p>
@@ -38520,7 +39720,7 @@
                           <a:ea typeface="210 옴니고딕 040"/>
                           <a:cs typeface="210 옴니고딕 040"/>
                         </a:rPr>
-                        <a:t>2026: ~9.28 마감</a:t>
+                        <a:t>2026: 3차 9.28 마감</a:t>
                       </a:r>
                       <a:endParaRPr lang="ko-KR" sz="950"/>
                     </a:p>
@@ -38590,7 +39790,7 @@
                   </a:tcPr>
                 </a:tc>
               </a:tr>
-              <a:tr h="412577">
+              <a:tr h="403982">
                 <a:tc vMerge="1">
                   <a:txBody>
                     <a:bodyPr/>
@@ -38610,7 +39810,7 @@
                         <a:buNone/>
                       </a:pPr>
                       <a:r>
-                        <a:rPr lang="ko-KR" sz="1050" b="1">
+                        <a:rPr lang="ko-KR" sz="1000" b="1">
                           <a:solidFill>
                             <a:srgbClr val="1D1F2B"/>
                           </a:solidFill>
@@ -38618,257 +39818,16 @@
                           <a:ea typeface="210 옴니고딕 050"/>
                           <a:cs typeface="210 옴니고딕 050"/>
                         </a:rPr>
-                        <a:t>시장진입 단계별 규제 극복</a:t>
+                        <a:t>혁신의료기기 지정 제도</a:t>
                       </a:r>
-                      <a:endParaRPr lang="ko-KR" sz="1050"/>
+                      <a:endParaRPr lang="ko-KR" sz="1000"/>
                     </a:p>
                     <a:p>
                       <a:pPr marL="0" indent="0" algn="l">
                         <a:buNone/>
                       </a:pPr>
                       <a:r>
-                        <a:rPr lang="ko-KR" sz="850">
-                          <a:solidFill>
-                            <a:srgbClr val="6B6E7A"/>
-                          </a:solidFill>
-                          <a:latin typeface="210 옴니고딕 040"/>
-                          <a:ea typeface="210 옴니고딕 040"/>
-                          <a:cs typeface="210 옴니고딕 040"/>
-                        </a:rPr>
-                        <a:t>복지부 · KHIDI</a:t>
-                      </a:r>
-                      <a:endParaRPr lang="ko-KR" sz="850"/>
-                    </a:p>
-                  </a:txBody>
-                  <a:tcPr marL="64008" marR="45720" marT="27432" marB="27432" anchor="ctr">
-                    <a:lnL w="0">
-                      <a:noFill/>
-                    </a:lnL>
-                    <a:lnR w="0">
-                      <a:noFill/>
-                    </a:lnR>
-                    <a:lnT w="6350">
-                      <a:solidFill>
-                        <a:srgbClr val="E3E6EC"/>
-                      </a:solidFill>
-                    </a:lnT>
-                    <a:lnB w="6350">
-                      <a:solidFill>
-                        <a:srgbClr val="E3E6EC"/>
-                      </a:solidFill>
-                    </a:lnB>
-                    <a:noFill/>
-                  </a:tcPr>
-                </a:tc>
-                <a:tc>
-                  <a:txBody>
-                    <a:bodyPr/>
-                    <a:lstStyle/>
-                    <a:p>
-                      <a:pPr marL="0" indent="0" algn="l">
-                        <a:buNone/>
-                      </a:pPr>
-                      <a:r>
-                        <a:rPr lang="ko-KR" sz="950">
-                          <a:solidFill>
-                            <a:srgbClr val="1D1F2B"/>
-                          </a:solidFill>
-                          <a:latin typeface="210 옴니고딕 040"/>
-                          <a:ea typeface="210 옴니고딕 040"/>
-                          <a:cs typeface="210 옴니고딕 040"/>
-                        </a:rPr>
-                        <a:t>임상설계 · 시험 · 인허가 보완</a:t>
-                      </a:r>
-                      <a:endParaRPr lang="ko-KR" sz="950"/>
-                    </a:p>
-                  </a:txBody>
-                  <a:tcPr marL="64008" marR="45720" marT="27432" marB="27432" anchor="ctr">
-                    <a:lnL w="0">
-                      <a:noFill/>
-                    </a:lnL>
-                    <a:lnR w="0">
-                      <a:noFill/>
-                    </a:lnR>
-                    <a:lnT w="6350">
-                      <a:solidFill>
-                        <a:srgbClr val="E3E6EC"/>
-                      </a:solidFill>
-                    </a:lnT>
-                    <a:lnB w="6350">
-                      <a:solidFill>
-                        <a:srgbClr val="E3E6EC"/>
-                      </a:solidFill>
-                    </a:lnB>
-                    <a:noFill/>
-                  </a:tcPr>
-                </a:tc>
-                <a:tc>
-                  <a:txBody>
-                    <a:bodyPr/>
-                    <a:lstStyle/>
-                    <a:p>
-                      <a:pPr marL="0" indent="0" algn="l">
-                        <a:buNone/>
-                      </a:pPr>
-                      <a:r>
-                        <a:rPr lang="ko-KR" sz="950" b="1">
-                          <a:solidFill>
-                            <a:srgbClr val="1D1F2B"/>
-                          </a:solidFill>
-                          <a:latin typeface="210 옴니고딕 050"/>
-                          <a:ea typeface="210 옴니고딕 050"/>
-                          <a:cs typeface="210 옴니고딕 050"/>
-                        </a:rPr>
-                        <a:t>최대 1,000만원</a:t>
-                      </a:r>
-                      <a:endParaRPr lang="ko-KR" sz="950"/>
-                    </a:p>
-                  </a:txBody>
-                  <a:tcPr marL="64008" marR="45720" marT="27432" marB="27432" anchor="ctr">
-                    <a:lnL w="0">
-                      <a:noFill/>
-                    </a:lnL>
-                    <a:lnR w="0">
-                      <a:noFill/>
-                    </a:lnR>
-                    <a:lnT w="6350">
-                      <a:solidFill>
-                        <a:srgbClr val="E3E6EC"/>
-                      </a:solidFill>
-                    </a:lnT>
-                    <a:lnB w="6350">
-                      <a:solidFill>
-                        <a:srgbClr val="E3E6EC"/>
-                      </a:solidFill>
-                    </a:lnB>
-                    <a:noFill/>
-                  </a:tcPr>
-                </a:tc>
-                <a:tc>
-                  <a:txBody>
-                    <a:bodyPr/>
-                    <a:lstStyle/>
-                    <a:p>
-                      <a:pPr marL="0" indent="0" algn="l">
-                        <a:buNone/>
-                      </a:pPr>
-                      <a:r>
-                        <a:rPr lang="ko-KR" sz="950">
-                          <a:solidFill>
-                            <a:srgbClr val="1D1F2B"/>
-                          </a:solidFill>
-                          <a:latin typeface="210 옴니고딕 040"/>
-                          <a:ea typeface="210 옴니고딕 040"/>
-                          <a:cs typeface="210 옴니고딕 040"/>
-                        </a:rPr>
-                        <a:t>2026: ~2.23 마감</a:t>
-                      </a:r>
-                      <a:endParaRPr lang="ko-KR" sz="950"/>
-                    </a:p>
-                  </a:txBody>
-                  <a:tcPr marL="64008" marR="45720" marT="27432" marB="27432" anchor="ctr">
-                    <a:lnL w="0">
-                      <a:noFill/>
-                    </a:lnL>
-                    <a:lnR w="0">
-                      <a:noFill/>
-                    </a:lnR>
-                    <a:lnT w="6350">
-                      <a:solidFill>
-                        <a:srgbClr val="E3E6EC"/>
-                      </a:solidFill>
-                    </a:lnT>
-                    <a:lnB w="6350">
-                      <a:solidFill>
-                        <a:srgbClr val="E3E6EC"/>
-                      </a:solidFill>
-                    </a:lnB>
-                    <a:noFill/>
-                  </a:tcPr>
-                </a:tc>
-                <a:tc>
-                  <a:txBody>
-                    <a:bodyPr/>
-                    <a:lstStyle/>
-                    <a:p>
-                      <a:pPr marL="0" indent="0" algn="ctr">
-                        <a:buNone/>
-                      </a:pPr>
-                      <a:r>
-                        <a:rPr lang="ko-KR" sz="950" b="1">
-                          <a:solidFill>
-                            <a:srgbClr val="FFFFFF"/>
-                          </a:solidFill>
-                          <a:latin typeface="210 옴니고딕 050"/>
-                          <a:ea typeface="210 옴니고딕 050"/>
-                          <a:cs typeface="210 옴니고딕 050"/>
-                        </a:rPr>
-                        <a:t>2027 예상</a:t>
-                      </a:r>
-                      <a:endParaRPr lang="ko-KR" sz="950"/>
-                    </a:p>
-                  </a:txBody>
-                  <a:tcPr marL="27432" marR="27432" marT="27432" marB="27432" anchor="ctr">
-                    <a:lnL w="0">
-                      <a:noFill/>
-                    </a:lnL>
-                    <a:lnR w="0">
-                      <a:noFill/>
-                    </a:lnR>
-                    <a:lnT w="6350">
-                      <a:solidFill>
-                        <a:srgbClr val="E3E6EC"/>
-                      </a:solidFill>
-                    </a:lnT>
-                    <a:lnB w="6350">
-                      <a:solidFill>
-                        <a:srgbClr val="E3E6EC"/>
-                      </a:solidFill>
-                    </a:lnB>
-                    <a:solidFill>
-                      <a:srgbClr val="437DFF"/>
-                    </a:solidFill>
-                  </a:tcPr>
-                </a:tc>
-              </a:tr>
-              <a:tr h="412577">
-                <a:tc vMerge="1">
-                  <a:txBody>
-                    <a:bodyPr/>
-                    <a:lstStyle/>
-                    <a:p>
-                      <a:endParaRPr lang="ko-KR"/>
-                    </a:p>
-                  </a:txBody>
-                  <a:tcPr/>
-                </a:tc>
-                <a:tc>
-                  <a:txBody>
-                    <a:bodyPr/>
-                    <a:lstStyle/>
-                    <a:p>
-                      <a:pPr marL="0" indent="0" algn="l">
-                        <a:buNone/>
-                      </a:pPr>
-                      <a:r>
-                        <a:rPr lang="ko-KR" sz="1050" b="1">
-                          <a:solidFill>
-                            <a:srgbClr val="1D1F2B"/>
-                          </a:solidFill>
-                          <a:latin typeface="210 옴니고딕 050"/>
-                          <a:ea typeface="210 옴니고딕 050"/>
-                          <a:cs typeface="210 옴니고딕 050"/>
-                        </a:rPr>
-                        <a:t>혁신의료기기 지정</a:t>
-                      </a:r>
-                      <a:endParaRPr lang="ko-KR" sz="1050"/>
-                    </a:p>
-                    <a:p>
-                      <a:pPr marL="0" indent="0" algn="l">
-                        <a:buNone/>
-                      </a:pPr>
-                      <a:r>
-                        <a:rPr lang="ko-KR" sz="850">
+                        <a:rPr lang="ko-KR" sz="800">
                           <a:solidFill>
                             <a:srgbClr val="6B6E7A"/>
                           </a:solidFill>
@@ -38878,10 +39837,10 @@
                         </a:rPr>
                         <a:t>식약처</a:t>
                       </a:r>
-                      <a:endParaRPr lang="ko-KR" sz="850"/>
+                      <a:endParaRPr lang="ko-KR" sz="800"/>
                     </a:p>
                   </a:txBody>
-                  <a:tcPr marL="64008" marR="45720" marT="27432" marB="27432" anchor="ctr">
+                  <a:tcPr marL="64008" marR="45720" marT="9144" marB="9144" anchor="ctr">
                     <a:lnL w="0">
                       <a:noFill/>
                     </a:lnL>
@@ -39072,7 +40031,7 @@
                   </a:tcPr>
                 </a:tc>
               </a:tr>
-              <a:tr h="412577">
+              <a:tr h="403982">
                 <a:tc>
                   <a:txBody>
                     <a:bodyPr/>
@@ -39143,7 +40102,7 @@
                         <a:buNone/>
                       </a:pPr>
                       <a:r>
-                        <a:rPr lang="ko-KR" sz="1050" b="1">
+                        <a:rPr lang="ko-KR" sz="1000" b="1">
                           <a:solidFill>
                             <a:srgbClr val="1D1F2B"/>
                           </a:solidFill>
@@ -39151,16 +40110,16 @@
                           <a:ea typeface="210 옴니고딕 050"/>
                           <a:cs typeface="210 옴니고딕 050"/>
                         </a:rPr>
-                        <a:t>국산의료기기 사용자 임상평가</a:t>
+                        <a:t>2026년 국산의료기기 사용자(의료기관) 임상평가 지원 사업</a:t>
                       </a:r>
-                      <a:endParaRPr lang="ko-KR" sz="1050"/>
+                      <a:endParaRPr lang="ko-KR" sz="1000"/>
                     </a:p>
                     <a:p>
                       <a:pPr marL="0" indent="0" algn="l">
                         <a:buNone/>
                       </a:pPr>
                       <a:r>
-                        <a:rPr lang="ko-KR" sz="850">
+                        <a:rPr lang="ko-KR" sz="800">
                           <a:solidFill>
                             <a:srgbClr val="6B6E7A"/>
                           </a:solidFill>
@@ -39168,12 +40127,12 @@
                           <a:ea typeface="210 옴니고딕 040"/>
                           <a:cs typeface="210 옴니고딕 040"/>
                         </a:rPr>
-                        <a:t>KHIDI</a:t>
+                        <a:t>보건복지부 · KHIDI</a:t>
                       </a:r>
-                      <a:endParaRPr lang="ko-KR" sz="850"/>
+                      <a:endParaRPr lang="ko-KR" sz="800"/>
                     </a:p>
                   </a:txBody>
-                  <a:tcPr marL="64008" marR="45720" marT="27432" marB="27432" anchor="ctr">
+                  <a:tcPr marL="64008" marR="45720" marT="9144" marB="9144" anchor="ctr">
                     <a:lnL w="0">
                       <a:noFill/>
                     </a:lnL>
@@ -39210,7 +40169,7 @@
                           <a:ea typeface="210 옴니고딕 040"/>
                           <a:cs typeface="210 옴니고딕 040"/>
                         </a:rPr>
-                        <a:t>허가 후 의료기관 평가 · 기업 현금 30% 이상</a:t>
+                        <a:t>허가 후 의료기관 비교평가 · 성능검증</a:t>
                       </a:r>
                       <a:endParaRPr lang="ko-KR" sz="950"/>
                     </a:p>
@@ -39252,7 +40211,7 @@
                           <a:ea typeface="210 옴니고딕 050"/>
                           <a:cs typeface="210 옴니고딕 050"/>
                         </a:rPr>
-                        <a:t>단일 0.75/1.2억 · 다기관 1/2억</a:t>
+                        <a:t>단년 0.75억 · 단일기관 다년 1.2억 · 다기관 다년 2억</a:t>
                       </a:r>
                       <a:endParaRPr lang="ko-KR" sz="950"/>
                     </a:p>
@@ -39370,7 +40329,50 @@
       </p:graphicFrame>
       <p:sp>
         <p:nvSpPr>
-          <p:cNvPr id="9" name="Key box"/>
+          <p:cNvPr id="9" name="Grant note"/>
+          <p:cNvSpPr txBox="1"/>
+          <p:nvPr/>
+        </p:nvSpPr>
+        <p:spPr>
+          <a:xfrm>
+            <a:off x="502920" y="5360213"/>
+            <a:ext cx="11183112" cy="395387"/>
+          </a:xfrm>
+          <a:prstGeom prst="rect">
+            <a:avLst/>
+          </a:prstGeom>
+          <a:noFill/>
+          <a:ln>
+            <a:noFill/>
+          </a:ln>
+        </p:spPr>
+        <p:txBody>
+          <a:bodyPr wrap="square" lIns="0" tIns="0" rIns="0" bIns="0" anchor="ctr">
+            <a:noAutofit/>
+          </a:bodyPr>
+          <a:lstStyle/>
+          <a:p>
+            <a:pPr marL="0" indent="0" algn="l">
+              <a:buNone/>
+            </a:pPr>
+            <a:r>
+              <a:rPr lang="ko-KR" sz="950">
+                <a:solidFill>
+                  <a:srgbClr val="6B6E7A"/>
+                </a:solidFill>
+                <a:latin typeface="210 옴니고딕 040"/>
+                <a:ea typeface="210 옴니고딕 040"/>
+                <a:cs typeface="210 옴니고딕 040"/>
+              </a:rPr>
+              <a:t>과거 과제 검색: NTIS(ntis.go.kr)에서 사업명 ‘범부처전주기의료기기연구개발사업’(2020–2025, 1기) + ‘창상피복재 · 화상 · 케라틴’ 또는 수행기관 ‘바이오프렌즈’ · 이전 버전의 ‘시장진입 단계별 규제 극복’은 공고명이 확인되지 않아 제외</a:t>
+            </a:r>
+            <a:endParaRPr lang="ko-KR" sz="950"/>
+          </a:p>
+        </p:txBody>
+      </p:sp>
+      <p:sp>
+        <p:nvSpPr>
+          <p:cNvPr id="10" name="Key box"/>
           <p:cNvSpPr/>
           <p:nvPr/>
         </p:nvSpPr>
@@ -39394,7 +40396,7 @@
       </p:sp>
       <p:sp>
         <p:nvSpPr>
-          <p:cNvPr id="10" name="Key label"/>
+          <p:cNvPr id="11" name="Key label"/>
           <p:cNvSpPr txBox="1"/>
           <p:nvPr/>
         </p:nvSpPr>
@@ -39441,7 +40443,7 @@
       </p:sp>
       <p:sp>
         <p:nvSpPr>
-          <p:cNvPr id="11" name="Key text"/>
+          <p:cNvPr id="12" name="Key text"/>
           <p:cNvSpPr txBox="1"/>
           <p:nvPr/>
         </p:nvSpPr>
@@ -39476,7 +40478,7 @@
                 <a:ea typeface="210 옴니고딕 050"/>
                 <a:cs typeface="210 옴니고딕 050"/>
               </a:rPr>
-              <a:t>지금 할 일: KTR 해외규격인증 3차(~11.13) 신청 검토 + FDA 중소기업 인정 → 2027 KMDF 공고 전 임상계획 · 견적 준비</a:t>
+              <a:t>지금 할 일: 해외규격인증획득 지원사업 3차(~11.13) 신청 검토 + FDA 중소기업 인정 → 2027 KMDF 공고 전 임상계획 · 견적 준비</a:t>
             </a:r>
             <a:endParaRPr lang="ko-KR" sz="1250"/>
           </a:p>
@@ -39484,7 +40486,7 @@
       </p:sp>
       <p:sp>
         <p:nvSpPr>
-          <p:cNvPr id="12" name="Sources"/>
+          <p:cNvPr id="13" name="Sources"/>
           <p:cNvSpPr txBox="1"/>
           <p:nvPr/>
         </p:nvSpPr>
@@ -39531,7 +40533,7 @@
                 <a:cs typeface="210 옴니고딕 040"/>
                 <a:hlinkClick r:id="rL1"/>
               </a:rPr>
-              <a:t>KTR 해외규격인증획득지원</a:t>
+              <a:t>해외규격인증획득 지원사업 3차 (KDI)</a:t>
             </a:r>
             <a:r>
               <a:rPr lang="ko-KR" sz="750">
@@ -39554,7 +40556,7 @@
                 <a:cs typeface="210 옴니고딕 040"/>
                 <a:hlinkClick r:id="rL2"/>
               </a:rPr>
-              <a:t>KMDF 공고</a:t>
+              <a:t>KMDF 2026 제1차 공고</a:t>
             </a:r>
             <a:r>
               <a:rPr lang="ko-KR" sz="750">

</xml_diff>

<commit_message>
Align target-market page rows by metric and convert all values to KRW
Rows: total dressings, advanced dressings, non-foam moist dressings, each
global vs Korea in KRW at 1,400 KRW/USD with a Korea/global ratio; the
first-entry patient-count row is removed.

Co-Authored-By: Claude Opus 5.5 <noreply@anthropic.com>
Claude-Session: https://claude.ai/code/session_01RfoKnZfSzTcBgCwQYEg1hs
</commit_message>
<xml_diff>
--- a/presentation/BioFriends_KheAl_15-34_제품소개템플릿_20261026.pptx
+++ b/presentation/BioFriends_KheAl_15-34_제품소개템플릿_20261026.pptx
@@ -5088,7 +5088,7 @@
                 <a:ea typeface="210 옴니고딕 030"/>
                 <a:cs typeface="210 옴니고딕 030"/>
               </a:rPr>
-              <a:t>KheAl 대상 시장 — 전체에서 ‘2도 화상 습윤 겔’로 좁히기</a:t>
+              <a:t>KheAl 대상 시장 — 전체 · 첨단 드레싱 · 폼 외 습윤 드레싱</a:t>
             </a:r>
             <a:endParaRPr lang="ko-KR" sz="2400"/>
           </a:p>
@@ -5155,7 +5155,7 @@
                 <a:ea typeface="210 옴니고딕 050"/>
                 <a:cs typeface="210 옴니고딕 050"/>
               </a:rPr>
-              <a:t>판매가 미정 → 금액 대신 시장 크기 · 환자 규모로 제시. 판매가 확정 후 ‘환자 수 × 사용량 × 단가’로 매출 환산</a:t>
+              <a:t>같은 줄 = 같은 지표 · 모두 원화 환산 (1달러 = 1,400원) · 글로벌과 국내는 조사 연도 · 기관이 달라 ‘크기 차이’만 참고</a:t>
             </a:r>
             <a:endParaRPr lang="ko-KR" sz="1200"/>
           </a:p>
@@ -5206,14 +5206,14 @@
       </p:sp>
       <p:sp>
         <p:nvSpPr>
-          <p:cNvPr id="8" name="Global bar back"/>
+          <p:cNvPr id="8" name="G head back"/>
           <p:cNvSpPr/>
           <p:nvPr/>
         </p:nvSpPr>
         <p:spPr>
           <a:xfrm>
-            <a:off x="502920" y="1664208"/>
-            <a:ext cx="5486400" cy="309433"/>
+            <a:off x="3246120" y="1664208"/>
+            <a:ext cx="3886200" cy="309433"/>
           </a:xfrm>
           <a:prstGeom prst="parallelogram">
             <a:avLst/>
@@ -5228,14 +5228,14 @@
       </p:sp>
       <p:sp>
         <p:nvSpPr>
-          <p:cNvPr id="9" name="Global bar"/>
-          <p:cNvSpPr txBox="1"/>
-          <p:nvPr/>
-        </p:nvSpPr>
-        <p:spPr>
-          <a:xfrm>
-            <a:off x="566928" y="1664208"/>
-            <a:ext cx="5358384" cy="309433"/>
+          <p:cNvPr id="9" name="G head"/>
+          <p:cNvSpPr txBox="1"/>
+          <p:nvPr/>
+        </p:nvSpPr>
+        <p:spPr>
+          <a:xfrm>
+            <a:off x="3310128" y="1664208"/>
+            <a:ext cx="3758184" cy="309433"/>
           </a:xfrm>
           <a:prstGeom prst="parallelogram">
             <a:avLst/>
@@ -5273,14 +5273,14 @@
       </p:sp>
       <p:sp>
         <p:nvSpPr>
-          <p:cNvPr id="10" name="Korea bar back"/>
+          <p:cNvPr id="10" name="K head back"/>
           <p:cNvSpPr/>
           <p:nvPr/>
         </p:nvSpPr>
         <p:spPr>
           <a:xfrm>
-            <a:off x="6199632" y="1664208"/>
-            <a:ext cx="5486400" cy="309433"/>
+            <a:off x="7269480" y="1664208"/>
+            <a:ext cx="3246120" cy="309433"/>
           </a:xfrm>
           <a:prstGeom prst="parallelogram">
             <a:avLst/>
@@ -5295,14 +5295,14 @@
       </p:sp>
       <p:sp>
         <p:nvSpPr>
-          <p:cNvPr id="11" name="Korea bar"/>
-          <p:cNvSpPr txBox="1"/>
-          <p:nvPr/>
-        </p:nvSpPr>
-        <p:spPr>
-          <a:xfrm>
-            <a:off x="6263640" y="1664208"/>
-            <a:ext cx="5358384" cy="309433"/>
+          <p:cNvPr id="11" name="K head"/>
+          <p:cNvSpPr txBox="1"/>
+          <p:nvPr/>
+        </p:nvSpPr>
+        <p:spPr>
+          <a:xfrm>
+            <a:off x="7333488" y="1664208"/>
+            <a:ext cx="3118104" cy="309433"/>
           </a:xfrm>
           <a:prstGeom prst="parallelogram">
             <a:avLst/>
@@ -5340,18 +5340,1036 @@
       </p:sp>
       <p:sp>
         <p:nvSpPr>
-          <p:cNvPr id="12" name="G lvl 0"/>
-          <p:cNvSpPr txBox="1"/>
-          <p:nvPr/>
-        </p:nvSpPr>
-        <p:spPr>
-          <a:xfrm>
-            <a:off x="502920" y="2136953"/>
-            <a:ext cx="5486400" cy="988466"/>
+          <p:cNvPr id="12" name="R head"/>
+          <p:cNvSpPr txBox="1"/>
+          <p:nvPr/>
+        </p:nvSpPr>
+        <p:spPr>
+          <a:xfrm>
+            <a:off x="10607040" y="1664208"/>
+            <a:ext cx="1078992" cy="309433"/>
+          </a:xfrm>
+          <a:prstGeom prst="rect">
+            <a:avLst/>
+          </a:prstGeom>
+          <a:noFill/>
+          <a:ln>
+            <a:noFill/>
+          </a:ln>
+        </p:spPr>
+        <p:txBody>
+          <a:bodyPr wrap="square" lIns="0" tIns="0" rIns="0" bIns="0" anchor="ctr">
+            <a:noAutofit/>
+          </a:bodyPr>
+          <a:lstStyle/>
+          <a:p>
+            <a:pPr marL="0" indent="0" algn="ctr">
+              <a:buNone/>
+            </a:pPr>
+            <a:r>
+              <a:rPr lang="ko-KR" sz="1000" b="1">
+                <a:solidFill>
+                  <a:srgbClr val="6B6E7A"/>
+                </a:solidFill>
+                <a:latin typeface="210 옴니고딕 050"/>
+                <a:ea typeface="210 옴니고딕 050"/>
+                <a:cs typeface="210 옴니고딕 050"/>
+              </a:rPr>
+              <a:t>국내 / 글로벌</a:t>
+            </a:r>
+            <a:endParaRPr lang="ko-KR" sz="1000"/>
+          </a:p>
+        </p:txBody>
+      </p:sp>
+      <p:sp>
+        <p:nvSpPr>
+          <p:cNvPr id="13" name="Row 0"/>
+          <p:cNvSpPr/>
+          <p:nvPr/>
+        </p:nvSpPr>
+        <p:spPr>
+          <a:xfrm>
+            <a:off x="502920" y="2093976"/>
+            <a:ext cx="11183112" cy="1014252"/>
           </a:xfrm>
           <a:prstGeom prst="roundRect">
             <a:avLst>
-              <a:gd name="adj" fmla="val 10000"/>
+              <a:gd name="adj" fmla="val 4000"/>
+            </a:avLst>
+          </a:prstGeom>
+          <a:solidFill>
+            <a:srgbClr val="FFFFFF"/>
+          </a:solidFill>
+          <a:ln w="9525">
+            <a:solidFill>
+              <a:srgbClr val="D5D8E0"/>
+            </a:solidFill>
+          </a:ln>
+        </p:spPr>
+      </p:sp>
+      <p:sp>
+        <p:nvSpPr>
+          <p:cNvPr id="14" name="Nm 0"/>
+          <p:cNvSpPr txBox="1"/>
+          <p:nvPr/>
+        </p:nvSpPr>
+        <p:spPr>
+          <a:xfrm>
+            <a:off x="640080" y="2222906"/>
+            <a:ext cx="2560320" cy="361005"/>
+          </a:xfrm>
+          <a:prstGeom prst="rect">
+            <a:avLst/>
+          </a:prstGeom>
+          <a:noFill/>
+          <a:ln>
+            <a:noFill/>
+          </a:ln>
+        </p:spPr>
+        <p:txBody>
+          <a:bodyPr wrap="square" lIns="0" tIns="0" rIns="0" bIns="0" anchor="t">
+            <a:noAutofit/>
+          </a:bodyPr>
+          <a:lstStyle/>
+          <a:p>
+            <a:pPr marL="0" indent="0" algn="l">
+              <a:buNone/>
+            </a:pPr>
+            <a:r>
+              <a:rPr lang="ko-KR" sz="1300" b="1">
+                <a:solidFill>
+                  <a:srgbClr val="1D1F2B"/>
+                </a:solidFill>
+                <a:latin typeface="210 옴니고딕 050"/>
+                <a:ea typeface="210 옴니고딕 050"/>
+                <a:cs typeface="210 옴니고딕 050"/>
+              </a:rPr>
+              <a:t>①  창상피복재 전체</a:t>
+            </a:r>
+            <a:endParaRPr lang="ko-KR" sz="1300"/>
+          </a:p>
+        </p:txBody>
+      </p:sp>
+      <p:sp>
+        <p:nvSpPr>
+          <p:cNvPr id="15" name="Sub 0"/>
+          <p:cNvSpPr txBox="1"/>
+          <p:nvPr/>
+        </p:nvSpPr>
+        <p:spPr>
+          <a:xfrm>
+            <a:off x="640080" y="2592507"/>
+            <a:ext cx="2560320" cy="472745"/>
+          </a:xfrm>
+          <a:prstGeom prst="rect">
+            <a:avLst/>
+          </a:prstGeom>
+          <a:noFill/>
+          <a:ln>
+            <a:noFill/>
+          </a:ln>
+        </p:spPr>
+        <p:txBody>
+          <a:bodyPr wrap="square" lIns="0" tIns="0" rIns="0" bIns="0" anchor="t">
+            <a:noAutofit/>
+          </a:bodyPr>
+          <a:lstStyle/>
+          <a:p>
+            <a:pPr marL="0" indent="0" algn="l">
+              <a:buNone/>
+            </a:pPr>
+            <a:r>
+              <a:rPr lang="ko-KR" sz="950">
+                <a:solidFill>
+                  <a:srgbClr val="6B6E7A"/>
+                </a:solidFill>
+                <a:latin typeface="210 옴니고딕 040"/>
+                <a:ea typeface="210 옴니고딕 040"/>
+                <a:cs typeface="210 옴니고딕 040"/>
+              </a:rPr>
+              <a:t>드레싱 시장 전체</a:t>
+            </a:r>
+            <a:endParaRPr lang="ko-KR" sz="950"/>
+          </a:p>
+        </p:txBody>
+      </p:sp>
+      <p:sp>
+        <p:nvSpPr>
+          <p:cNvPr id="16" name="Gb 0"/>
+          <p:cNvSpPr txBox="1"/>
+          <p:nvPr/>
+        </p:nvSpPr>
+        <p:spPr>
+          <a:xfrm>
+            <a:off x="3291840" y="2162739"/>
+            <a:ext cx="3794760" cy="446959"/>
+          </a:xfrm>
+          <a:prstGeom prst="rect">
+            <a:avLst/>
+          </a:prstGeom>
+          <a:noFill/>
+          <a:ln>
+            <a:noFill/>
+          </a:ln>
+        </p:spPr>
+        <p:txBody>
+          <a:bodyPr wrap="square" lIns="0" tIns="0" rIns="0" bIns="0" anchor="t">
+            <a:noAutofit/>
+          </a:bodyPr>
+          <a:lstStyle/>
+          <a:p>
+            <a:pPr marL="0" indent="0" algn="l">
+              <a:buNone/>
+            </a:pPr>
+            <a:r>
+              <a:rPr lang="ko-KR" sz="2400" b="1">
+                <a:solidFill>
+                  <a:srgbClr val="437DFF"/>
+                </a:solidFill>
+                <a:latin typeface="210 옴니고딕 050"/>
+                <a:ea typeface="210 옴니고딕 050"/>
+                <a:cs typeface="210 옴니고딕 050"/>
+              </a:rPr>
+              <a:t>16.2조원</a:t>
+            </a:r>
+            <a:endParaRPr lang="ko-KR" sz="2400"/>
+          </a:p>
+        </p:txBody>
+      </p:sp>
+      <p:sp>
+        <p:nvSpPr>
+          <p:cNvPr id="17" name="Gs 0"/>
+          <p:cNvSpPr txBox="1"/>
+          <p:nvPr/>
+        </p:nvSpPr>
+        <p:spPr>
+          <a:xfrm>
+            <a:off x="3291840" y="2609698"/>
+            <a:ext cx="3794760" cy="472745"/>
+          </a:xfrm>
+          <a:prstGeom prst="rect">
+            <a:avLst/>
+          </a:prstGeom>
+          <a:noFill/>
+          <a:ln>
+            <a:noFill/>
+          </a:ln>
+        </p:spPr>
+        <p:txBody>
+          <a:bodyPr wrap="square" lIns="0" tIns="0" rIns="0" bIns="0" anchor="t">
+            <a:noAutofit/>
+          </a:bodyPr>
+          <a:lstStyle/>
+          <a:p>
+            <a:pPr marL="0" indent="0" algn="l">
+              <a:spcAft>
+                <a:spcPts val="100"/>
+              </a:spcAft>
+              <a:buNone/>
+            </a:pPr>
+            <a:r>
+              <a:rPr lang="ko-KR" sz="950">
+                <a:solidFill>
+                  <a:srgbClr val="6B6E7A"/>
+                </a:solidFill>
+                <a:latin typeface="210 옴니고딕 040"/>
+                <a:ea typeface="210 옴니고딕 040"/>
+                <a:cs typeface="210 옴니고딕 040"/>
+              </a:rPr>
+              <a:t>2025 · $11.6B  →  2030 22.3조원 ($15.9B)</a:t>
+            </a:r>
+            <a:endParaRPr lang="ko-KR" sz="1100"/>
+          </a:p>
+          <a:p>
+            <a:pPr marL="0" indent="0" algn="l">
+              <a:spcAft>
+                <a:spcPts val="100"/>
+              </a:spcAft>
+              <a:buNone/>
+            </a:pPr>
+            <a:r>
+              <a:rPr lang="ko-KR" sz="950" b="1">
+                <a:solidFill>
+                  <a:srgbClr val="1D1F2B"/>
+                </a:solidFill>
+                <a:latin typeface="210 옴니고딕 050"/>
+                <a:ea typeface="210 옴니고딕 050"/>
+                <a:cs typeface="210 옴니고딕 050"/>
+              </a:rPr>
+              <a:t>미국 2.8조원 ($2.03B, 2025)</a:t>
+            </a:r>
+            <a:endParaRPr lang="ko-KR" sz="1100"/>
+          </a:p>
+        </p:txBody>
+      </p:sp>
+      <p:sp>
+        <p:nvSpPr>
+          <p:cNvPr id="18" name="Kb 0"/>
+          <p:cNvSpPr txBox="1"/>
+          <p:nvPr/>
+        </p:nvSpPr>
+        <p:spPr>
+          <a:xfrm>
+            <a:off x="7315200" y="2162739"/>
+            <a:ext cx="3200400" cy="446959"/>
+          </a:xfrm>
+          <a:prstGeom prst="rect">
+            <a:avLst/>
+          </a:prstGeom>
+          <a:noFill/>
+          <a:ln>
+            <a:noFill/>
+          </a:ln>
+        </p:spPr>
+        <p:txBody>
+          <a:bodyPr wrap="square" lIns="0" tIns="0" rIns="0" bIns="0" anchor="t">
+            <a:noAutofit/>
+          </a:bodyPr>
+          <a:lstStyle/>
+          <a:p>
+            <a:pPr marL="0" indent="0" algn="l">
+              <a:buNone/>
+            </a:pPr>
+            <a:r>
+              <a:rPr lang="ko-KR" sz="2400" b="1">
+                <a:solidFill>
+                  <a:srgbClr val="7030A0"/>
+                </a:solidFill>
+                <a:latin typeface="210 옴니고딕 050"/>
+                <a:ea typeface="210 옴니고딕 050"/>
+                <a:cs typeface="210 옴니고딕 050"/>
+              </a:rPr>
+              <a:t>3,319억원</a:t>
+            </a:r>
+            <a:endParaRPr lang="ko-KR" sz="2400"/>
+          </a:p>
+        </p:txBody>
+      </p:sp>
+      <p:sp>
+        <p:nvSpPr>
+          <p:cNvPr id="19" name="Ks 0"/>
+          <p:cNvSpPr txBox="1"/>
+          <p:nvPr/>
+        </p:nvSpPr>
+        <p:spPr>
+          <a:xfrm>
+            <a:off x="7315200" y="2609698"/>
+            <a:ext cx="3200400" cy="472745"/>
+          </a:xfrm>
+          <a:prstGeom prst="rect">
+            <a:avLst/>
+          </a:prstGeom>
+          <a:noFill/>
+          <a:ln>
+            <a:noFill/>
+          </a:ln>
+        </p:spPr>
+        <p:txBody>
+          <a:bodyPr wrap="square" lIns="0" tIns="0" rIns="0" bIns="0" anchor="t">
+            <a:noAutofit/>
+          </a:bodyPr>
+          <a:lstStyle/>
+          <a:p>
+            <a:pPr marL="0" indent="0" algn="l">
+              <a:buNone/>
+            </a:pPr>
+            <a:r>
+              <a:rPr lang="ko-KR" sz="950">
+                <a:solidFill>
+                  <a:srgbClr val="6B6E7A"/>
+                </a:solidFill>
+                <a:latin typeface="210 옴니고딕 040"/>
+                <a:ea typeface="210 옴니고딕 040"/>
+                <a:cs typeface="210 옴니고딕 040"/>
+              </a:rPr>
+              <a:t>2022 추정 · 최종 구입가 기준</a:t>
+            </a:r>
+            <a:endParaRPr lang="ko-KR" sz="950"/>
+          </a:p>
+        </p:txBody>
+      </p:sp>
+      <p:sp>
+        <p:nvSpPr>
+          <p:cNvPr id="20" name="Ratio 0"/>
+          <p:cNvSpPr txBox="1"/>
+          <p:nvPr/>
+        </p:nvSpPr>
+        <p:spPr>
+          <a:xfrm>
+            <a:off x="10680192" y="2403409"/>
+            <a:ext cx="932688" cy="378196"/>
+          </a:xfrm>
+          <a:prstGeom prst="roundRect">
+            <a:avLst>
+              <a:gd name="adj" fmla="val 16000"/>
+            </a:avLst>
+          </a:prstGeom>
+          <a:solidFill>
+            <a:srgbClr val="3B3F57"/>
+          </a:solidFill>
+          <a:ln>
+            <a:noFill/>
+          </a:ln>
+        </p:spPr>
+        <p:txBody>
+          <a:bodyPr wrap="square" lIns="36576" tIns="18288" rIns="36576" bIns="18288" anchor="ctr">
+            <a:noAutofit/>
+          </a:bodyPr>
+          <a:lstStyle/>
+          <a:p>
+            <a:pPr marL="0" indent="0" algn="ctr">
+              <a:buNone/>
+            </a:pPr>
+            <a:r>
+              <a:rPr lang="ko-KR" sz="1200" b="1">
+                <a:solidFill>
+                  <a:srgbClr val="FFFFFF"/>
+                </a:solidFill>
+                <a:latin typeface="210 옴니고딕 050"/>
+                <a:ea typeface="210 옴니고딕 050"/>
+                <a:cs typeface="210 옴니고딕 050"/>
+              </a:rPr>
+              <a:t>2.0%</a:t>
+            </a:r>
+            <a:endParaRPr lang="ko-KR" sz="1200"/>
+          </a:p>
+        </p:txBody>
+      </p:sp>
+      <p:sp>
+        <p:nvSpPr>
+          <p:cNvPr id="21" name="Row 1"/>
+          <p:cNvSpPr/>
+          <p:nvPr/>
+        </p:nvSpPr>
+        <p:spPr>
+          <a:xfrm>
+            <a:off x="502920" y="3211373"/>
+            <a:ext cx="11183112" cy="1014252"/>
+          </a:xfrm>
+          <a:prstGeom prst="roundRect">
+            <a:avLst>
+              <a:gd name="adj" fmla="val 4000"/>
+            </a:avLst>
+          </a:prstGeom>
+          <a:solidFill>
+            <a:srgbClr val="FFFFFF"/>
+          </a:solidFill>
+          <a:ln w="9525">
+            <a:solidFill>
+              <a:srgbClr val="D5D8E0"/>
+            </a:solidFill>
+          </a:ln>
+        </p:spPr>
+      </p:sp>
+      <p:sp>
+        <p:nvSpPr>
+          <p:cNvPr id="22" name="Nm 1"/>
+          <p:cNvSpPr txBox="1"/>
+          <p:nvPr/>
+        </p:nvSpPr>
+        <p:spPr>
+          <a:xfrm>
+            <a:off x="640080" y="3340303"/>
+            <a:ext cx="2560320" cy="361005"/>
+          </a:xfrm>
+          <a:prstGeom prst="rect">
+            <a:avLst/>
+          </a:prstGeom>
+          <a:noFill/>
+          <a:ln>
+            <a:noFill/>
+          </a:ln>
+        </p:spPr>
+        <p:txBody>
+          <a:bodyPr wrap="square" lIns="0" tIns="0" rIns="0" bIns="0" anchor="t">
+            <a:noAutofit/>
+          </a:bodyPr>
+          <a:lstStyle/>
+          <a:p>
+            <a:pPr marL="0" indent="0" algn="l">
+              <a:buNone/>
+            </a:pPr>
+            <a:r>
+              <a:rPr lang="ko-KR" sz="1300" b="1">
+                <a:solidFill>
+                  <a:srgbClr val="1D1F2B"/>
+                </a:solidFill>
+                <a:latin typeface="210 옴니고딕 050"/>
+                <a:ea typeface="210 옴니고딕 050"/>
+                <a:cs typeface="210 옴니고딕 050"/>
+              </a:rPr>
+              <a:t>②  첨단 드레싱</a:t>
+            </a:r>
+            <a:endParaRPr lang="ko-KR" sz="1300"/>
+          </a:p>
+        </p:txBody>
+      </p:sp>
+      <p:sp>
+        <p:nvSpPr>
+          <p:cNvPr id="23" name="Sub 1"/>
+          <p:cNvSpPr txBox="1"/>
+          <p:nvPr/>
+        </p:nvSpPr>
+        <p:spPr>
+          <a:xfrm>
+            <a:off x="640080" y="3709904"/>
+            <a:ext cx="2560320" cy="472745"/>
+          </a:xfrm>
+          <a:prstGeom prst="rect">
+            <a:avLst/>
+          </a:prstGeom>
+          <a:noFill/>
+          <a:ln>
+            <a:noFill/>
+          </a:ln>
+        </p:spPr>
+        <p:txBody>
+          <a:bodyPr wrap="square" lIns="0" tIns="0" rIns="0" bIns="0" anchor="t">
+            <a:noAutofit/>
+          </a:bodyPr>
+          <a:lstStyle/>
+          <a:p>
+            <a:pPr marL="0" indent="0" algn="l">
+              <a:buNone/>
+            </a:pPr>
+            <a:r>
+              <a:rPr lang="ko-KR" sz="950">
+                <a:solidFill>
+                  <a:srgbClr val="6B6E7A"/>
+                </a:solidFill>
+                <a:latin typeface="210 옴니고딕 040"/>
+                <a:ea typeface="210 옴니고딕 040"/>
+                <a:cs typeface="210 옴니고딕 040"/>
+              </a:rPr>
+              <a:t>폼 + 습윤 계열 (거즈 · 음압 제외)</a:t>
+            </a:r>
+            <a:endParaRPr lang="ko-KR" sz="950"/>
+          </a:p>
+        </p:txBody>
+      </p:sp>
+      <p:sp>
+        <p:nvSpPr>
+          <p:cNvPr id="24" name="Gb 1"/>
+          <p:cNvSpPr txBox="1"/>
+          <p:nvPr/>
+        </p:nvSpPr>
+        <p:spPr>
+          <a:xfrm>
+            <a:off x="3291840" y="3280136"/>
+            <a:ext cx="3794760" cy="446959"/>
+          </a:xfrm>
+          <a:prstGeom prst="rect">
+            <a:avLst/>
+          </a:prstGeom>
+          <a:noFill/>
+          <a:ln>
+            <a:noFill/>
+          </a:ln>
+        </p:spPr>
+        <p:txBody>
+          <a:bodyPr wrap="square" lIns="0" tIns="0" rIns="0" bIns="0" anchor="t">
+            <a:noAutofit/>
+          </a:bodyPr>
+          <a:lstStyle/>
+          <a:p>
+            <a:pPr marL="0" indent="0" algn="l">
+              <a:buNone/>
+            </a:pPr>
+            <a:r>
+              <a:rPr lang="ko-KR" sz="2400" b="1">
+                <a:solidFill>
+                  <a:srgbClr val="437DFF"/>
+                </a:solidFill>
+                <a:latin typeface="210 옴니고딕 050"/>
+                <a:ea typeface="210 옴니고딕 050"/>
+                <a:cs typeface="210 옴니고딕 050"/>
+              </a:rPr>
+              <a:t>9.0조원</a:t>
+            </a:r>
+            <a:endParaRPr lang="ko-KR" sz="2400"/>
+          </a:p>
+        </p:txBody>
+      </p:sp>
+      <p:sp>
+        <p:nvSpPr>
+          <p:cNvPr id="25" name="Gs 1"/>
+          <p:cNvSpPr txBox="1"/>
+          <p:nvPr/>
+        </p:nvSpPr>
+        <p:spPr>
+          <a:xfrm>
+            <a:off x="3291840" y="3727094"/>
+            <a:ext cx="3794760" cy="472745"/>
+          </a:xfrm>
+          <a:prstGeom prst="rect">
+            <a:avLst/>
+          </a:prstGeom>
+          <a:noFill/>
+          <a:ln>
+            <a:noFill/>
+          </a:ln>
+        </p:spPr>
+        <p:txBody>
+          <a:bodyPr wrap="square" lIns="0" tIns="0" rIns="0" bIns="0" anchor="t">
+            <a:noAutofit/>
+          </a:bodyPr>
+          <a:lstStyle/>
+          <a:p>
+            <a:pPr marL="0" indent="0" algn="l">
+              <a:spcAft>
+                <a:spcPts val="100"/>
+              </a:spcAft>
+              <a:buNone/>
+            </a:pPr>
+            <a:r>
+              <a:rPr lang="ko-KR" sz="950">
+                <a:solidFill>
+                  <a:srgbClr val="6B6E7A"/>
+                </a:solidFill>
+                <a:latin typeface="210 옴니고딕 040"/>
+                <a:ea typeface="210 옴니고딕 040"/>
+                <a:cs typeface="210 옴니고딕 040"/>
+              </a:rPr>
+              <a:t>2025 · $6.4B  →  2030 13.2조원 ($9.4B)</a:t>
+            </a:r>
+            <a:endParaRPr lang="ko-KR" sz="1100"/>
+          </a:p>
+        </p:txBody>
+      </p:sp>
+      <p:sp>
+        <p:nvSpPr>
+          <p:cNvPr id="26" name="Kb 1"/>
+          <p:cNvSpPr txBox="1"/>
+          <p:nvPr/>
+        </p:nvSpPr>
+        <p:spPr>
+          <a:xfrm>
+            <a:off x="7315200" y="3280136"/>
+            <a:ext cx="3200400" cy="446959"/>
+          </a:xfrm>
+          <a:prstGeom prst="rect">
+            <a:avLst/>
+          </a:prstGeom>
+          <a:noFill/>
+          <a:ln>
+            <a:noFill/>
+          </a:ln>
+        </p:spPr>
+        <p:txBody>
+          <a:bodyPr wrap="square" lIns="0" tIns="0" rIns="0" bIns="0" anchor="t">
+            <a:noAutofit/>
+          </a:bodyPr>
+          <a:lstStyle/>
+          <a:p>
+            <a:pPr marL="0" indent="0" algn="l">
+              <a:buNone/>
+            </a:pPr>
+            <a:r>
+              <a:rPr lang="ko-KR" sz="2400" b="1">
+                <a:solidFill>
+                  <a:srgbClr val="7030A0"/>
+                </a:solidFill>
+                <a:latin typeface="210 옴니고딕 050"/>
+                <a:ea typeface="210 옴니고딕 050"/>
+                <a:cs typeface="210 옴니고딕 050"/>
+              </a:rPr>
+              <a:t>1,307억원</a:t>
+            </a:r>
+            <a:endParaRPr lang="ko-KR" sz="2400"/>
+          </a:p>
+        </p:txBody>
+      </p:sp>
+      <p:sp>
+        <p:nvSpPr>
+          <p:cNvPr id="27" name="Ks 1"/>
+          <p:cNvSpPr txBox="1"/>
+          <p:nvPr/>
+        </p:nvSpPr>
+        <p:spPr>
+          <a:xfrm>
+            <a:off x="7315200" y="3727094"/>
+            <a:ext cx="3200400" cy="472745"/>
+          </a:xfrm>
+          <a:prstGeom prst="rect">
+            <a:avLst/>
+          </a:prstGeom>
+          <a:noFill/>
+          <a:ln>
+            <a:noFill/>
+          </a:ln>
+        </p:spPr>
+        <p:txBody>
+          <a:bodyPr wrap="square" lIns="0" tIns="0" rIns="0" bIns="0" anchor="t">
+            <a:noAutofit/>
+          </a:bodyPr>
+          <a:lstStyle/>
+          <a:p>
+            <a:pPr marL="0" indent="0" algn="l">
+              <a:buNone/>
+            </a:pPr>
+            <a:r>
+              <a:rPr lang="ko-KR" sz="950">
+                <a:solidFill>
+                  <a:srgbClr val="6B6E7A"/>
+                </a:solidFill>
+                <a:latin typeface="210 옴니고딕 040"/>
+                <a:ea typeface="210 옴니고딕 040"/>
+                <a:cs typeface="210 옴니고딕 040"/>
+              </a:rPr>
+              <a:t>2022 · 병원 급여 청구 1,579억 중 폼 68.8% + 기타 습윤 14.0%</a:t>
+            </a:r>
+            <a:endParaRPr lang="ko-KR" sz="950"/>
+          </a:p>
+        </p:txBody>
+      </p:sp>
+      <p:sp>
+        <p:nvSpPr>
+          <p:cNvPr id="28" name="Ratio 1"/>
+          <p:cNvSpPr txBox="1"/>
+          <p:nvPr/>
+        </p:nvSpPr>
+        <p:spPr>
+          <a:xfrm>
+            <a:off x="10680192" y="3520806"/>
+            <a:ext cx="932688" cy="378196"/>
+          </a:xfrm>
+          <a:prstGeom prst="roundRect">
+            <a:avLst>
+              <a:gd name="adj" fmla="val 16000"/>
+            </a:avLst>
+          </a:prstGeom>
+          <a:solidFill>
+            <a:srgbClr val="3B3F57"/>
+          </a:solidFill>
+          <a:ln>
+            <a:noFill/>
+          </a:ln>
+        </p:spPr>
+        <p:txBody>
+          <a:bodyPr wrap="square" lIns="36576" tIns="18288" rIns="36576" bIns="18288" anchor="ctr">
+            <a:noAutofit/>
+          </a:bodyPr>
+          <a:lstStyle/>
+          <a:p>
+            <a:pPr marL="0" indent="0" algn="ctr">
+              <a:buNone/>
+            </a:pPr>
+            <a:r>
+              <a:rPr lang="ko-KR" sz="1200" b="1">
+                <a:solidFill>
+                  <a:srgbClr val="FFFFFF"/>
+                </a:solidFill>
+                <a:latin typeface="210 옴니고딕 050"/>
+                <a:ea typeface="210 옴니고딕 050"/>
+                <a:cs typeface="210 옴니고딕 050"/>
+              </a:rPr>
+              <a:t>1.5%</a:t>
+            </a:r>
+            <a:endParaRPr lang="ko-KR" sz="1200"/>
+          </a:p>
+        </p:txBody>
+      </p:sp>
+      <p:sp>
+        <p:nvSpPr>
+          <p:cNvPr id="29" name="Row 2"/>
+          <p:cNvSpPr/>
+          <p:nvPr/>
+        </p:nvSpPr>
+        <p:spPr>
+          <a:xfrm>
+            <a:off x="502920" y="4328770"/>
+            <a:ext cx="11183112" cy="1014252"/>
+          </a:xfrm>
+          <a:prstGeom prst="roundRect">
+            <a:avLst>
+              <a:gd name="adj" fmla="val 4000"/>
+            </a:avLst>
+          </a:prstGeom>
+          <a:solidFill>
+            <a:srgbClr val="E6E9F5"/>
+          </a:solidFill>
+          <a:ln w="9525">
+            <a:solidFill>
+              <a:srgbClr val="102290"/>
+            </a:solidFill>
+          </a:ln>
+        </p:spPr>
+      </p:sp>
+      <p:sp>
+        <p:nvSpPr>
+          <p:cNvPr id="30" name="Nm 2"/>
+          <p:cNvSpPr txBox="1"/>
+          <p:nvPr/>
+        </p:nvSpPr>
+        <p:spPr>
+          <a:xfrm>
+            <a:off x="640080" y="4457700"/>
+            <a:ext cx="2560320" cy="361005"/>
+          </a:xfrm>
+          <a:prstGeom prst="rect">
+            <a:avLst/>
+          </a:prstGeom>
+          <a:noFill/>
+          <a:ln>
+            <a:noFill/>
+          </a:ln>
+        </p:spPr>
+        <p:txBody>
+          <a:bodyPr wrap="square" lIns="0" tIns="0" rIns="0" bIns="0" anchor="t">
+            <a:noAutofit/>
+          </a:bodyPr>
+          <a:lstStyle/>
+          <a:p>
+            <a:pPr marL="0" indent="0" algn="l">
+              <a:buNone/>
+            </a:pPr>
+            <a:r>
+              <a:rPr lang="ko-KR" sz="1300" b="1">
+                <a:solidFill>
+                  <a:srgbClr val="102290"/>
+                </a:solidFill>
+                <a:latin typeface="210 옴니고딕 050"/>
+                <a:ea typeface="210 옴니고딕 050"/>
+                <a:cs typeface="210 옴니고딕 050"/>
+              </a:rPr>
+              <a:t>③  폼 외 습윤 드레싱</a:t>
+            </a:r>
+            <a:endParaRPr lang="ko-KR" sz="1300"/>
+          </a:p>
+        </p:txBody>
+      </p:sp>
+      <p:sp>
+        <p:nvSpPr>
+          <p:cNvPr id="31" name="Sub 2"/>
+          <p:cNvSpPr txBox="1"/>
+          <p:nvPr/>
+        </p:nvSpPr>
+        <p:spPr>
+          <a:xfrm>
+            <a:off x="640080" y="4827300"/>
+            <a:ext cx="2560320" cy="472745"/>
+          </a:xfrm>
+          <a:prstGeom prst="rect">
+            <a:avLst/>
+          </a:prstGeom>
+          <a:noFill/>
+          <a:ln>
+            <a:noFill/>
+          </a:ln>
+        </p:spPr>
+        <p:txBody>
+          <a:bodyPr wrap="square" lIns="0" tIns="0" rIns="0" bIns="0" anchor="t">
+            <a:noAutofit/>
+          </a:bodyPr>
+          <a:lstStyle/>
+          <a:p>
+            <a:pPr marL="0" indent="0" algn="l">
+              <a:buNone/>
+            </a:pPr>
+            <a:r>
+              <a:rPr lang="ko-KR" sz="950">
+                <a:solidFill>
+                  <a:srgbClr val="6B6E7A"/>
+                </a:solidFill>
+                <a:latin typeface="210 옴니고딕 040"/>
+                <a:ea typeface="210 옴니고딕 040"/>
+                <a:cs typeface="210 옴니고딕 040"/>
+              </a:rPr>
+              <a:t>거즈 · 음압도 제외 = KheAl 영역 (하이드로겔 · 하이드로콜로이드 · 알지네이트 등)</a:t>
+            </a:r>
+            <a:endParaRPr lang="ko-KR" sz="950"/>
+          </a:p>
+        </p:txBody>
+      </p:sp>
+      <p:sp>
+        <p:nvSpPr>
+          <p:cNvPr id="32" name="Gb 2"/>
+          <p:cNvSpPr txBox="1"/>
+          <p:nvPr/>
+        </p:nvSpPr>
+        <p:spPr>
+          <a:xfrm>
+            <a:off x="3291840" y="4397532"/>
+            <a:ext cx="3794760" cy="446959"/>
+          </a:xfrm>
+          <a:prstGeom prst="rect">
+            <a:avLst/>
+          </a:prstGeom>
+          <a:noFill/>
+          <a:ln>
+            <a:noFill/>
+          </a:ln>
+        </p:spPr>
+        <p:txBody>
+          <a:bodyPr wrap="square" lIns="0" tIns="0" rIns="0" bIns="0" anchor="t">
+            <a:noAutofit/>
+          </a:bodyPr>
+          <a:lstStyle/>
+          <a:p>
+            <a:pPr marL="0" indent="0" algn="l">
+              <a:buNone/>
+            </a:pPr>
+            <a:r>
+              <a:rPr lang="ko-KR" sz="2400" b="1">
+                <a:solidFill>
+                  <a:srgbClr val="102290"/>
+                </a:solidFill>
+                <a:latin typeface="210 옴니고딕 050"/>
+                <a:ea typeface="210 옴니고딕 050"/>
+                <a:cs typeface="210 옴니고딕 050"/>
+              </a:rPr>
+              <a:t>약 6.8조원</a:t>
+            </a:r>
+            <a:endParaRPr lang="ko-KR" sz="2400"/>
+          </a:p>
+        </p:txBody>
+      </p:sp>
+      <p:sp>
+        <p:nvSpPr>
+          <p:cNvPr id="33" name="Gs 2"/>
+          <p:cNvSpPr txBox="1"/>
+          <p:nvPr/>
+        </p:nvSpPr>
+        <p:spPr>
+          <a:xfrm>
+            <a:off x="3291840" y="4844491"/>
+            <a:ext cx="3794760" cy="472745"/>
+          </a:xfrm>
+          <a:prstGeom prst="rect">
+            <a:avLst/>
+          </a:prstGeom>
+          <a:noFill/>
+          <a:ln>
+            <a:noFill/>
+          </a:ln>
+        </p:spPr>
+        <p:txBody>
+          <a:bodyPr wrap="square" lIns="0" tIns="0" rIns="0" bIns="0" anchor="t">
+            <a:noAutofit/>
+          </a:bodyPr>
+          <a:lstStyle/>
+          <a:p>
+            <a:pPr marL="0" indent="0" algn="l">
+              <a:spcAft>
+                <a:spcPts val="100"/>
+              </a:spcAft>
+              <a:buNone/>
+            </a:pPr>
+            <a:r>
+              <a:rPr lang="ko-KR" sz="950">
+                <a:solidFill>
+                  <a:srgbClr val="6B6E7A"/>
+                </a:solidFill>
+                <a:latin typeface="210 옴니고딕 040"/>
+                <a:ea typeface="210 옴니고딕 040"/>
+                <a:cs typeface="210 옴니고딕 040"/>
+              </a:rPr>
+              <a:t>추정 = 첨단 드레싱 × (1 − 폼 비중 23.6%)</a:t>
+            </a:r>
+            <a:endParaRPr lang="ko-KR" sz="1100"/>
+          </a:p>
+        </p:txBody>
+      </p:sp>
+      <p:sp>
+        <p:nvSpPr>
+          <p:cNvPr id="34" name="Kb 2"/>
+          <p:cNvSpPr txBox="1"/>
+          <p:nvPr/>
+        </p:nvSpPr>
+        <p:spPr>
+          <a:xfrm>
+            <a:off x="7315200" y="4397532"/>
+            <a:ext cx="3200400" cy="446959"/>
+          </a:xfrm>
+          <a:prstGeom prst="rect">
+            <a:avLst/>
+          </a:prstGeom>
+          <a:noFill/>
+          <a:ln>
+            <a:noFill/>
+          </a:ln>
+        </p:spPr>
+        <p:txBody>
+          <a:bodyPr wrap="square" lIns="0" tIns="0" rIns="0" bIns="0" anchor="t">
+            <a:noAutofit/>
+          </a:bodyPr>
+          <a:lstStyle/>
+          <a:p>
+            <a:pPr marL="0" indent="0" algn="l">
+              <a:buNone/>
+            </a:pPr>
+            <a:r>
+              <a:rPr lang="ko-KR" sz="2400" b="1">
+                <a:solidFill>
+                  <a:srgbClr val="102290"/>
+                </a:solidFill>
+                <a:latin typeface="210 옴니고딕 050"/>
+                <a:ea typeface="210 옴니고딕 050"/>
+                <a:cs typeface="210 옴니고딕 050"/>
+              </a:rPr>
+              <a:t>약 221억원</a:t>
+            </a:r>
+            <a:endParaRPr lang="ko-KR" sz="2400"/>
+          </a:p>
+        </p:txBody>
+      </p:sp>
+      <p:sp>
+        <p:nvSpPr>
+          <p:cNvPr id="35" name="Ks 2"/>
+          <p:cNvSpPr txBox="1"/>
+          <p:nvPr/>
+        </p:nvSpPr>
+        <p:spPr>
+          <a:xfrm>
+            <a:off x="7315200" y="4844491"/>
+            <a:ext cx="3200400" cy="472745"/>
+          </a:xfrm>
+          <a:prstGeom prst="rect">
+            <a:avLst/>
+          </a:prstGeom>
+          <a:noFill/>
+          <a:ln>
+            <a:noFill/>
+          </a:ln>
+        </p:spPr>
+        <p:txBody>
+          <a:bodyPr wrap="square" lIns="0" tIns="0" rIns="0" bIns="0" anchor="t">
+            <a:noAutofit/>
+          </a:bodyPr>
+          <a:lstStyle/>
+          <a:p>
+            <a:pPr marL="0" indent="0" algn="l">
+              <a:buNone/>
+            </a:pPr>
+            <a:r>
+              <a:rPr lang="ko-KR" sz="950">
+                <a:solidFill>
+                  <a:srgbClr val="6B6E7A"/>
+                </a:solidFill>
+                <a:latin typeface="210 옴니고딕 040"/>
+                <a:ea typeface="210 옴니고딕 040"/>
+                <a:cs typeface="210 옴니고딕 040"/>
+              </a:rPr>
+              <a:t>급여 청구 중 하이드로콜로이드 2.3 + 알지네이트 · 하이드로파이버 1.6 + 기타 10.1 = 14%</a:t>
+            </a:r>
+            <a:endParaRPr lang="ko-KR" sz="950"/>
+          </a:p>
+        </p:txBody>
+      </p:sp>
+      <p:sp>
+        <p:nvSpPr>
+          <p:cNvPr id="36" name="Ratio 2"/>
+          <p:cNvSpPr txBox="1"/>
+          <p:nvPr/>
+        </p:nvSpPr>
+        <p:spPr>
+          <a:xfrm>
+            <a:off x="10680192" y="4638203"/>
+            <a:ext cx="932688" cy="378196"/>
+          </a:xfrm>
+          <a:prstGeom prst="roundRect">
+            <a:avLst>
+              <a:gd name="adj" fmla="val 16000"/>
             </a:avLst>
           </a:prstGeom>
           <a:solidFill>
@@ -5362,7 +6380,7 @@
           </a:ln>
         </p:spPr>
         <p:txBody>
-          <a:bodyPr wrap="square" lIns="91440" tIns="27432" rIns="91440" bIns="27432" anchor="ctr">
+          <a:bodyPr wrap="square" lIns="36576" tIns="18288" rIns="36576" bIns="18288" anchor="ctr">
             <a:noAutofit/>
           </a:bodyPr>
           <a:lstStyle/>
@@ -5371,7 +6389,7 @@
               <a:buNone/>
             </a:pPr>
             <a:r>
-              <a:rPr lang="ko-KR" sz="1100" b="1">
+              <a:rPr lang="ko-KR" sz="1200" b="1">
                 <a:solidFill>
                   <a:srgbClr val="FFFFFF"/>
                 </a:solidFill>
@@ -5379,497 +6397,58 @@
                 <a:ea typeface="210 옴니고딕 050"/>
                 <a:cs typeface="210 옴니고딕 050"/>
               </a:rPr>
-              <a:t>전체  ·  글로벌 창상피복재</a:t>
-            </a:r>
-            <a:endParaRPr lang="ko-KR" sz="1100"/>
-          </a:p>
-          <a:p>
-            <a:pPr marL="0" indent="0" algn="ctr">
-              <a:buNone/>
-            </a:pPr>
-            <a:r>
-              <a:rPr lang="ko-KR" sz="2000" b="1">
-                <a:solidFill>
-                  <a:srgbClr val="FFFFFF"/>
-                </a:solidFill>
-                <a:latin typeface="210 옴니고딕 050"/>
-                <a:ea typeface="210 옴니고딕 050"/>
-                <a:cs typeface="210 옴니고딕 050"/>
-              </a:rPr>
-              <a:t>$11.6B → $15.9B</a:t>
-            </a:r>
-            <a:endParaRPr lang="ko-KR" sz="2000"/>
-          </a:p>
-          <a:p>
-            <a:pPr marL="0" indent="0" algn="ctr">
-              <a:buNone/>
-            </a:pPr>
-            <a:r>
-              <a:rPr lang="ko-KR" sz="950">
-                <a:solidFill>
-                  <a:srgbClr val="FFFFFF"/>
+              <a:t>0.3%</a:t>
+            </a:r>
+            <a:endParaRPr lang="ko-KR" sz="1200"/>
+          </a:p>
+        </p:txBody>
+      </p:sp>
+      <p:sp>
+        <p:nvSpPr>
+          <p:cNvPr id="37" name="Tgt note"/>
+          <p:cNvSpPr txBox="1"/>
+          <p:nvPr/>
+        </p:nvSpPr>
+        <p:spPr>
+          <a:xfrm>
+            <a:off x="502920" y="5446166"/>
+            <a:ext cx="11183112" cy="309433"/>
+          </a:xfrm>
+          <a:prstGeom prst="rect">
+            <a:avLst/>
+          </a:prstGeom>
+          <a:noFill/>
+          <a:ln>
+            <a:noFill/>
+          </a:ln>
+        </p:spPr>
+        <p:txBody>
+          <a:bodyPr wrap="square" lIns="0" tIns="0" rIns="0" bIns="0" anchor="ctr">
+            <a:noAutofit/>
+          </a:bodyPr>
+          <a:lstStyle/>
+          <a:p>
+            <a:pPr marL="0" indent="0" algn="l">
+              <a:buNone/>
+            </a:pPr>
+            <a:r>
+              <a:rPr lang="ko-KR" sz="900">
+                <a:solidFill>
+                  <a:srgbClr val="6B6E7A"/>
                 </a:solidFill>
                 <a:latin typeface="210 옴니고딕 040"/>
                 <a:ea typeface="210 옴니고딕 040"/>
                 <a:cs typeface="210 옴니고딕 040"/>
               </a:rPr>
-              <a:t>2025 → 2030 · 연 6.5%</a:t>
-            </a:r>
-            <a:endParaRPr lang="ko-KR" sz="950"/>
-          </a:p>
-        </p:txBody>
-      </p:sp>
-      <p:sp>
-        <p:nvSpPr>
-          <p:cNvPr id="13" name="G lvl 1"/>
-          <p:cNvSpPr txBox="1"/>
-          <p:nvPr/>
-        </p:nvSpPr>
-        <p:spPr>
-          <a:xfrm>
-            <a:off x="960120" y="3254350"/>
-            <a:ext cx="4572000" cy="988466"/>
-          </a:xfrm>
-          <a:prstGeom prst="roundRect">
-            <a:avLst>
-              <a:gd name="adj" fmla="val 10000"/>
-            </a:avLst>
-          </a:prstGeom>
-          <a:solidFill>
-            <a:srgbClr val="437DFF"/>
-          </a:solidFill>
-          <a:ln>
-            <a:noFill/>
-          </a:ln>
-        </p:spPr>
-        <p:txBody>
-          <a:bodyPr wrap="square" lIns="91440" tIns="27432" rIns="91440" bIns="27432" anchor="ctr">
-            <a:noAutofit/>
-          </a:bodyPr>
-          <a:lstStyle/>
-          <a:p>
-            <a:pPr marL="0" indent="0" algn="ctr">
-              <a:buNone/>
-            </a:pPr>
-            <a:r>
-              <a:rPr lang="ko-KR" sz="1100" b="1">
-                <a:solidFill>
-                  <a:srgbClr val="FFFFFF"/>
-                </a:solidFill>
-                <a:latin typeface="210 옴니고딕 050"/>
-                <a:ea typeface="210 옴니고딕 050"/>
-                <a:cs typeface="210 옴니고딕 050"/>
-              </a:rPr>
-              <a:t>대상  ·  첨단 드레싱</a:t>
-            </a:r>
-            <a:endParaRPr lang="ko-KR" sz="1100"/>
-          </a:p>
-          <a:p>
-            <a:pPr marL="0" indent="0" algn="ctr">
-              <a:buNone/>
-            </a:pPr>
-            <a:r>
-              <a:rPr lang="ko-KR" sz="2000" b="1">
-                <a:solidFill>
-                  <a:srgbClr val="FFFFFF"/>
-                </a:solidFill>
-                <a:latin typeface="210 옴니고딕 050"/>
-                <a:ea typeface="210 옴니고딕 050"/>
-                <a:cs typeface="210 옴니고딕 050"/>
-              </a:rPr>
-              <a:t>$6.4B → $9.4B</a:t>
-            </a:r>
-            <a:endParaRPr lang="ko-KR" sz="2000"/>
-          </a:p>
-          <a:p>
-            <a:pPr marL="0" indent="0" algn="ctr">
-              <a:buNone/>
-            </a:pPr>
-            <a:r>
-              <a:rPr lang="ko-KR" sz="950">
-                <a:solidFill>
-                  <a:srgbClr val="FFFFFF"/>
-                </a:solidFill>
-                <a:latin typeface="210 옴니고딕 040"/>
-                <a:ea typeface="210 옴니고딕 040"/>
-                <a:cs typeface="210 옴니고딕 040"/>
-              </a:rPr>
-              <a:t>2025 → 2030 · 2024년 비중 54.4%</a:t>
-            </a:r>
-            <a:endParaRPr lang="ko-KR" sz="950"/>
-          </a:p>
-        </p:txBody>
-      </p:sp>
-      <p:sp>
-        <p:nvSpPr>
-          <p:cNvPr id="14" name="G lvl 2"/>
-          <p:cNvSpPr txBox="1"/>
-          <p:nvPr/>
-        </p:nvSpPr>
-        <p:spPr>
-          <a:xfrm>
-            <a:off x="1417320" y="4371746"/>
-            <a:ext cx="3657600" cy="988466"/>
-          </a:xfrm>
-          <a:prstGeom prst="roundRect">
-            <a:avLst>
-              <a:gd name="adj" fmla="val 10000"/>
-            </a:avLst>
-          </a:prstGeom>
-          <a:solidFill>
-            <a:srgbClr val="7030A0"/>
-          </a:solidFill>
-          <a:ln>
-            <a:noFill/>
-          </a:ln>
-        </p:spPr>
-        <p:txBody>
-          <a:bodyPr wrap="square" lIns="91440" tIns="27432" rIns="91440" bIns="27432" anchor="ctr">
-            <a:noAutofit/>
-          </a:bodyPr>
-          <a:lstStyle/>
-          <a:p>
-            <a:pPr marL="0" indent="0" algn="ctr">
-              <a:buNone/>
-            </a:pPr>
-            <a:r>
-              <a:rPr lang="ko-KR" sz="1100" b="1">
-                <a:solidFill>
-                  <a:srgbClr val="FFFFFF"/>
-                </a:solidFill>
-                <a:latin typeface="210 옴니고딕 050"/>
-                <a:ea typeface="210 옴니고딕 050"/>
-                <a:cs typeface="210 옴니고딕 050"/>
-              </a:rPr>
-              <a:t>첫 진입  ·  미국 화상 부상</a:t>
-            </a:r>
-            <a:endParaRPr lang="ko-KR" sz="1100"/>
-          </a:p>
-          <a:p>
-            <a:pPr marL="0" indent="0" algn="ctr">
-              <a:buNone/>
-            </a:pPr>
-            <a:r>
-              <a:rPr lang="ko-KR" sz="2000" b="1">
-                <a:solidFill>
-                  <a:srgbClr val="FFFFFF"/>
-                </a:solidFill>
-                <a:latin typeface="210 옴니고딕 050"/>
-                <a:ea typeface="210 옴니고딕 050"/>
-                <a:cs typeface="210 옴니고딕 050"/>
-              </a:rPr>
-              <a:t>39.8만 건 + 25.2만 건</a:t>
-            </a:r>
-            <a:endParaRPr lang="ko-KR" sz="2000"/>
-          </a:p>
-          <a:p>
-            <a:pPr marL="0" indent="0" algn="ctr">
-              <a:buNone/>
-            </a:pPr>
-            <a:r>
-              <a:rPr lang="ko-KR" sz="950">
-                <a:solidFill>
-                  <a:srgbClr val="FFFFFF"/>
-                </a:solidFill>
-                <a:latin typeface="210 옴니고딕 040"/>
-                <a:ea typeface="210 옴니고딕 040"/>
-                <a:cs typeface="210 옴니고딕 040"/>
-              </a:rPr>
-              <a:t>화재·화상 + 뜨거운 물체 접촉 (2021) · 입원 2.9만 건/년</a:t>
-            </a:r>
-            <a:endParaRPr lang="ko-KR" sz="950"/>
-          </a:p>
-        </p:txBody>
-      </p:sp>
-      <p:sp>
-        <p:nvSpPr>
-          <p:cNvPr id="15" name="K lvl 0"/>
-          <p:cNvSpPr txBox="1"/>
-          <p:nvPr/>
-        </p:nvSpPr>
-        <p:spPr>
-          <a:xfrm>
-            <a:off x="6199632" y="2136953"/>
-            <a:ext cx="5486400" cy="988466"/>
-          </a:xfrm>
-          <a:prstGeom prst="roundRect">
-            <a:avLst>
-              <a:gd name="adj" fmla="val 10000"/>
-            </a:avLst>
-          </a:prstGeom>
-          <a:solidFill>
-            <a:srgbClr val="102290"/>
-          </a:solidFill>
-          <a:ln>
-            <a:noFill/>
-          </a:ln>
-        </p:spPr>
-        <p:txBody>
-          <a:bodyPr wrap="square" lIns="91440" tIns="27432" rIns="91440" bIns="27432" anchor="ctr">
-            <a:noAutofit/>
-          </a:bodyPr>
-          <a:lstStyle/>
-          <a:p>
-            <a:pPr marL="0" indent="0" algn="ctr">
-              <a:buNone/>
-            </a:pPr>
-            <a:r>
-              <a:rPr lang="ko-KR" sz="1100" b="1">
-                <a:solidFill>
-                  <a:srgbClr val="FFFFFF"/>
-                </a:solidFill>
-                <a:latin typeface="210 옴니고딕 050"/>
-                <a:ea typeface="210 옴니고딕 050"/>
-                <a:cs typeface="210 옴니고딕 050"/>
-              </a:rPr>
-              <a:t>전체  ·  국내 창상피복재</a:t>
-            </a:r>
-            <a:endParaRPr lang="ko-KR" sz="1100"/>
-          </a:p>
-          <a:p>
-            <a:pPr marL="0" indent="0" algn="ctr">
-              <a:buNone/>
-            </a:pPr>
-            <a:r>
-              <a:rPr lang="ko-KR" sz="2000" b="1">
-                <a:solidFill>
-                  <a:srgbClr val="FFFFFF"/>
-                </a:solidFill>
-                <a:latin typeface="210 옴니고딕 050"/>
-                <a:ea typeface="210 옴니고딕 050"/>
-                <a:cs typeface="210 옴니고딕 050"/>
-              </a:rPr>
-              <a:t>3,319억원</a:t>
-            </a:r>
-            <a:endParaRPr lang="ko-KR" sz="2000"/>
-          </a:p>
-          <a:p>
-            <a:pPr marL="0" indent="0" algn="ctr">
-              <a:buNone/>
-            </a:pPr>
-            <a:r>
-              <a:rPr lang="ko-KR" sz="950">
-                <a:solidFill>
-                  <a:srgbClr val="FFFFFF"/>
-                </a:solidFill>
-                <a:latin typeface="210 옴니고딕 040"/>
-                <a:ea typeface="210 옴니고딕 040"/>
-                <a:cs typeface="210 옴니고딕 040"/>
-              </a:rPr>
-              <a:t>2022 추정 · 최종 구입가 기준</a:t>
-            </a:r>
-            <a:endParaRPr lang="ko-KR" sz="950"/>
-          </a:p>
-        </p:txBody>
-      </p:sp>
-      <p:sp>
-        <p:nvSpPr>
-          <p:cNvPr id="16" name="K lvl 1"/>
-          <p:cNvSpPr txBox="1"/>
-          <p:nvPr/>
-        </p:nvSpPr>
-        <p:spPr>
-          <a:xfrm>
-            <a:off x="6656832" y="3254350"/>
-            <a:ext cx="4572000" cy="988466"/>
-          </a:xfrm>
-          <a:prstGeom prst="roundRect">
-            <a:avLst>
-              <a:gd name="adj" fmla="val 10000"/>
-            </a:avLst>
-          </a:prstGeom>
-          <a:solidFill>
-            <a:srgbClr val="437DFF"/>
-          </a:solidFill>
-          <a:ln>
-            <a:noFill/>
-          </a:ln>
-        </p:spPr>
-        <p:txBody>
-          <a:bodyPr wrap="square" lIns="91440" tIns="27432" rIns="91440" bIns="27432" anchor="ctr">
-            <a:noAutofit/>
-          </a:bodyPr>
-          <a:lstStyle/>
-          <a:p>
-            <a:pPr marL="0" indent="0" algn="ctr">
-              <a:buNone/>
-            </a:pPr>
-            <a:r>
-              <a:rPr lang="ko-KR" sz="1100" b="1">
-                <a:solidFill>
-                  <a:srgbClr val="FFFFFF"/>
-                </a:solidFill>
-                <a:latin typeface="210 옴니고딕 050"/>
-                <a:ea typeface="210 옴니고딕 050"/>
-                <a:cs typeface="210 옴니고딕 050"/>
-              </a:rPr>
-              <a:t>대상  ·  병원 구매 (급여 청구)</a:t>
-            </a:r>
-            <a:endParaRPr lang="ko-KR" sz="1100"/>
-          </a:p>
-          <a:p>
-            <a:pPr marL="0" indent="0" algn="ctr">
-              <a:buNone/>
-            </a:pPr>
-            <a:r>
-              <a:rPr lang="ko-KR" sz="2000" b="1">
-                <a:solidFill>
-                  <a:srgbClr val="FFFFFF"/>
-                </a:solidFill>
-                <a:latin typeface="210 옴니고딕 050"/>
-                <a:ea typeface="210 옴니고딕 050"/>
-                <a:cs typeface="210 옴니고딕 050"/>
-              </a:rPr>
-              <a:t>1,579억원</a:t>
-            </a:r>
-            <a:endParaRPr lang="ko-KR" sz="2000"/>
-          </a:p>
-          <a:p>
-            <a:pPr marL="0" indent="0" algn="ctr">
-              <a:buNone/>
-            </a:pPr>
-            <a:r>
-              <a:rPr lang="ko-KR" sz="950">
-                <a:solidFill>
-                  <a:srgbClr val="FFFFFF"/>
-                </a:solidFill>
-                <a:latin typeface="210 옴니고딕 040"/>
-                <a:ea typeface="210 옴니고딕 040"/>
-                <a:cs typeface="210 옴니고딕 040"/>
-              </a:rPr>
-              <a:t>폼 68.8% · 합성거즈 14.1% · 음압 3.1%</a:t>
-            </a:r>
-            <a:endParaRPr lang="ko-KR" sz="950"/>
-          </a:p>
-        </p:txBody>
-      </p:sp>
-      <p:sp>
-        <p:nvSpPr>
-          <p:cNvPr id="17" name="K lvl 2"/>
-          <p:cNvSpPr txBox="1"/>
-          <p:nvPr/>
-        </p:nvSpPr>
-        <p:spPr>
-          <a:xfrm>
-            <a:off x="7114032" y="4371746"/>
-            <a:ext cx="3657600" cy="988466"/>
-          </a:xfrm>
-          <a:prstGeom prst="roundRect">
-            <a:avLst>
-              <a:gd name="adj" fmla="val 10000"/>
-            </a:avLst>
-          </a:prstGeom>
-          <a:solidFill>
-            <a:srgbClr val="7030A0"/>
-          </a:solidFill>
-          <a:ln>
-            <a:noFill/>
-          </a:ln>
-        </p:spPr>
-        <p:txBody>
-          <a:bodyPr wrap="square" lIns="91440" tIns="27432" rIns="91440" bIns="27432" anchor="ctr">
-            <a:noAutofit/>
-          </a:bodyPr>
-          <a:lstStyle/>
-          <a:p>
-            <a:pPr marL="0" indent="0" algn="ctr">
-              <a:buNone/>
-            </a:pPr>
-            <a:r>
-              <a:rPr lang="ko-KR" sz="1100" b="1">
-                <a:solidFill>
-                  <a:srgbClr val="FFFFFF"/>
-                </a:solidFill>
-                <a:latin typeface="210 옴니고딕 050"/>
-                <a:ea typeface="210 옴니고딕 050"/>
-                <a:cs typeface="210 옴니고딕 050"/>
-              </a:rPr>
-              <a:t>첫 진입  ·  폼·거즈·음압 외 습윤 드레싱</a:t>
-            </a:r>
-            <a:endParaRPr lang="ko-KR" sz="1100"/>
-          </a:p>
-          <a:p>
-            <a:pPr marL="0" indent="0" algn="ctr">
-              <a:buNone/>
-            </a:pPr>
-            <a:r>
-              <a:rPr lang="ko-KR" sz="2000" b="1">
-                <a:solidFill>
-                  <a:srgbClr val="FFFFFF"/>
-                </a:solidFill>
-                <a:latin typeface="210 옴니고딕 050"/>
-                <a:ea typeface="210 옴니고딕 050"/>
-                <a:cs typeface="210 옴니고딕 050"/>
-              </a:rPr>
-              <a:t>약 221억원</a:t>
-            </a:r>
-            <a:endParaRPr lang="ko-KR" sz="2000"/>
-          </a:p>
-          <a:p>
-            <a:pPr marL="0" indent="0" algn="ctr">
-              <a:buNone/>
-            </a:pPr>
-            <a:r>
-              <a:rPr lang="ko-KR" sz="950">
-                <a:solidFill>
-                  <a:srgbClr val="FFFFFF"/>
-                </a:solidFill>
-                <a:latin typeface="210 옴니고딕 040"/>
-                <a:ea typeface="210 옴니고딕 040"/>
-                <a:cs typeface="210 옴니고딕 040"/>
-              </a:rPr>
-              <a:t>하이드로콜로이드 2.3 + 알지네이트·하이드로파이버 1.6 + 기타 10.1 = 14%</a:t>
-            </a:r>
-            <a:endParaRPr lang="ko-KR" sz="950"/>
-          </a:p>
-        </p:txBody>
-      </p:sp>
-      <p:sp>
-        <p:nvSpPr>
-          <p:cNvPr id="18" name="Gap"/>
-          <p:cNvSpPr txBox="1"/>
-          <p:nvPr/>
-        </p:nvSpPr>
-        <p:spPr>
-          <a:xfrm>
-            <a:off x="502920" y="5506334"/>
-            <a:ext cx="11155680" cy="240670"/>
-          </a:xfrm>
-          <a:prstGeom prst="rect">
-            <a:avLst/>
-          </a:prstGeom>
-          <a:noFill/>
-          <a:ln>
-            <a:noFill/>
-          </a:ln>
-        </p:spPr>
-        <p:txBody>
-          <a:bodyPr wrap="square" lIns="0" tIns="0" rIns="0" bIns="0" anchor="t">
-            <a:noAutofit/>
-          </a:bodyPr>
-          <a:lstStyle/>
-          <a:p>
-            <a:pPr marL="0" indent="0" algn="l">
-              <a:buNone/>
-            </a:pPr>
-            <a:r>
-              <a:rPr lang="ko-KR" sz="950">
-                <a:solidFill>
-                  <a:srgbClr val="6B6E7A"/>
-                </a:solidFill>
-                <a:latin typeface="210 옴니고딕 040"/>
-                <a:ea typeface="210 옴니고딕 040"/>
-                <a:cs typeface="210 옴니고딕 040"/>
-              </a:rPr>
-              <a:t>국내 화상 환자 수는 국민건강보험공단 공공데이터(연도별 화상 진료건수, 2020–2024)로 보완 필요 · ‘약 221억원’은 급여 구성비로 계산한 추정치</a:t>
-            </a:r>
-            <a:endParaRPr lang="ko-KR" sz="950"/>
-          </a:p>
-        </p:txBody>
-      </p:sp>
-      <p:sp>
-        <p:nvSpPr>
-          <p:cNvPr id="19" name="Key box"/>
+              <a:t>글로벌: MarketsandMarkets (2025) · 폼 비중은 Grand View Research (2025) · 국내 ①은 최종 구입가, ②③은 의료기관 급여 청구액 기준 · 미국 첨단 · 습윤 세부 수치는 출처마다 정의가 달라 미기재</a:t>
+            </a:r>
+            <a:endParaRPr lang="ko-KR" sz="900"/>
+          </a:p>
+        </p:txBody>
+      </p:sp>
+      <p:sp>
+        <p:nvSpPr>
+          <p:cNvPr id="38" name="Key box"/>
           <p:cNvSpPr/>
           <p:nvPr/>
         </p:nvSpPr>
@@ -5893,7 +6472,7 @@
       </p:sp>
       <p:sp>
         <p:nvSpPr>
-          <p:cNvPr id="20" name="Key label"/>
+          <p:cNvPr id="39" name="Key label"/>
           <p:cNvSpPr txBox="1"/>
           <p:nvPr/>
         </p:nvSpPr>
@@ -5940,7 +6519,7 @@
       </p:sp>
       <p:sp>
         <p:nvSpPr>
-          <p:cNvPr id="21" name="Key text"/>
+          <p:cNvPr id="40" name="Key text"/>
           <p:cNvSpPr txBox="1"/>
           <p:nvPr/>
         </p:nvSpPr>
@@ -5975,7 +6554,7 @@
                 <a:ea typeface="210 옴니고딕 050"/>
                 <a:cs typeface="210 옴니고딕 050"/>
               </a:rPr>
-              <a:t>숫자는 ‘얼마나 큰 시장인가’까지 — 매출은 판매가가 정해지면 위 환자·시장 규모에서 바로 계산</a:t>
+              <a:t>KheAl 영역(폼 외 습윤 드레싱) = 글로벌 약 6.8조원 · 국내 약 221억원 → 국내는 작은 틈새, 해외 진출(510(k))을 함께 가야 하는 이유</a:t>
             </a:r>
             <a:endParaRPr lang="ko-KR" sz="1250"/>
           </a:p>
@@ -5983,7 +6562,7 @@
       </p:sp>
       <p:sp>
         <p:nvSpPr>
-          <p:cNvPr id="22" name="Sources"/>
+          <p:cNvPr id="41" name="Sources"/>
           <p:cNvSpPr txBox="1"/>
           <p:nvPr/>
         </p:nvSpPr>
@@ -6053,7 +6632,7 @@
                 <a:cs typeface="210 옴니고딕 040"/>
                 <a:hlinkClick r:id="rL2"/>
               </a:rPr>
-              <a:t>KIND 티앤엘 2025 공시</a:t>
+              <a:t>MarketsandMarkets US Wound Dressings</a:t>
             </a:r>
             <a:r>
               <a:rPr lang="ko-KR" sz="750">
@@ -6076,7 +6655,7 @@
                 <a:cs typeface="210 옴니고딕 040"/>
                 <a:hlinkClick r:id="rL3"/>
               </a:rPr>
-              <a:t>ABA Burn Incidence Fact Sheet</a:t>
+              <a:t>Grand View Research Advanced Wound Dressing</a:t>
             </a:r>
             <a:r>
               <a:rPr lang="ko-KR" sz="750">
@@ -6099,7 +6678,7 @@
                 <a:cs typeface="210 옴니고딕 040"/>
                 <a:hlinkClick r:id="rL4"/>
               </a:rPr>
-              <a:t>공공데이터포털 화상 진료건수</a:t>
+              <a:t>KIND 티앤엘 2025 공시</a:t>
             </a:r>
             <a:endParaRPr lang="ko-KR" sz="750"/>
           </a:p>

</xml_diff>